<commit_message>
doc(readme)&feat(swipe): added Readme & smoothened swiping
</commit_message>
<xml_diff>
--- a/App_Logo.pptx
+++ b/App_Logo.pptx
@@ -7,10 +7,13 @@
   <p:sldIdLst>
     <p:sldId id="256" r:id="rId2"/>
     <p:sldId id="258" r:id="rId3"/>
-    <p:sldId id="259" r:id="rId4"/>
-    <p:sldId id="260" r:id="rId5"/>
-    <p:sldId id="261" r:id="rId6"/>
-    <p:sldId id="257" r:id="rId7"/>
+    <p:sldId id="262" r:id="rId4"/>
+    <p:sldId id="259" r:id="rId5"/>
+    <p:sldId id="260" r:id="rId6"/>
+    <p:sldId id="263" r:id="rId7"/>
+    <p:sldId id="261" r:id="rId8"/>
+    <p:sldId id="257" r:id="rId9"/>
+    <p:sldId id="264" r:id="rId10"/>
   </p:sldIdLst>
   <p:sldSz cx="12192000" cy="6858000"/>
   <p:notesSz cx="6858000" cy="9144000"/>
@@ -109,6 +112,11 @@
       </a:defRPr>
     </a:lvl9pPr>
   </p:defaultTextStyle>
+  <p:extLst>
+    <p:ext uri="{EFAFB233-063F-42B5-8137-9DF3F51BA10A}">
+      <p15:sldGuideLst xmlns:p15="http://schemas.microsoft.com/office/powerpoint/2012/main"/>
+    </p:ext>
+  </p:extLst>
 </p:presentation>
 </file>
 
@@ -261,7 +269,7 @@
           <a:p>
             <a:fld id="{DAE86DB9-DEFD-4D48-8EC1-A7DB55CC092E}" type="datetimeFigureOut">
               <a:rPr lang="en-US" smtClean="0"/>
-              <a:t>3/31/2026</a:t>
+              <a:t>4/3/2026</a:t>
             </a:fld>
             <a:endParaRPr lang="en-US"/>
           </a:p>
@@ -461,7 +469,7 @@
           <a:p>
             <a:fld id="{DAE86DB9-DEFD-4D48-8EC1-A7DB55CC092E}" type="datetimeFigureOut">
               <a:rPr lang="en-US" smtClean="0"/>
-              <a:t>3/31/2026</a:t>
+              <a:t>4/3/2026</a:t>
             </a:fld>
             <a:endParaRPr lang="en-US"/>
           </a:p>
@@ -671,7 +679,7 @@
           <a:p>
             <a:fld id="{DAE86DB9-DEFD-4D48-8EC1-A7DB55CC092E}" type="datetimeFigureOut">
               <a:rPr lang="en-US" smtClean="0"/>
-              <a:t>3/31/2026</a:t>
+              <a:t>4/3/2026</a:t>
             </a:fld>
             <a:endParaRPr lang="en-US"/>
           </a:p>
@@ -871,7 +879,7 @@
           <a:p>
             <a:fld id="{DAE86DB9-DEFD-4D48-8EC1-A7DB55CC092E}" type="datetimeFigureOut">
               <a:rPr lang="en-US" smtClean="0"/>
-              <a:t>3/31/2026</a:t>
+              <a:t>4/3/2026</a:t>
             </a:fld>
             <a:endParaRPr lang="en-US"/>
           </a:p>
@@ -1147,7 +1155,7 @@
           <a:p>
             <a:fld id="{DAE86DB9-DEFD-4D48-8EC1-A7DB55CC092E}" type="datetimeFigureOut">
               <a:rPr lang="en-US" smtClean="0"/>
-              <a:t>3/31/2026</a:t>
+              <a:t>4/3/2026</a:t>
             </a:fld>
             <a:endParaRPr lang="en-US"/>
           </a:p>
@@ -1415,7 +1423,7 @@
           <a:p>
             <a:fld id="{DAE86DB9-DEFD-4D48-8EC1-A7DB55CC092E}" type="datetimeFigureOut">
               <a:rPr lang="en-US" smtClean="0"/>
-              <a:t>3/31/2026</a:t>
+              <a:t>4/3/2026</a:t>
             </a:fld>
             <a:endParaRPr lang="en-US"/>
           </a:p>
@@ -1830,7 +1838,7 @@
           <a:p>
             <a:fld id="{DAE86DB9-DEFD-4D48-8EC1-A7DB55CC092E}" type="datetimeFigureOut">
               <a:rPr lang="en-US" smtClean="0"/>
-              <a:t>3/31/2026</a:t>
+              <a:t>4/3/2026</a:t>
             </a:fld>
             <a:endParaRPr lang="en-US"/>
           </a:p>
@@ -1972,7 +1980,7 @@
           <a:p>
             <a:fld id="{DAE86DB9-DEFD-4D48-8EC1-A7DB55CC092E}" type="datetimeFigureOut">
               <a:rPr lang="en-US" smtClean="0"/>
-              <a:t>3/31/2026</a:t>
+              <a:t>4/3/2026</a:t>
             </a:fld>
             <a:endParaRPr lang="en-US"/>
           </a:p>
@@ -2085,7 +2093,7 @@
           <a:p>
             <a:fld id="{DAE86DB9-DEFD-4D48-8EC1-A7DB55CC092E}" type="datetimeFigureOut">
               <a:rPr lang="en-US" smtClean="0"/>
-              <a:t>3/31/2026</a:t>
+              <a:t>4/3/2026</a:t>
             </a:fld>
             <a:endParaRPr lang="en-US"/>
           </a:p>
@@ -2398,7 +2406,7 @@
           <a:p>
             <a:fld id="{DAE86DB9-DEFD-4D48-8EC1-A7DB55CC092E}" type="datetimeFigureOut">
               <a:rPr lang="en-US" smtClean="0"/>
-              <a:t>3/31/2026</a:t>
+              <a:t>4/3/2026</a:t>
             </a:fld>
             <a:endParaRPr lang="en-US"/>
           </a:p>
@@ -2687,7 +2695,7 @@
           <a:p>
             <a:fld id="{DAE86DB9-DEFD-4D48-8EC1-A7DB55CC092E}" type="datetimeFigureOut">
               <a:rPr lang="en-US" smtClean="0"/>
-              <a:t>3/31/2026</a:t>
+              <a:t>4/3/2026</a:t>
             </a:fld>
             <a:endParaRPr lang="en-US"/>
           </a:p>
@@ -2930,7 +2938,7 @@
           <a:p>
             <a:fld id="{DAE86DB9-DEFD-4D48-8EC1-A7DB55CC092E}" type="datetimeFigureOut">
               <a:rPr lang="en-US" smtClean="0"/>
-              <a:t>3/31/2026</a:t>
+              <a:t>4/3/2026</a:t>
             </a:fld>
             <a:endParaRPr lang="en-US"/>
           </a:p>
@@ -5293,6 +5301,973 @@
         <p:cNvPr id="1" name="">
           <a:extLst>
             <a:ext uri="{FF2B5EF4-FFF2-40B4-BE49-F238E27FC236}">
+              <a16:creationId xmlns:a16="http://schemas.microsoft.com/office/drawing/2014/main" id="{C898D2C9-996F-54D6-E4AC-E6D882F8AF24}"/>
+            </a:ext>
+          </a:extLst>
+        </p:cNvPr>
+        <p:cNvGrpSpPr/>
+        <p:nvPr/>
+      </p:nvGrpSpPr>
+      <p:grpSpPr>
+        <a:xfrm>
+          <a:off x="0" y="0"/>
+          <a:ext cx="0" cy="0"/>
+          <a:chOff x="0" y="0"/>
+          <a:chExt cx="0" cy="0"/>
+        </a:xfrm>
+      </p:grpSpPr>
+      <p:sp>
+        <p:nvSpPr>
+          <p:cNvPr id="6" name="Rechteck: abgerundete Ecken 5">
+            <a:extLst>
+              <a:ext uri="{FF2B5EF4-FFF2-40B4-BE49-F238E27FC236}">
+                <a16:creationId xmlns:a16="http://schemas.microsoft.com/office/drawing/2014/main" id="{2F86E24A-9111-548D-166A-9C7495529110}"/>
+              </a:ext>
+            </a:extLst>
+          </p:cNvPr>
+          <p:cNvSpPr/>
+          <p:nvPr/>
+        </p:nvSpPr>
+        <p:spPr>
+          <a:xfrm>
+            <a:off x="3396000" y="729000"/>
+            <a:ext cx="5400000" cy="5400000"/>
+          </a:xfrm>
+          <a:prstGeom prst="roundRect">
+            <a:avLst>
+              <a:gd name="adj" fmla="val 0"/>
+            </a:avLst>
+          </a:prstGeom>
+          <a:gradFill>
+            <a:gsLst>
+              <a:gs pos="0">
+                <a:schemeClr val="tx1">
+                  <a:lumMod val="85000"/>
+                  <a:lumOff val="15000"/>
+                </a:schemeClr>
+              </a:gs>
+              <a:gs pos="100000">
+                <a:schemeClr val="tx1">
+                  <a:lumMod val="95000"/>
+                  <a:lumOff val="5000"/>
+                </a:schemeClr>
+              </a:gs>
+            </a:gsLst>
+            <a:lin ang="5400000" scaled="1"/>
+          </a:gradFill>
+          <a:ln>
+            <a:noFill/>
+          </a:ln>
+        </p:spPr>
+        <p:style>
+          <a:lnRef idx="2">
+            <a:schemeClr val="accent1">
+              <a:shade val="15000"/>
+            </a:schemeClr>
+          </a:lnRef>
+          <a:fillRef idx="1">
+            <a:schemeClr val="accent1"/>
+          </a:fillRef>
+          <a:effectRef idx="0">
+            <a:schemeClr val="accent1"/>
+          </a:effectRef>
+          <a:fontRef idx="minor">
+            <a:schemeClr val="lt1"/>
+          </a:fontRef>
+        </p:style>
+        <p:txBody>
+          <a:bodyPr rtlCol="0" anchor="ctr"/>
+          <a:lstStyle/>
+          <a:p>
+            <a:pPr algn="ctr"/>
+            <a:endParaRPr lang="en-US"/>
+          </a:p>
+        </p:txBody>
+      </p:sp>
+      <p:sp>
+        <p:nvSpPr>
+          <p:cNvPr id="10" name="Freihandform: Form 9">
+            <a:extLst>
+              <a:ext uri="{FF2B5EF4-FFF2-40B4-BE49-F238E27FC236}">
+                <a16:creationId xmlns:a16="http://schemas.microsoft.com/office/drawing/2014/main" id="{83399170-5A11-8990-143F-004591163B77}"/>
+              </a:ext>
+            </a:extLst>
+          </p:cNvPr>
+          <p:cNvSpPr/>
+          <p:nvPr/>
+        </p:nvSpPr>
+        <p:spPr>
+          <a:xfrm rot="18880689">
+            <a:off x="4917910" y="2747465"/>
+            <a:ext cx="2233750" cy="2444602"/>
+          </a:xfrm>
+          <a:custGeom>
+            <a:avLst/>
+            <a:gdLst>
+              <a:gd name="csX0" fmla="*/ 2152604 w 2233750"/>
+              <a:gd name="csY0" fmla="*/ 81146 h 2444602"/>
+              <a:gd name="csX1" fmla="*/ 2233750 w 2233750"/>
+              <a:gd name="csY1" fmla="*/ 277049 h 2444602"/>
+              <a:gd name="csX2" fmla="*/ 2233750 w 2233750"/>
+              <a:gd name="csY2" fmla="*/ 1504152 h 2444602"/>
+              <a:gd name="csX3" fmla="*/ 1956701 w 2233750"/>
+              <a:gd name="csY3" fmla="*/ 1781201 h 2444602"/>
+              <a:gd name="csX4" fmla="*/ 1433949 w 2233750"/>
+              <a:gd name="csY4" fmla="*/ 1781201 h 2444602"/>
+              <a:gd name="csX5" fmla="*/ 731578 w 2233750"/>
+              <a:gd name="csY5" fmla="*/ 2402052 h 2444602"/>
+              <a:gd name="csX6" fmla="*/ 492060 w 2233750"/>
+              <a:gd name="csY6" fmla="*/ 2387296 h 2444602"/>
+              <a:gd name="csX7" fmla="*/ 42550 w 2233750"/>
+              <a:gd name="csY7" fmla="*/ 1878764 h 2444602"/>
+              <a:gd name="csX8" fmla="*/ 57306 w 2233750"/>
+              <a:gd name="csY8" fmla="*/ 1639246 h 2444602"/>
+              <a:gd name="csX9" fmla="*/ 571490 w 2233750"/>
+              <a:gd name="csY9" fmla="*/ 1184740 h 2444602"/>
+              <a:gd name="csX10" fmla="*/ 571490 w 2233750"/>
+              <a:gd name="csY10" fmla="*/ 277049 h 2444602"/>
+              <a:gd name="csX11" fmla="*/ 848539 w 2233750"/>
+              <a:gd name="csY11" fmla="*/ 0 h 2444602"/>
+              <a:gd name="csX12" fmla="*/ 1956701 w 2233750"/>
+              <a:gd name="csY12" fmla="*/ 0 h 2444602"/>
+              <a:gd name="csX13" fmla="*/ 2152604 w 2233750"/>
+              <a:gd name="csY13" fmla="*/ 81146 h 2444602"/>
+            </a:gdLst>
+            <a:ahLst/>
+            <a:cxnLst>
+              <a:cxn ang="0">
+                <a:pos x="csX0" y="csY0"/>
+              </a:cxn>
+              <a:cxn ang="0">
+                <a:pos x="csX1" y="csY1"/>
+              </a:cxn>
+              <a:cxn ang="0">
+                <a:pos x="csX2" y="csY2"/>
+              </a:cxn>
+              <a:cxn ang="0">
+                <a:pos x="csX3" y="csY3"/>
+              </a:cxn>
+              <a:cxn ang="0">
+                <a:pos x="csX4" y="csY4"/>
+              </a:cxn>
+              <a:cxn ang="0">
+                <a:pos x="csX5" y="csY5"/>
+              </a:cxn>
+              <a:cxn ang="0">
+                <a:pos x="csX6" y="csY6"/>
+              </a:cxn>
+              <a:cxn ang="0">
+                <a:pos x="csX7" y="csY7"/>
+              </a:cxn>
+              <a:cxn ang="0">
+                <a:pos x="csX8" y="csY8"/>
+              </a:cxn>
+              <a:cxn ang="0">
+                <a:pos x="csX9" y="csY9"/>
+              </a:cxn>
+              <a:cxn ang="0">
+                <a:pos x="csX10" y="csY10"/>
+              </a:cxn>
+              <a:cxn ang="0">
+                <a:pos x="csX11" y="csY11"/>
+              </a:cxn>
+              <a:cxn ang="0">
+                <a:pos x="csX12" y="csY12"/>
+              </a:cxn>
+              <a:cxn ang="0">
+                <a:pos x="csX13" y="csY13"/>
+              </a:cxn>
+            </a:cxnLst>
+            <a:rect l="l" t="t" r="r" b="b"/>
+            <a:pathLst>
+              <a:path w="2233750" h="2444602">
+                <a:moveTo>
+                  <a:pt x="2152604" y="81146"/>
+                </a:moveTo>
+                <a:cubicBezTo>
+                  <a:pt x="2202740" y="131282"/>
+                  <a:pt x="2233750" y="200544"/>
+                  <a:pt x="2233750" y="277049"/>
+                </a:cubicBezTo>
+                <a:lnTo>
+                  <a:pt x="2233750" y="1504152"/>
+                </a:lnTo>
+                <a:cubicBezTo>
+                  <a:pt x="2233750" y="1657162"/>
+                  <a:pt x="2109711" y="1781201"/>
+                  <a:pt x="1956701" y="1781201"/>
+                </a:cubicBezTo>
+                <a:lnTo>
+                  <a:pt x="1433949" y="1781201"/>
+                </a:lnTo>
+                <a:lnTo>
+                  <a:pt x="731578" y="2402052"/>
+                </a:lnTo>
+                <a:cubicBezTo>
+                  <a:pt x="661362" y="2464118"/>
+                  <a:pt x="554126" y="2457512"/>
+                  <a:pt x="492060" y="2387296"/>
+                </a:cubicBezTo>
+                <a:lnTo>
+                  <a:pt x="42550" y="1878764"/>
+                </a:lnTo>
+                <a:cubicBezTo>
+                  <a:pt x="-19516" y="1808548"/>
+                  <a:pt x="-12910" y="1701312"/>
+                  <a:pt x="57306" y="1639246"/>
+                </a:cubicBezTo>
+                <a:lnTo>
+                  <a:pt x="571490" y="1184740"/>
+                </a:lnTo>
+                <a:lnTo>
+                  <a:pt x="571490" y="277049"/>
+                </a:lnTo>
+                <a:cubicBezTo>
+                  <a:pt x="571490" y="124039"/>
+                  <a:pt x="695529" y="0"/>
+                  <a:pt x="848539" y="0"/>
+                </a:cubicBezTo>
+                <a:lnTo>
+                  <a:pt x="1956701" y="0"/>
+                </a:lnTo>
+                <a:cubicBezTo>
+                  <a:pt x="2033206" y="0"/>
+                  <a:pt x="2102468" y="31010"/>
+                  <a:pt x="2152604" y="81146"/>
+                </a:cubicBezTo>
+                <a:close/>
+              </a:path>
+            </a:pathLst>
+          </a:custGeom>
+          <a:solidFill>
+            <a:srgbClr val="9FF62A"/>
+          </a:solidFill>
+          <a:ln>
+            <a:noFill/>
+          </a:ln>
+        </p:spPr>
+        <p:style>
+          <a:lnRef idx="2">
+            <a:schemeClr val="accent1">
+              <a:shade val="15000"/>
+            </a:schemeClr>
+          </a:lnRef>
+          <a:fillRef idx="1">
+            <a:schemeClr val="accent1"/>
+          </a:fillRef>
+          <a:effectRef idx="0">
+            <a:schemeClr val="accent1"/>
+          </a:effectRef>
+          <a:fontRef idx="minor">
+            <a:schemeClr val="lt1"/>
+          </a:fontRef>
+        </p:style>
+        <p:txBody>
+          <a:bodyPr wrap="square" rtlCol="0" anchor="ctr">
+            <a:noAutofit/>
+          </a:bodyPr>
+          <a:lstStyle/>
+          <a:p>
+            <a:pPr algn="ctr"/>
+            <a:endParaRPr lang="en-US"/>
+          </a:p>
+        </p:txBody>
+      </p:sp>
+      <p:grpSp>
+        <p:nvGrpSpPr>
+          <p:cNvPr id="3" name="Gruppieren 2">
+            <a:extLst>
+              <a:ext uri="{FF2B5EF4-FFF2-40B4-BE49-F238E27FC236}">
+                <a16:creationId xmlns:a16="http://schemas.microsoft.com/office/drawing/2014/main" id="{2B8E1200-89C4-C691-99B2-F62FB86712A5}"/>
+              </a:ext>
+            </a:extLst>
+          </p:cNvPr>
+          <p:cNvGrpSpPr/>
+          <p:nvPr/>
+        </p:nvGrpSpPr>
+        <p:grpSpPr>
+          <a:xfrm>
+            <a:off x="4348757" y="1658235"/>
+            <a:ext cx="3494487" cy="2429130"/>
+            <a:chOff x="4348757" y="1658235"/>
+            <a:chExt cx="3494487" cy="2429130"/>
+          </a:xfrm>
+          <a:solidFill>
+            <a:schemeClr val="accent3"/>
+          </a:solidFill>
+        </p:grpSpPr>
+        <p:sp>
+          <p:nvSpPr>
+            <p:cNvPr id="11" name="Ellipse 10">
+              <a:extLst>
+                <a:ext uri="{FF2B5EF4-FFF2-40B4-BE49-F238E27FC236}">
+                  <a16:creationId xmlns:a16="http://schemas.microsoft.com/office/drawing/2014/main" id="{28026591-8F5B-A81E-95A5-F839FE1653CF}"/>
+                </a:ext>
+              </a:extLst>
+            </p:cNvPr>
+            <p:cNvSpPr/>
+            <p:nvPr/>
+          </p:nvSpPr>
+          <p:spPr>
+            <a:xfrm>
+              <a:off x="4833972" y="2874297"/>
+              <a:ext cx="1093509" cy="1213068"/>
+            </a:xfrm>
+            <a:prstGeom prst="ellipse">
+              <a:avLst/>
+            </a:prstGeom>
+            <a:grpFill/>
+            <a:ln>
+              <a:noFill/>
+            </a:ln>
+          </p:spPr>
+          <p:style>
+            <a:lnRef idx="2">
+              <a:schemeClr val="accent1">
+                <a:shade val="15000"/>
+              </a:schemeClr>
+            </a:lnRef>
+            <a:fillRef idx="1">
+              <a:schemeClr val="accent1"/>
+            </a:fillRef>
+            <a:effectRef idx="0">
+              <a:schemeClr val="accent1"/>
+            </a:effectRef>
+            <a:fontRef idx="minor">
+              <a:schemeClr val="lt1"/>
+            </a:fontRef>
+          </p:style>
+          <p:txBody>
+            <a:bodyPr rtlCol="0" anchor="ctr"/>
+            <a:lstStyle/>
+            <a:p>
+              <a:pPr algn="ctr"/>
+              <a:endParaRPr lang="en-US"/>
+            </a:p>
+          </p:txBody>
+        </p:sp>
+        <p:sp>
+          <p:nvSpPr>
+            <p:cNvPr id="12" name="Ellipse 11">
+              <a:extLst>
+                <a:ext uri="{FF2B5EF4-FFF2-40B4-BE49-F238E27FC236}">
+                  <a16:creationId xmlns:a16="http://schemas.microsoft.com/office/drawing/2014/main" id="{69C30A15-2842-4CEE-F68D-9453D2FF57E0}"/>
+                </a:ext>
+              </a:extLst>
+            </p:cNvPr>
+            <p:cNvSpPr/>
+            <p:nvPr/>
+          </p:nvSpPr>
+          <p:spPr>
+            <a:xfrm>
+              <a:off x="4348757" y="2827162"/>
+              <a:ext cx="895013" cy="978969"/>
+            </a:xfrm>
+            <a:prstGeom prst="ellipse">
+              <a:avLst/>
+            </a:prstGeom>
+            <a:grpFill/>
+            <a:ln>
+              <a:noFill/>
+            </a:ln>
+          </p:spPr>
+          <p:style>
+            <a:lnRef idx="2">
+              <a:schemeClr val="accent1">
+                <a:shade val="15000"/>
+              </a:schemeClr>
+            </a:lnRef>
+            <a:fillRef idx="1">
+              <a:schemeClr val="accent1"/>
+            </a:fillRef>
+            <a:effectRef idx="0">
+              <a:schemeClr val="accent1"/>
+            </a:effectRef>
+            <a:fontRef idx="minor">
+              <a:schemeClr val="lt1"/>
+            </a:fontRef>
+          </p:style>
+          <p:txBody>
+            <a:bodyPr rtlCol="0" anchor="ctr"/>
+            <a:lstStyle/>
+            <a:p>
+              <a:pPr algn="ctr"/>
+              <a:endParaRPr lang="en-US"/>
+            </a:p>
+          </p:txBody>
+        </p:sp>
+        <p:sp>
+          <p:nvSpPr>
+            <p:cNvPr id="13" name="Ellipse 12">
+              <a:extLst>
+                <a:ext uri="{FF2B5EF4-FFF2-40B4-BE49-F238E27FC236}">
+                  <a16:creationId xmlns:a16="http://schemas.microsoft.com/office/drawing/2014/main" id="{429465A3-43EE-40EB-04DE-BF835A0E2E64}"/>
+                </a:ext>
+              </a:extLst>
+            </p:cNvPr>
+            <p:cNvSpPr/>
+            <p:nvPr/>
+          </p:nvSpPr>
+          <p:spPr>
+            <a:xfrm>
+              <a:off x="4523417" y="2216729"/>
+              <a:ext cx="895013" cy="978969"/>
+            </a:xfrm>
+            <a:prstGeom prst="ellipse">
+              <a:avLst/>
+            </a:prstGeom>
+            <a:grpFill/>
+            <a:ln>
+              <a:noFill/>
+            </a:ln>
+          </p:spPr>
+          <p:style>
+            <a:lnRef idx="2">
+              <a:schemeClr val="accent1">
+                <a:shade val="15000"/>
+              </a:schemeClr>
+            </a:lnRef>
+            <a:fillRef idx="1">
+              <a:schemeClr val="accent1"/>
+            </a:fillRef>
+            <a:effectRef idx="0">
+              <a:schemeClr val="accent1"/>
+            </a:effectRef>
+            <a:fontRef idx="minor">
+              <a:schemeClr val="lt1"/>
+            </a:fontRef>
+          </p:style>
+          <p:txBody>
+            <a:bodyPr rtlCol="0" anchor="ctr"/>
+            <a:lstStyle/>
+            <a:p>
+              <a:pPr algn="ctr"/>
+              <a:endParaRPr lang="en-US"/>
+            </a:p>
+          </p:txBody>
+        </p:sp>
+        <p:sp>
+          <p:nvSpPr>
+            <p:cNvPr id="14" name="Ellipse 13">
+              <a:extLst>
+                <a:ext uri="{FF2B5EF4-FFF2-40B4-BE49-F238E27FC236}">
+                  <a16:creationId xmlns:a16="http://schemas.microsoft.com/office/drawing/2014/main" id="{33DDC948-5704-1F1A-8988-2C3EAE1FEDCA}"/>
+                </a:ext>
+              </a:extLst>
+            </p:cNvPr>
+            <p:cNvSpPr/>
+            <p:nvPr/>
+          </p:nvSpPr>
+          <p:spPr>
+            <a:xfrm>
+              <a:off x="5139472" y="1658235"/>
+              <a:ext cx="1447888" cy="1213068"/>
+            </a:xfrm>
+            <a:prstGeom prst="ellipse">
+              <a:avLst/>
+            </a:prstGeom>
+            <a:grpFill/>
+            <a:ln>
+              <a:noFill/>
+            </a:ln>
+          </p:spPr>
+          <p:style>
+            <a:lnRef idx="2">
+              <a:schemeClr val="accent1">
+                <a:shade val="15000"/>
+              </a:schemeClr>
+            </a:lnRef>
+            <a:fillRef idx="1">
+              <a:schemeClr val="accent1"/>
+            </a:fillRef>
+            <a:effectRef idx="0">
+              <a:schemeClr val="accent1"/>
+            </a:effectRef>
+            <a:fontRef idx="minor">
+              <a:schemeClr val="lt1"/>
+            </a:fontRef>
+          </p:style>
+          <p:txBody>
+            <a:bodyPr rtlCol="0" anchor="ctr"/>
+            <a:lstStyle/>
+            <a:p>
+              <a:pPr algn="ctr"/>
+              <a:endParaRPr lang="en-US"/>
+            </a:p>
+          </p:txBody>
+        </p:sp>
+        <p:sp>
+          <p:nvSpPr>
+            <p:cNvPr id="15" name="Ellipse 14">
+              <a:extLst>
+                <a:ext uri="{FF2B5EF4-FFF2-40B4-BE49-F238E27FC236}">
+                  <a16:creationId xmlns:a16="http://schemas.microsoft.com/office/drawing/2014/main" id="{86731413-B55D-B9CF-70EC-9280F2546B97}"/>
+                </a:ext>
+              </a:extLst>
+            </p:cNvPr>
+            <p:cNvSpPr/>
+            <p:nvPr/>
+          </p:nvSpPr>
+          <p:spPr>
+            <a:xfrm>
+              <a:off x="6166303" y="1874525"/>
+              <a:ext cx="1093509" cy="978969"/>
+            </a:xfrm>
+            <a:prstGeom prst="ellipse">
+              <a:avLst/>
+            </a:prstGeom>
+            <a:grpFill/>
+            <a:ln>
+              <a:noFill/>
+            </a:ln>
+          </p:spPr>
+          <p:style>
+            <a:lnRef idx="2">
+              <a:schemeClr val="accent1">
+                <a:shade val="15000"/>
+              </a:schemeClr>
+            </a:lnRef>
+            <a:fillRef idx="1">
+              <a:schemeClr val="accent1"/>
+            </a:fillRef>
+            <a:effectRef idx="0">
+              <a:schemeClr val="accent1"/>
+            </a:effectRef>
+            <a:fontRef idx="minor">
+              <a:schemeClr val="lt1"/>
+            </a:fontRef>
+          </p:style>
+          <p:txBody>
+            <a:bodyPr rtlCol="0" anchor="ctr"/>
+            <a:lstStyle/>
+            <a:p>
+              <a:pPr algn="ctr"/>
+              <a:endParaRPr lang="en-US"/>
+            </a:p>
+          </p:txBody>
+        </p:sp>
+        <p:sp>
+          <p:nvSpPr>
+            <p:cNvPr id="16" name="Ellipse 15">
+              <a:extLst>
+                <a:ext uri="{FF2B5EF4-FFF2-40B4-BE49-F238E27FC236}">
+                  <a16:creationId xmlns:a16="http://schemas.microsoft.com/office/drawing/2014/main" id="{17412450-3716-066B-4511-21B26C60B0C8}"/>
+                </a:ext>
+              </a:extLst>
+            </p:cNvPr>
+            <p:cNvSpPr/>
+            <p:nvPr/>
+          </p:nvSpPr>
+          <p:spPr>
+            <a:xfrm>
+              <a:off x="6685338" y="2280470"/>
+              <a:ext cx="947871" cy="978969"/>
+            </a:xfrm>
+            <a:prstGeom prst="ellipse">
+              <a:avLst/>
+            </a:prstGeom>
+            <a:grpFill/>
+            <a:ln>
+              <a:noFill/>
+            </a:ln>
+          </p:spPr>
+          <p:style>
+            <a:lnRef idx="2">
+              <a:schemeClr val="accent1">
+                <a:shade val="15000"/>
+              </a:schemeClr>
+            </a:lnRef>
+            <a:fillRef idx="1">
+              <a:schemeClr val="accent1"/>
+            </a:fillRef>
+            <a:effectRef idx="0">
+              <a:schemeClr val="accent1"/>
+            </a:effectRef>
+            <a:fontRef idx="minor">
+              <a:schemeClr val="lt1"/>
+            </a:fontRef>
+          </p:style>
+          <p:txBody>
+            <a:bodyPr rtlCol="0" anchor="ctr"/>
+            <a:lstStyle/>
+            <a:p>
+              <a:pPr algn="ctr"/>
+              <a:endParaRPr lang="en-US"/>
+            </a:p>
+          </p:txBody>
+        </p:sp>
+        <p:sp>
+          <p:nvSpPr>
+            <p:cNvPr id="17" name="Ellipse 16">
+              <a:extLst>
+                <a:ext uri="{FF2B5EF4-FFF2-40B4-BE49-F238E27FC236}">
+                  <a16:creationId xmlns:a16="http://schemas.microsoft.com/office/drawing/2014/main" id="{969AB51C-817F-60EB-694D-11627F08DBD8}"/>
+                </a:ext>
+              </a:extLst>
+            </p:cNvPr>
+            <p:cNvSpPr/>
+            <p:nvPr/>
+          </p:nvSpPr>
+          <p:spPr>
+            <a:xfrm>
+              <a:off x="6895373" y="2815788"/>
+              <a:ext cx="947871" cy="978969"/>
+            </a:xfrm>
+            <a:prstGeom prst="ellipse">
+              <a:avLst/>
+            </a:prstGeom>
+            <a:grpFill/>
+            <a:ln>
+              <a:noFill/>
+            </a:ln>
+          </p:spPr>
+          <p:style>
+            <a:lnRef idx="2">
+              <a:schemeClr val="accent1">
+                <a:shade val="15000"/>
+              </a:schemeClr>
+            </a:lnRef>
+            <a:fillRef idx="1">
+              <a:schemeClr val="accent1"/>
+            </a:fillRef>
+            <a:effectRef idx="0">
+              <a:schemeClr val="accent1"/>
+            </a:effectRef>
+            <a:fontRef idx="minor">
+              <a:schemeClr val="lt1"/>
+            </a:fontRef>
+          </p:style>
+          <p:txBody>
+            <a:bodyPr rtlCol="0" anchor="ctr"/>
+            <a:lstStyle/>
+            <a:p>
+              <a:pPr algn="ctr"/>
+              <a:endParaRPr lang="en-US"/>
+            </a:p>
+          </p:txBody>
+        </p:sp>
+        <p:sp>
+          <p:nvSpPr>
+            <p:cNvPr id="18" name="Ellipse 17">
+              <a:extLst>
+                <a:ext uri="{FF2B5EF4-FFF2-40B4-BE49-F238E27FC236}">
+                  <a16:creationId xmlns:a16="http://schemas.microsoft.com/office/drawing/2014/main" id="{30812F45-85B2-DB37-E35B-E69D1CF2803C}"/>
+                </a:ext>
+              </a:extLst>
+            </p:cNvPr>
+            <p:cNvSpPr/>
+            <p:nvPr/>
+          </p:nvSpPr>
+          <p:spPr>
+            <a:xfrm>
+              <a:off x="6447064" y="3074692"/>
+              <a:ext cx="947871" cy="978969"/>
+            </a:xfrm>
+            <a:prstGeom prst="ellipse">
+              <a:avLst/>
+            </a:prstGeom>
+            <a:grpFill/>
+            <a:ln>
+              <a:noFill/>
+            </a:ln>
+          </p:spPr>
+          <p:style>
+            <a:lnRef idx="2">
+              <a:schemeClr val="accent1">
+                <a:shade val="15000"/>
+              </a:schemeClr>
+            </a:lnRef>
+            <a:fillRef idx="1">
+              <a:schemeClr val="accent1"/>
+            </a:fillRef>
+            <a:effectRef idx="0">
+              <a:schemeClr val="accent1"/>
+            </a:effectRef>
+            <a:fontRef idx="minor">
+              <a:schemeClr val="lt1"/>
+            </a:fontRef>
+          </p:style>
+          <p:txBody>
+            <a:bodyPr rtlCol="0" anchor="ctr"/>
+            <a:lstStyle/>
+            <a:p>
+              <a:pPr algn="ctr"/>
+              <a:endParaRPr lang="en-US"/>
+            </a:p>
+          </p:txBody>
+        </p:sp>
+        <p:sp>
+          <p:nvSpPr>
+            <p:cNvPr id="19" name="Ellipse 18">
+              <a:extLst>
+                <a:ext uri="{FF2B5EF4-FFF2-40B4-BE49-F238E27FC236}">
+                  <a16:creationId xmlns:a16="http://schemas.microsoft.com/office/drawing/2014/main" id="{E4D72D00-101D-A976-B4B3-78016666359A}"/>
+                </a:ext>
+              </a:extLst>
+            </p:cNvPr>
+            <p:cNvSpPr/>
+            <p:nvPr/>
+          </p:nvSpPr>
+          <p:spPr>
+            <a:xfrm>
+              <a:off x="5967792" y="2548129"/>
+              <a:ext cx="947871" cy="978969"/>
+            </a:xfrm>
+            <a:prstGeom prst="ellipse">
+              <a:avLst/>
+            </a:prstGeom>
+            <a:grpFill/>
+            <a:ln>
+              <a:noFill/>
+            </a:ln>
+          </p:spPr>
+          <p:style>
+            <a:lnRef idx="2">
+              <a:schemeClr val="accent1">
+                <a:shade val="15000"/>
+              </a:schemeClr>
+            </a:lnRef>
+            <a:fillRef idx="1">
+              <a:schemeClr val="accent1"/>
+            </a:fillRef>
+            <a:effectRef idx="0">
+              <a:schemeClr val="accent1"/>
+            </a:effectRef>
+            <a:fontRef idx="minor">
+              <a:schemeClr val="lt1"/>
+            </a:fontRef>
+          </p:style>
+          <p:txBody>
+            <a:bodyPr rtlCol="0" anchor="ctr"/>
+            <a:lstStyle/>
+            <a:p>
+              <a:pPr algn="ctr"/>
+              <a:endParaRPr lang="en-US"/>
+            </a:p>
+          </p:txBody>
+        </p:sp>
+        <p:sp>
+          <p:nvSpPr>
+            <p:cNvPr id="21" name="Ellipse 20">
+              <a:extLst>
+                <a:ext uri="{FF2B5EF4-FFF2-40B4-BE49-F238E27FC236}">
+                  <a16:creationId xmlns:a16="http://schemas.microsoft.com/office/drawing/2014/main" id="{AB7E4354-2BC3-6279-8E00-EF63B7708FA3}"/>
+                </a:ext>
+              </a:extLst>
+            </p:cNvPr>
+            <p:cNvSpPr/>
+            <p:nvPr/>
+          </p:nvSpPr>
+          <p:spPr>
+            <a:xfrm>
+              <a:off x="5259186" y="2426730"/>
+              <a:ext cx="1201277" cy="1156099"/>
+            </a:xfrm>
+            <a:prstGeom prst="ellipse">
+              <a:avLst/>
+            </a:prstGeom>
+            <a:grpFill/>
+            <a:ln>
+              <a:noFill/>
+            </a:ln>
+          </p:spPr>
+          <p:style>
+            <a:lnRef idx="2">
+              <a:schemeClr val="accent1">
+                <a:shade val="15000"/>
+              </a:schemeClr>
+            </a:lnRef>
+            <a:fillRef idx="1">
+              <a:schemeClr val="accent1"/>
+            </a:fillRef>
+            <a:effectRef idx="0">
+              <a:schemeClr val="accent1"/>
+            </a:effectRef>
+            <a:fontRef idx="minor">
+              <a:schemeClr val="lt1"/>
+            </a:fontRef>
+          </p:style>
+          <p:txBody>
+            <a:bodyPr rtlCol="0" anchor="ctr"/>
+            <a:lstStyle/>
+            <a:p>
+              <a:pPr algn="ctr"/>
+              <a:endParaRPr lang="en-US"/>
+            </a:p>
+          </p:txBody>
+        </p:sp>
+      </p:grpSp>
+      <p:sp>
+        <p:nvSpPr>
+          <p:cNvPr id="23" name="Bogen 22">
+            <a:extLst>
+              <a:ext uri="{FF2B5EF4-FFF2-40B4-BE49-F238E27FC236}">
+                <a16:creationId xmlns:a16="http://schemas.microsoft.com/office/drawing/2014/main" id="{4C3B7B66-F9F8-91AD-D720-40009B335579}"/>
+              </a:ext>
+            </a:extLst>
+          </p:cNvPr>
+          <p:cNvSpPr/>
+          <p:nvPr/>
+        </p:nvSpPr>
+        <p:spPr>
+          <a:xfrm>
+            <a:off x="6402694" y="3087567"/>
+            <a:ext cx="969948" cy="978969"/>
+          </a:xfrm>
+          <a:prstGeom prst="arc">
+            <a:avLst>
+              <a:gd name="adj1" fmla="val 18172811"/>
+              <a:gd name="adj2" fmla="val 1288239"/>
+            </a:avLst>
+          </a:prstGeom>
+          <a:ln w="76200">
+            <a:solidFill>
+              <a:schemeClr val="bg1"/>
+            </a:solidFill>
+          </a:ln>
+        </p:spPr>
+        <p:style>
+          <a:lnRef idx="2">
+            <a:schemeClr val="accent1"/>
+          </a:lnRef>
+          <a:fillRef idx="0">
+            <a:schemeClr val="accent1"/>
+          </a:fillRef>
+          <a:effectRef idx="1">
+            <a:schemeClr val="accent1"/>
+          </a:effectRef>
+          <a:fontRef idx="minor">
+            <a:schemeClr val="tx1"/>
+          </a:fontRef>
+        </p:style>
+        <p:txBody>
+          <a:bodyPr rtlCol="0" anchor="ctr"/>
+          <a:lstStyle/>
+          <a:p>
+            <a:pPr algn="ctr"/>
+            <a:endParaRPr lang="en-US"/>
+          </a:p>
+        </p:txBody>
+      </p:sp>
+      <p:sp>
+        <p:nvSpPr>
+          <p:cNvPr id="24" name="Bogen 23">
+            <a:extLst>
+              <a:ext uri="{FF2B5EF4-FFF2-40B4-BE49-F238E27FC236}">
+                <a16:creationId xmlns:a16="http://schemas.microsoft.com/office/drawing/2014/main" id="{78983B1E-ED83-32C9-C30D-5FEBB4408756}"/>
+              </a:ext>
+            </a:extLst>
+          </p:cNvPr>
+          <p:cNvSpPr/>
+          <p:nvPr/>
+        </p:nvSpPr>
+        <p:spPr>
+          <a:xfrm>
+            <a:off x="5735049" y="2434333"/>
+            <a:ext cx="1212348" cy="1213069"/>
+          </a:xfrm>
+          <a:prstGeom prst="arc">
+            <a:avLst/>
+          </a:prstGeom>
+          <a:ln w="76200">
+            <a:solidFill>
+              <a:schemeClr val="bg1"/>
+            </a:solidFill>
+          </a:ln>
+        </p:spPr>
+        <p:style>
+          <a:lnRef idx="2">
+            <a:schemeClr val="accent1"/>
+          </a:lnRef>
+          <a:fillRef idx="0">
+            <a:schemeClr val="accent1"/>
+          </a:fillRef>
+          <a:effectRef idx="1">
+            <a:schemeClr val="accent1"/>
+          </a:effectRef>
+          <a:fontRef idx="minor">
+            <a:schemeClr val="tx1"/>
+          </a:fontRef>
+        </p:style>
+        <p:txBody>
+          <a:bodyPr rtlCol="0" anchor="ctr"/>
+          <a:lstStyle/>
+          <a:p>
+            <a:pPr algn="ctr"/>
+            <a:endParaRPr lang="en-US"/>
+          </a:p>
+        </p:txBody>
+      </p:sp>
+      <p:sp>
+        <p:nvSpPr>
+          <p:cNvPr id="25" name="Bogen 24">
+            <a:extLst>
+              <a:ext uri="{FF2B5EF4-FFF2-40B4-BE49-F238E27FC236}">
+                <a16:creationId xmlns:a16="http://schemas.microsoft.com/office/drawing/2014/main" id="{ACD2D8A4-E5E6-C484-072B-FDF1B711A5CA}"/>
+              </a:ext>
+            </a:extLst>
+          </p:cNvPr>
+          <p:cNvSpPr/>
+          <p:nvPr/>
+        </p:nvSpPr>
+        <p:spPr>
+          <a:xfrm>
+            <a:off x="4770774" y="2999003"/>
+            <a:ext cx="1093509" cy="1156099"/>
+          </a:xfrm>
+          <a:prstGeom prst="arc">
+            <a:avLst/>
+          </a:prstGeom>
+          <a:ln w="76200">
+            <a:solidFill>
+              <a:schemeClr val="bg1"/>
+            </a:solidFill>
+          </a:ln>
+        </p:spPr>
+        <p:style>
+          <a:lnRef idx="2">
+            <a:schemeClr val="accent1"/>
+          </a:lnRef>
+          <a:fillRef idx="0">
+            <a:schemeClr val="accent1"/>
+          </a:fillRef>
+          <a:effectRef idx="1">
+            <a:schemeClr val="accent1"/>
+          </a:effectRef>
+          <a:fontRef idx="minor">
+            <a:schemeClr val="tx1"/>
+          </a:fontRef>
+        </p:style>
+        <p:txBody>
+          <a:bodyPr rtlCol="0" anchor="ctr"/>
+          <a:lstStyle/>
+          <a:p>
+            <a:pPr algn="ctr"/>
+            <a:endParaRPr lang="en-US"/>
+          </a:p>
+        </p:txBody>
+      </p:sp>
+    </p:spTree>
+    <p:extLst>
+      <p:ext uri="{BB962C8B-B14F-4D97-AF65-F5344CB8AC3E}">
+        <p14:creationId xmlns:p14="http://schemas.microsoft.com/office/powerpoint/2010/main" val="3675591727"/>
+      </p:ext>
+    </p:extLst>
+  </p:cSld>
+  <p:clrMapOvr>
+    <a:masterClrMapping/>
+  </p:clrMapOvr>
+</p:sld>
+</file>
+
+<file path=ppt/slides/slide4.xml><?xml version="1.0" encoding="utf-8"?>
+<p:sld xmlns:a="http://schemas.openxmlformats.org/drawingml/2006/main" xmlns:r="http://schemas.openxmlformats.org/officeDocument/2006/relationships" xmlns:p="http://schemas.openxmlformats.org/presentationml/2006/main">
+  <p:cSld>
+    <p:spTree>
+      <p:nvGrpSpPr>
+        <p:cNvPr id="1" name="">
+          <a:extLst>
+            <a:ext uri="{FF2B5EF4-FFF2-40B4-BE49-F238E27FC236}">
               <a16:creationId xmlns:a16="http://schemas.microsoft.com/office/drawing/2014/main" id="{ABABF23A-96A5-076A-998A-A8E83771D3A2}"/>
             </a:ext>
           </a:extLst>
@@ -5330,9 +6305,20 @@
               <a:gd name="adj" fmla="val 0"/>
             </a:avLst>
           </a:prstGeom>
-          <a:solidFill>
-            <a:schemeClr val="tx1"/>
-          </a:solidFill>
+          <a:gradFill>
+            <a:gsLst>
+              <a:gs pos="0">
+                <a:schemeClr val="tx1">
+                  <a:lumMod val="65000"/>
+                  <a:lumOff val="35000"/>
+                </a:schemeClr>
+              </a:gs>
+              <a:gs pos="100000">
+                <a:schemeClr val="tx1"/>
+              </a:gs>
+            </a:gsLst>
+            <a:lin ang="5400000" scaled="1"/>
+          </a:gradFill>
           <a:ln>
             <a:noFill/>
           </a:ln>
@@ -6243,7 +7229,7 @@
 </p:sld>
 </file>
 
-<file path=ppt/slides/slide4.xml><?xml version="1.0" encoding="utf-8"?>
+<file path=ppt/slides/slide5.xml><?xml version="1.0" encoding="utf-8"?>
 <p:sld xmlns:a="http://schemas.openxmlformats.org/drawingml/2006/main" xmlns:r="http://schemas.openxmlformats.org/officeDocument/2006/relationships" xmlns:p="http://schemas.openxmlformats.org/presentationml/2006/main">
   <p:cSld>
     <p:spTree>
@@ -6266,12 +7252,47 @@
           <a:chExt cx="0" cy="0"/>
         </a:xfrm>
       </p:grpSpPr>
+      <p:sp>
+        <p:nvSpPr>
+          <p:cNvPr id="41" name="Textfeld 40">
+            <a:extLst>
+              <a:ext uri="{FF2B5EF4-FFF2-40B4-BE49-F238E27FC236}">
+                <a16:creationId xmlns:a16="http://schemas.microsoft.com/office/drawing/2014/main" id="{01773E8C-5336-89F3-3957-B661E5376FF8}"/>
+              </a:ext>
+            </a:extLst>
+          </p:cNvPr>
+          <p:cNvSpPr txBox="1"/>
+          <p:nvPr/>
+        </p:nvSpPr>
+        <p:spPr>
+          <a:xfrm>
+            <a:off x="414779" y="890393"/>
+            <a:ext cx="1608197" cy="369332"/>
+          </a:xfrm>
+          <a:prstGeom prst="rect">
+            <a:avLst/>
+          </a:prstGeom>
+          <a:noFill/>
+        </p:spPr>
+        <p:txBody>
+          <a:bodyPr wrap="none" rtlCol="0">
+            <a:spAutoFit/>
+          </a:bodyPr>
+          <a:lstStyle/>
+          <a:p>
+            <a:r>
+              <a:rPr lang="en-US"/>
+              <a:t>Splash Screen</a:t>
+            </a:r>
+          </a:p>
+        </p:txBody>
+      </p:sp>
       <p:grpSp>
         <p:nvGrpSpPr>
-          <p:cNvPr id="42" name="Gruppieren 41">
+          <p:cNvPr id="67" name="Gruppieren 66">
             <a:extLst>
               <a:ext uri="{FF2B5EF4-FFF2-40B4-BE49-F238E27FC236}">
-                <a16:creationId xmlns:a16="http://schemas.microsoft.com/office/drawing/2014/main" id="{97B47D7B-9C95-C6A8-DF67-C52626208CEA}"/>
+                <a16:creationId xmlns:a16="http://schemas.microsoft.com/office/drawing/2014/main" id="{19C0E5F3-440A-B413-D873-AF7EAE55DF41}"/>
               </a:ext>
             </a:extLst>
           </p:cNvPr>
@@ -6308,8 +7329,260 @@
                 <a:gd name="adj" fmla="val 0"/>
               </a:avLst>
             </a:prstGeom>
+            <a:gradFill>
+              <a:gsLst>
+                <a:gs pos="0">
+                  <a:srgbClr val="262626"/>
+                </a:gs>
+                <a:gs pos="100000">
+                  <a:schemeClr val="tx1">
+                    <a:lumMod val="85000"/>
+                    <a:lumOff val="15000"/>
+                  </a:schemeClr>
+                </a:gs>
+              </a:gsLst>
+              <a:lin ang="5400000" scaled="1"/>
+            </a:gradFill>
+            <a:ln>
+              <a:noFill/>
+            </a:ln>
+          </p:spPr>
+          <p:style>
+            <a:lnRef idx="2">
+              <a:schemeClr val="accent1">
+                <a:shade val="15000"/>
+              </a:schemeClr>
+            </a:lnRef>
+            <a:fillRef idx="1">
+              <a:schemeClr val="accent1"/>
+            </a:fillRef>
+            <a:effectRef idx="0">
+              <a:schemeClr val="accent1"/>
+            </a:effectRef>
+            <a:fontRef idx="minor">
+              <a:schemeClr val="lt1"/>
+            </a:fontRef>
+          </p:style>
+          <p:txBody>
+            <a:bodyPr rtlCol="0" anchor="ctr"/>
+            <a:lstStyle/>
+            <a:p>
+              <a:pPr algn="ctr"/>
+              <a:endParaRPr lang="en-US"/>
+            </a:p>
+          </p:txBody>
+        </p:sp>
+        <p:sp>
+          <p:nvSpPr>
+            <p:cNvPr id="51" name="Freihandform: Form 50">
+              <a:extLst>
+                <a:ext uri="{FF2B5EF4-FFF2-40B4-BE49-F238E27FC236}">
+                  <a16:creationId xmlns:a16="http://schemas.microsoft.com/office/drawing/2014/main" id="{CF183EFF-7130-4D42-162C-F1F2799B9EE3}"/>
+                </a:ext>
+              </a:extLst>
+            </p:cNvPr>
+            <p:cNvSpPr/>
+            <p:nvPr/>
+          </p:nvSpPr>
+          <p:spPr>
+            <a:xfrm rot="18880689">
+              <a:off x="5345801" y="3050316"/>
+              <a:ext cx="1422436" cy="1556706"/>
+            </a:xfrm>
+            <a:custGeom>
+              <a:avLst/>
+              <a:gdLst>
+                <a:gd name="csX0" fmla="*/ 2152604 w 2233750"/>
+                <a:gd name="csY0" fmla="*/ 81146 h 2444602"/>
+                <a:gd name="csX1" fmla="*/ 2233750 w 2233750"/>
+                <a:gd name="csY1" fmla="*/ 277049 h 2444602"/>
+                <a:gd name="csX2" fmla="*/ 2233750 w 2233750"/>
+                <a:gd name="csY2" fmla="*/ 1504152 h 2444602"/>
+                <a:gd name="csX3" fmla="*/ 1956701 w 2233750"/>
+                <a:gd name="csY3" fmla="*/ 1781201 h 2444602"/>
+                <a:gd name="csX4" fmla="*/ 1433949 w 2233750"/>
+                <a:gd name="csY4" fmla="*/ 1781201 h 2444602"/>
+                <a:gd name="csX5" fmla="*/ 731578 w 2233750"/>
+                <a:gd name="csY5" fmla="*/ 2402052 h 2444602"/>
+                <a:gd name="csX6" fmla="*/ 492060 w 2233750"/>
+                <a:gd name="csY6" fmla="*/ 2387296 h 2444602"/>
+                <a:gd name="csX7" fmla="*/ 42550 w 2233750"/>
+                <a:gd name="csY7" fmla="*/ 1878764 h 2444602"/>
+                <a:gd name="csX8" fmla="*/ 57306 w 2233750"/>
+                <a:gd name="csY8" fmla="*/ 1639246 h 2444602"/>
+                <a:gd name="csX9" fmla="*/ 571490 w 2233750"/>
+                <a:gd name="csY9" fmla="*/ 1184740 h 2444602"/>
+                <a:gd name="csX10" fmla="*/ 571490 w 2233750"/>
+                <a:gd name="csY10" fmla="*/ 277049 h 2444602"/>
+                <a:gd name="csX11" fmla="*/ 848539 w 2233750"/>
+                <a:gd name="csY11" fmla="*/ 0 h 2444602"/>
+                <a:gd name="csX12" fmla="*/ 1956701 w 2233750"/>
+                <a:gd name="csY12" fmla="*/ 0 h 2444602"/>
+                <a:gd name="csX13" fmla="*/ 2152604 w 2233750"/>
+                <a:gd name="csY13" fmla="*/ 81146 h 2444602"/>
+              </a:gdLst>
+              <a:ahLst/>
+              <a:cxnLst>
+                <a:cxn ang="0">
+                  <a:pos x="csX0" y="csY0"/>
+                </a:cxn>
+                <a:cxn ang="0">
+                  <a:pos x="csX1" y="csY1"/>
+                </a:cxn>
+                <a:cxn ang="0">
+                  <a:pos x="csX2" y="csY2"/>
+                </a:cxn>
+                <a:cxn ang="0">
+                  <a:pos x="csX3" y="csY3"/>
+                </a:cxn>
+                <a:cxn ang="0">
+                  <a:pos x="csX4" y="csY4"/>
+                </a:cxn>
+                <a:cxn ang="0">
+                  <a:pos x="csX5" y="csY5"/>
+                </a:cxn>
+                <a:cxn ang="0">
+                  <a:pos x="csX6" y="csY6"/>
+                </a:cxn>
+                <a:cxn ang="0">
+                  <a:pos x="csX7" y="csY7"/>
+                </a:cxn>
+                <a:cxn ang="0">
+                  <a:pos x="csX8" y="csY8"/>
+                </a:cxn>
+                <a:cxn ang="0">
+                  <a:pos x="csX9" y="csY9"/>
+                </a:cxn>
+                <a:cxn ang="0">
+                  <a:pos x="csX10" y="csY10"/>
+                </a:cxn>
+                <a:cxn ang="0">
+                  <a:pos x="csX11" y="csY11"/>
+                </a:cxn>
+                <a:cxn ang="0">
+                  <a:pos x="csX12" y="csY12"/>
+                </a:cxn>
+                <a:cxn ang="0">
+                  <a:pos x="csX13" y="csY13"/>
+                </a:cxn>
+              </a:cxnLst>
+              <a:rect l="l" t="t" r="r" b="b"/>
+              <a:pathLst>
+                <a:path w="2233750" h="2444602">
+                  <a:moveTo>
+                    <a:pt x="2152604" y="81146"/>
+                  </a:moveTo>
+                  <a:cubicBezTo>
+                    <a:pt x="2202740" y="131282"/>
+                    <a:pt x="2233750" y="200544"/>
+                    <a:pt x="2233750" y="277049"/>
+                  </a:cubicBezTo>
+                  <a:lnTo>
+                    <a:pt x="2233750" y="1504152"/>
+                  </a:lnTo>
+                  <a:cubicBezTo>
+                    <a:pt x="2233750" y="1657162"/>
+                    <a:pt x="2109711" y="1781201"/>
+                    <a:pt x="1956701" y="1781201"/>
+                  </a:cubicBezTo>
+                  <a:lnTo>
+                    <a:pt x="1433949" y="1781201"/>
+                  </a:lnTo>
+                  <a:lnTo>
+                    <a:pt x="731578" y="2402052"/>
+                  </a:lnTo>
+                  <a:cubicBezTo>
+                    <a:pt x="661362" y="2464118"/>
+                    <a:pt x="554126" y="2457512"/>
+                    <a:pt x="492060" y="2387296"/>
+                  </a:cubicBezTo>
+                  <a:lnTo>
+                    <a:pt x="42550" y="1878764"/>
+                  </a:lnTo>
+                  <a:cubicBezTo>
+                    <a:pt x="-19516" y="1808548"/>
+                    <a:pt x="-12910" y="1701312"/>
+                    <a:pt x="57306" y="1639246"/>
+                  </a:cubicBezTo>
+                  <a:lnTo>
+                    <a:pt x="571490" y="1184740"/>
+                  </a:lnTo>
+                  <a:lnTo>
+                    <a:pt x="571490" y="277049"/>
+                  </a:lnTo>
+                  <a:cubicBezTo>
+                    <a:pt x="571490" y="124039"/>
+                    <a:pt x="695529" y="0"/>
+                    <a:pt x="848539" y="0"/>
+                  </a:cubicBezTo>
+                  <a:lnTo>
+                    <a:pt x="1956701" y="0"/>
+                  </a:lnTo>
+                  <a:cubicBezTo>
+                    <a:pt x="2033206" y="0"/>
+                    <a:pt x="2102468" y="31010"/>
+                    <a:pt x="2152604" y="81146"/>
+                  </a:cubicBezTo>
+                  <a:close/>
+                </a:path>
+              </a:pathLst>
+            </a:custGeom>
             <a:solidFill>
-              <a:schemeClr val="tx1"/>
+              <a:srgbClr val="9FF62A"/>
+            </a:solidFill>
+            <a:ln>
+              <a:noFill/>
+            </a:ln>
+          </p:spPr>
+          <p:style>
+            <a:lnRef idx="2">
+              <a:schemeClr val="accent1">
+                <a:shade val="15000"/>
+              </a:schemeClr>
+            </a:lnRef>
+            <a:fillRef idx="1">
+              <a:schemeClr val="accent1"/>
+            </a:fillRef>
+            <a:effectRef idx="0">
+              <a:schemeClr val="accent1"/>
+            </a:effectRef>
+            <a:fontRef idx="minor">
+              <a:schemeClr val="lt1"/>
+            </a:fontRef>
+          </p:style>
+          <p:txBody>
+            <a:bodyPr wrap="square" rtlCol="0" anchor="ctr">
+              <a:noAutofit/>
+            </a:bodyPr>
+            <a:lstStyle/>
+            <a:p>
+              <a:pPr algn="ctr"/>
+              <a:endParaRPr lang="en-US"/>
+            </a:p>
+          </p:txBody>
+        </p:sp>
+        <p:sp>
+          <p:nvSpPr>
+            <p:cNvPr id="53" name="Ellipse 52">
+              <a:extLst>
+                <a:ext uri="{FF2B5EF4-FFF2-40B4-BE49-F238E27FC236}">
+                  <a16:creationId xmlns:a16="http://schemas.microsoft.com/office/drawing/2014/main" id="{DC7A0DD3-8F05-52DA-2207-4F18CA94E615}"/>
+                </a:ext>
+              </a:extLst>
+            </p:cNvPr>
+            <p:cNvSpPr/>
+            <p:nvPr/>
+          </p:nvSpPr>
+          <p:spPr>
+            <a:xfrm>
+              <a:off x="5292350" y="3131082"/>
+              <a:ext cx="696339" cy="772473"/>
+            </a:xfrm>
+            <a:prstGeom prst="ellipse">
+              <a:avLst/>
+            </a:prstGeom>
+            <a:solidFill>
+              <a:schemeClr val="accent3"/>
             </a:solidFill>
             <a:ln>
               <a:noFill/>
@@ -6340,34 +7613,963 @@
             </a:p>
           </p:txBody>
         </p:sp>
-        <p:grpSp>
-          <p:nvGrpSpPr>
-            <p:cNvPr id="40" name="Gruppieren 39">
+        <p:sp>
+          <p:nvSpPr>
+            <p:cNvPr id="54" name="Ellipse 53">
               <a:extLst>
                 <a:ext uri="{FF2B5EF4-FFF2-40B4-BE49-F238E27FC236}">
-                  <a16:creationId xmlns:a16="http://schemas.microsoft.com/office/drawing/2014/main" id="{F99D1C0F-D2C4-F799-EBBA-13074026467F}"/>
+                  <a16:creationId xmlns:a16="http://schemas.microsoft.com/office/drawing/2014/main" id="{08313515-39DD-B8B3-000F-2AC4B2DC6C99}"/>
                 </a:ext>
               </a:extLst>
             </p:cNvPr>
-            <p:cNvGrpSpPr>
-              <a:grpSpLocks noChangeAspect="1"/>
-            </p:cNvGrpSpPr>
+            <p:cNvSpPr/>
+            <p:nvPr/>
+          </p:nvSpPr>
+          <p:spPr>
+            <a:xfrm>
+              <a:off x="4983368" y="3101067"/>
+              <a:ext cx="569938" cy="623401"/>
+            </a:xfrm>
+            <a:prstGeom prst="ellipse">
+              <a:avLst/>
+            </a:prstGeom>
+            <a:solidFill>
+              <a:schemeClr val="accent3"/>
+            </a:solidFill>
+            <a:ln>
+              <a:noFill/>
+            </a:ln>
+          </p:spPr>
+          <p:style>
+            <a:lnRef idx="2">
+              <a:schemeClr val="accent1">
+                <a:shade val="15000"/>
+              </a:schemeClr>
+            </a:lnRef>
+            <a:fillRef idx="1">
+              <a:schemeClr val="accent1"/>
+            </a:fillRef>
+            <a:effectRef idx="0">
+              <a:schemeClr val="accent1"/>
+            </a:effectRef>
+            <a:fontRef idx="minor">
+              <a:schemeClr val="lt1"/>
+            </a:fontRef>
+          </p:style>
+          <p:txBody>
+            <a:bodyPr rtlCol="0" anchor="ctr"/>
+            <a:lstStyle/>
+            <a:p>
+              <a:pPr algn="ctr"/>
+              <a:endParaRPr lang="en-US"/>
+            </a:p>
+          </p:txBody>
+        </p:sp>
+        <p:sp>
+          <p:nvSpPr>
+            <p:cNvPr id="55" name="Ellipse 54">
+              <a:extLst>
+                <a:ext uri="{FF2B5EF4-FFF2-40B4-BE49-F238E27FC236}">
+                  <a16:creationId xmlns:a16="http://schemas.microsoft.com/office/drawing/2014/main" id="{CA98B7F4-7367-A216-61CA-E6412A604391}"/>
+                </a:ext>
+              </a:extLst>
+            </p:cNvPr>
+            <p:cNvSpPr/>
+            <p:nvPr/>
+          </p:nvSpPr>
+          <p:spPr>
+            <a:xfrm>
+              <a:off x="5094590" y="2712347"/>
+              <a:ext cx="569938" cy="623401"/>
+            </a:xfrm>
+            <a:prstGeom prst="ellipse">
+              <a:avLst/>
+            </a:prstGeom>
+            <a:solidFill>
+              <a:schemeClr val="accent3"/>
+            </a:solidFill>
+            <a:ln>
+              <a:noFill/>
+            </a:ln>
+          </p:spPr>
+          <p:style>
+            <a:lnRef idx="2">
+              <a:schemeClr val="accent1">
+                <a:shade val="15000"/>
+              </a:schemeClr>
+            </a:lnRef>
+            <a:fillRef idx="1">
+              <a:schemeClr val="accent1"/>
+            </a:fillRef>
+            <a:effectRef idx="0">
+              <a:schemeClr val="accent1"/>
+            </a:effectRef>
+            <a:fontRef idx="minor">
+              <a:schemeClr val="lt1"/>
+            </a:fontRef>
+          </p:style>
+          <p:txBody>
+            <a:bodyPr rtlCol="0" anchor="ctr"/>
+            <a:lstStyle/>
+            <a:p>
+              <a:pPr algn="ctr"/>
+              <a:endParaRPr lang="en-US"/>
+            </a:p>
+          </p:txBody>
+        </p:sp>
+        <p:sp>
+          <p:nvSpPr>
+            <p:cNvPr id="56" name="Ellipse 55">
+              <a:extLst>
+                <a:ext uri="{FF2B5EF4-FFF2-40B4-BE49-F238E27FC236}">
+                  <a16:creationId xmlns:a16="http://schemas.microsoft.com/office/drawing/2014/main" id="{391DE06A-71E3-15D9-9F9C-C7B67B8388EA}"/>
+                </a:ext>
+              </a:extLst>
+            </p:cNvPr>
+            <p:cNvSpPr/>
+            <p:nvPr/>
+          </p:nvSpPr>
+          <p:spPr>
+            <a:xfrm>
+              <a:off x="5486890" y="2356702"/>
+              <a:ext cx="922005" cy="772473"/>
+            </a:xfrm>
+            <a:prstGeom prst="ellipse">
+              <a:avLst/>
+            </a:prstGeom>
+            <a:solidFill>
+              <a:schemeClr val="accent3"/>
+            </a:solidFill>
+            <a:ln>
+              <a:noFill/>
+            </a:ln>
+          </p:spPr>
+          <p:style>
+            <a:lnRef idx="2">
+              <a:schemeClr val="accent1">
+                <a:shade val="15000"/>
+              </a:schemeClr>
+            </a:lnRef>
+            <a:fillRef idx="1">
+              <a:schemeClr val="accent1"/>
+            </a:fillRef>
+            <a:effectRef idx="0">
+              <a:schemeClr val="accent1"/>
+            </a:effectRef>
+            <a:fontRef idx="minor">
+              <a:schemeClr val="lt1"/>
+            </a:fontRef>
+          </p:style>
+          <p:txBody>
+            <a:bodyPr rtlCol="0" anchor="ctr"/>
+            <a:lstStyle/>
+            <a:p>
+              <a:pPr algn="ctr"/>
+              <a:endParaRPr lang="en-US"/>
+            </a:p>
+          </p:txBody>
+        </p:sp>
+        <p:sp>
+          <p:nvSpPr>
+            <p:cNvPr id="57" name="Ellipse 56">
+              <a:extLst>
+                <a:ext uri="{FF2B5EF4-FFF2-40B4-BE49-F238E27FC236}">
+                  <a16:creationId xmlns:a16="http://schemas.microsoft.com/office/drawing/2014/main" id="{7C44995A-716D-2D0F-0576-9A73125DCF5A}"/>
+                </a:ext>
+              </a:extLst>
+            </p:cNvPr>
+            <p:cNvSpPr/>
+            <p:nvPr/>
+          </p:nvSpPr>
+          <p:spPr>
+            <a:xfrm>
+              <a:off x="6140769" y="2494434"/>
+              <a:ext cx="696339" cy="623401"/>
+            </a:xfrm>
+            <a:prstGeom prst="ellipse">
+              <a:avLst/>
+            </a:prstGeom>
+            <a:solidFill>
+              <a:schemeClr val="accent3"/>
+            </a:solidFill>
+            <a:ln>
+              <a:noFill/>
+            </a:ln>
+          </p:spPr>
+          <p:style>
+            <a:lnRef idx="2">
+              <a:schemeClr val="accent1">
+                <a:shade val="15000"/>
+              </a:schemeClr>
+            </a:lnRef>
+            <a:fillRef idx="1">
+              <a:schemeClr val="accent1"/>
+            </a:fillRef>
+            <a:effectRef idx="0">
+              <a:schemeClr val="accent1"/>
+            </a:effectRef>
+            <a:fontRef idx="minor">
+              <a:schemeClr val="lt1"/>
+            </a:fontRef>
+          </p:style>
+          <p:txBody>
+            <a:bodyPr rtlCol="0" anchor="ctr"/>
+            <a:lstStyle/>
+            <a:p>
+              <a:pPr algn="ctr"/>
+              <a:endParaRPr lang="en-US"/>
+            </a:p>
+          </p:txBody>
+        </p:sp>
+        <p:sp>
+          <p:nvSpPr>
+            <p:cNvPr id="58" name="Ellipse 57">
+              <a:extLst>
+                <a:ext uri="{FF2B5EF4-FFF2-40B4-BE49-F238E27FC236}">
+                  <a16:creationId xmlns:a16="http://schemas.microsoft.com/office/drawing/2014/main" id="{8C8C8A28-BB2A-575B-DC21-04D226A7DF79}"/>
+                </a:ext>
+              </a:extLst>
+            </p:cNvPr>
+            <p:cNvSpPr/>
+            <p:nvPr/>
+          </p:nvSpPr>
+          <p:spPr>
+            <a:xfrm>
+              <a:off x="6471287" y="2752937"/>
+              <a:ext cx="603598" cy="623401"/>
+            </a:xfrm>
+            <a:prstGeom prst="ellipse">
+              <a:avLst/>
+            </a:prstGeom>
+            <a:solidFill>
+              <a:schemeClr val="accent3"/>
+            </a:solidFill>
+            <a:ln>
+              <a:noFill/>
+            </a:ln>
+          </p:spPr>
+          <p:style>
+            <a:lnRef idx="2">
+              <a:schemeClr val="accent1">
+                <a:shade val="15000"/>
+              </a:schemeClr>
+            </a:lnRef>
+            <a:fillRef idx="1">
+              <a:schemeClr val="accent1"/>
+            </a:fillRef>
+            <a:effectRef idx="0">
+              <a:schemeClr val="accent1"/>
+            </a:effectRef>
+            <a:fontRef idx="minor">
+              <a:schemeClr val="lt1"/>
+            </a:fontRef>
+          </p:style>
+          <p:txBody>
+            <a:bodyPr rtlCol="0" anchor="ctr"/>
+            <a:lstStyle/>
+            <a:p>
+              <a:pPr algn="ctr"/>
+              <a:endParaRPr lang="en-US"/>
+            </a:p>
+          </p:txBody>
+        </p:sp>
+        <p:sp>
+          <p:nvSpPr>
+            <p:cNvPr id="59" name="Ellipse 58">
+              <a:extLst>
+                <a:ext uri="{FF2B5EF4-FFF2-40B4-BE49-F238E27FC236}">
+                  <a16:creationId xmlns:a16="http://schemas.microsoft.com/office/drawing/2014/main" id="{B7B90A04-73FE-39CF-8F4A-8F2ACED8D8AF}"/>
+                </a:ext>
+              </a:extLst>
+            </p:cNvPr>
+            <p:cNvSpPr/>
+            <p:nvPr/>
+          </p:nvSpPr>
+          <p:spPr>
+            <a:xfrm>
+              <a:off x="6605035" y="3093824"/>
+              <a:ext cx="603598" cy="623401"/>
+            </a:xfrm>
+            <a:prstGeom prst="ellipse">
+              <a:avLst/>
+            </a:prstGeom>
+            <a:solidFill>
+              <a:schemeClr val="accent3"/>
+            </a:solidFill>
+            <a:ln>
+              <a:noFill/>
+            </a:ln>
+          </p:spPr>
+          <p:style>
+            <a:lnRef idx="2">
+              <a:schemeClr val="accent1">
+                <a:shade val="15000"/>
+              </a:schemeClr>
+            </a:lnRef>
+            <a:fillRef idx="1">
+              <a:schemeClr val="accent1"/>
+            </a:fillRef>
+            <a:effectRef idx="0">
+              <a:schemeClr val="accent1"/>
+            </a:effectRef>
+            <a:fontRef idx="minor">
+              <a:schemeClr val="lt1"/>
+            </a:fontRef>
+          </p:style>
+          <p:txBody>
+            <a:bodyPr rtlCol="0" anchor="ctr"/>
+            <a:lstStyle/>
+            <a:p>
+              <a:pPr algn="ctr"/>
+              <a:endParaRPr lang="en-US"/>
+            </a:p>
+          </p:txBody>
+        </p:sp>
+        <p:sp>
+          <p:nvSpPr>
+            <p:cNvPr id="60" name="Ellipse 59">
+              <a:extLst>
+                <a:ext uri="{FF2B5EF4-FFF2-40B4-BE49-F238E27FC236}">
+                  <a16:creationId xmlns:a16="http://schemas.microsoft.com/office/drawing/2014/main" id="{FD22B976-F546-116B-D19E-3FD3D78D810D}"/>
+                </a:ext>
+              </a:extLst>
+            </p:cNvPr>
+            <p:cNvSpPr/>
+            <p:nvPr/>
+          </p:nvSpPr>
+          <p:spPr>
+            <a:xfrm>
+              <a:off x="6319555" y="3258692"/>
+              <a:ext cx="603598" cy="623401"/>
+            </a:xfrm>
+            <a:prstGeom prst="ellipse">
+              <a:avLst/>
+            </a:prstGeom>
+            <a:solidFill>
+              <a:schemeClr val="accent3"/>
+            </a:solidFill>
+            <a:ln>
+              <a:noFill/>
+            </a:ln>
+          </p:spPr>
+          <p:style>
+            <a:lnRef idx="2">
+              <a:schemeClr val="accent1">
+                <a:shade val="15000"/>
+              </a:schemeClr>
+            </a:lnRef>
+            <a:fillRef idx="1">
+              <a:schemeClr val="accent1"/>
+            </a:fillRef>
+            <a:effectRef idx="0">
+              <a:schemeClr val="accent1"/>
+            </a:effectRef>
+            <a:fontRef idx="minor">
+              <a:schemeClr val="lt1"/>
+            </a:fontRef>
+          </p:style>
+          <p:txBody>
+            <a:bodyPr rtlCol="0" anchor="ctr"/>
+            <a:lstStyle/>
+            <a:p>
+              <a:pPr algn="ctr"/>
+              <a:endParaRPr lang="en-US"/>
+            </a:p>
+          </p:txBody>
+        </p:sp>
+        <p:sp>
+          <p:nvSpPr>
+            <p:cNvPr id="61" name="Ellipse 60">
+              <a:extLst>
+                <a:ext uri="{FF2B5EF4-FFF2-40B4-BE49-F238E27FC236}">
+                  <a16:creationId xmlns:a16="http://schemas.microsoft.com/office/drawing/2014/main" id="{6CC425C3-E473-B66A-6839-990FB05B20D1}"/>
+                </a:ext>
+              </a:extLst>
+            </p:cNvPr>
+            <p:cNvSpPr/>
+            <p:nvPr/>
+          </p:nvSpPr>
+          <p:spPr>
+            <a:xfrm>
+              <a:off x="6014358" y="2923380"/>
+              <a:ext cx="603598" cy="623401"/>
+            </a:xfrm>
+            <a:prstGeom prst="ellipse">
+              <a:avLst/>
+            </a:prstGeom>
+            <a:solidFill>
+              <a:schemeClr val="accent3"/>
+            </a:solidFill>
+            <a:ln>
+              <a:noFill/>
+            </a:ln>
+          </p:spPr>
+          <p:style>
+            <a:lnRef idx="2">
+              <a:schemeClr val="accent1">
+                <a:shade val="15000"/>
+              </a:schemeClr>
+            </a:lnRef>
+            <a:fillRef idx="1">
+              <a:schemeClr val="accent1"/>
+            </a:fillRef>
+            <a:effectRef idx="0">
+              <a:schemeClr val="accent1"/>
+            </a:effectRef>
+            <a:fontRef idx="minor">
+              <a:schemeClr val="lt1"/>
+            </a:fontRef>
+          </p:style>
+          <p:txBody>
+            <a:bodyPr rtlCol="0" anchor="ctr"/>
+            <a:lstStyle/>
+            <a:p>
+              <a:pPr algn="ctr"/>
+              <a:endParaRPr lang="en-US"/>
+            </a:p>
+          </p:txBody>
+        </p:sp>
+        <p:sp>
+          <p:nvSpPr>
+            <p:cNvPr id="62" name="Ellipse 61">
+              <a:extLst>
+                <a:ext uri="{FF2B5EF4-FFF2-40B4-BE49-F238E27FC236}">
+                  <a16:creationId xmlns:a16="http://schemas.microsoft.com/office/drawing/2014/main" id="{6EF3BAFB-E234-3D47-AE42-209727F929B5}"/>
+                </a:ext>
+              </a:extLst>
+            </p:cNvPr>
+            <p:cNvSpPr/>
+            <p:nvPr/>
+          </p:nvSpPr>
+          <p:spPr>
+            <a:xfrm>
+              <a:off x="5563123" y="2846074"/>
+              <a:ext cx="764965" cy="736196"/>
+            </a:xfrm>
+            <a:prstGeom prst="ellipse">
+              <a:avLst/>
+            </a:prstGeom>
+            <a:solidFill>
+              <a:schemeClr val="accent3"/>
+            </a:solidFill>
+            <a:ln>
+              <a:noFill/>
+            </a:ln>
+          </p:spPr>
+          <p:style>
+            <a:lnRef idx="2">
+              <a:schemeClr val="accent1">
+                <a:shade val="15000"/>
+              </a:schemeClr>
+            </a:lnRef>
+            <a:fillRef idx="1">
+              <a:schemeClr val="accent1"/>
+            </a:fillRef>
+            <a:effectRef idx="0">
+              <a:schemeClr val="accent1"/>
+            </a:effectRef>
+            <a:fontRef idx="minor">
+              <a:schemeClr val="lt1"/>
+            </a:fontRef>
+          </p:style>
+          <p:txBody>
+            <a:bodyPr rtlCol="0" anchor="ctr"/>
+            <a:lstStyle/>
+            <a:p>
+              <a:pPr algn="ctr"/>
+              <a:endParaRPr lang="en-US"/>
+            </a:p>
+          </p:txBody>
+        </p:sp>
+        <p:sp>
+          <p:nvSpPr>
+            <p:cNvPr id="63" name="Bogen 62">
+              <a:extLst>
+                <a:ext uri="{FF2B5EF4-FFF2-40B4-BE49-F238E27FC236}">
+                  <a16:creationId xmlns:a16="http://schemas.microsoft.com/office/drawing/2014/main" id="{61F1E257-380E-7638-8B58-5169C3495CF4}"/>
+                </a:ext>
+              </a:extLst>
+            </p:cNvPr>
+            <p:cNvSpPr/>
+            <p:nvPr/>
+          </p:nvSpPr>
+          <p:spPr>
+            <a:xfrm>
+              <a:off x="6261287" y="3258692"/>
+              <a:ext cx="617656" cy="623401"/>
+            </a:xfrm>
+            <a:prstGeom prst="arc">
+              <a:avLst>
+                <a:gd name="adj1" fmla="val 18172811"/>
+                <a:gd name="adj2" fmla="val 1288239"/>
+              </a:avLst>
+            </a:prstGeom>
+            <a:ln w="76200">
+              <a:solidFill>
+                <a:schemeClr val="bg1"/>
+              </a:solidFill>
+            </a:ln>
+          </p:spPr>
+          <p:style>
+            <a:lnRef idx="2">
+              <a:schemeClr val="accent1"/>
+            </a:lnRef>
+            <a:fillRef idx="0">
+              <a:schemeClr val="accent1"/>
+            </a:fillRef>
+            <a:effectRef idx="1">
+              <a:schemeClr val="accent1"/>
+            </a:effectRef>
+            <a:fontRef idx="minor">
+              <a:schemeClr val="tx1"/>
+            </a:fontRef>
+          </p:style>
+          <p:txBody>
+            <a:bodyPr rtlCol="0" anchor="ctr"/>
+            <a:lstStyle/>
+            <a:p>
+              <a:pPr algn="ctr"/>
+              <a:endParaRPr lang="en-US"/>
+            </a:p>
+          </p:txBody>
+        </p:sp>
+        <p:sp>
+          <p:nvSpPr>
+            <p:cNvPr id="64" name="Bogen 63">
+              <a:extLst>
+                <a:ext uri="{FF2B5EF4-FFF2-40B4-BE49-F238E27FC236}">
+                  <a16:creationId xmlns:a16="http://schemas.microsoft.com/office/drawing/2014/main" id="{96EDDC49-532A-65F2-C899-67B2A97DC121}"/>
+                </a:ext>
+              </a:extLst>
+            </p:cNvPr>
+            <p:cNvSpPr/>
+            <p:nvPr/>
+          </p:nvSpPr>
+          <p:spPr>
+            <a:xfrm>
+              <a:off x="5866149" y="2850916"/>
+              <a:ext cx="772015" cy="772474"/>
+            </a:xfrm>
+            <a:prstGeom prst="arc">
+              <a:avLst>
+                <a:gd name="adj1" fmla="val 16200000"/>
+                <a:gd name="adj2" fmla="val 20501590"/>
+              </a:avLst>
+            </a:prstGeom>
+            <a:ln w="76200">
+              <a:solidFill>
+                <a:schemeClr val="bg1"/>
+              </a:solidFill>
+            </a:ln>
+          </p:spPr>
+          <p:style>
+            <a:lnRef idx="2">
+              <a:schemeClr val="accent1"/>
+            </a:lnRef>
+            <a:fillRef idx="0">
+              <a:schemeClr val="accent1"/>
+            </a:fillRef>
+            <a:effectRef idx="1">
+              <a:schemeClr val="accent1"/>
+            </a:effectRef>
+            <a:fontRef idx="minor">
+              <a:schemeClr val="tx1"/>
+            </a:fontRef>
+          </p:style>
+          <p:txBody>
+            <a:bodyPr rtlCol="0" anchor="ctr"/>
+            <a:lstStyle/>
+            <a:p>
+              <a:pPr algn="ctr"/>
+              <a:endParaRPr lang="en-US"/>
+            </a:p>
+          </p:txBody>
+        </p:sp>
+        <p:sp>
+          <p:nvSpPr>
+            <p:cNvPr id="65" name="Bogen 64">
+              <a:extLst>
+                <a:ext uri="{FF2B5EF4-FFF2-40B4-BE49-F238E27FC236}">
+                  <a16:creationId xmlns:a16="http://schemas.microsoft.com/office/drawing/2014/main" id="{38A13DFB-911D-8224-9A9A-1C863CD5501A}"/>
+                </a:ext>
+              </a:extLst>
+            </p:cNvPr>
+            <p:cNvSpPr/>
+            <p:nvPr/>
+          </p:nvSpPr>
+          <p:spPr>
+            <a:xfrm>
+              <a:off x="5252105" y="3210494"/>
+              <a:ext cx="696339" cy="736196"/>
+            </a:xfrm>
+            <a:prstGeom prst="arc">
+              <a:avLst>
+                <a:gd name="adj1" fmla="val 16200000"/>
+                <a:gd name="adj2" fmla="val 20595110"/>
+              </a:avLst>
+            </a:prstGeom>
+            <a:ln w="76200">
+              <a:solidFill>
+                <a:schemeClr val="bg1"/>
+              </a:solidFill>
+            </a:ln>
+          </p:spPr>
+          <p:style>
+            <a:lnRef idx="2">
+              <a:schemeClr val="accent1"/>
+            </a:lnRef>
+            <a:fillRef idx="0">
+              <a:schemeClr val="accent1"/>
+            </a:fillRef>
+            <a:effectRef idx="1">
+              <a:schemeClr val="accent1"/>
+            </a:effectRef>
+            <a:fontRef idx="minor">
+              <a:schemeClr val="tx1"/>
+            </a:fontRef>
+          </p:style>
+          <p:txBody>
+            <a:bodyPr rtlCol="0" anchor="ctr"/>
+            <a:lstStyle/>
+            <a:p>
+              <a:pPr algn="ctr"/>
+              <a:endParaRPr lang="en-US"/>
+            </a:p>
+          </p:txBody>
+        </p:sp>
+      </p:grpSp>
+    </p:spTree>
+    <p:extLst>
+      <p:ext uri="{BB962C8B-B14F-4D97-AF65-F5344CB8AC3E}">
+        <p14:creationId xmlns:p14="http://schemas.microsoft.com/office/powerpoint/2010/main" val="3030907397"/>
+      </p:ext>
+    </p:extLst>
+  </p:cSld>
+  <p:clrMapOvr>
+    <a:masterClrMapping/>
+  </p:clrMapOvr>
+</p:sld>
+</file>
+
+<file path=ppt/slides/slide6.xml><?xml version="1.0" encoding="utf-8"?>
+<p:sld xmlns:a="http://schemas.openxmlformats.org/drawingml/2006/main" xmlns:r="http://schemas.openxmlformats.org/officeDocument/2006/relationships" xmlns:p="http://schemas.openxmlformats.org/presentationml/2006/main">
+  <p:cSld>
+    <p:spTree>
+      <p:nvGrpSpPr>
+        <p:cNvPr id="1" name="">
+          <a:extLst>
+            <a:ext uri="{FF2B5EF4-FFF2-40B4-BE49-F238E27FC236}">
+              <a16:creationId xmlns:a16="http://schemas.microsoft.com/office/drawing/2014/main" id="{5293D7EC-7D5D-BCB0-8023-84F8BBA02D67}"/>
+            </a:ext>
+          </a:extLst>
+        </p:cNvPr>
+        <p:cNvGrpSpPr/>
+        <p:nvPr/>
+      </p:nvGrpSpPr>
+      <p:grpSpPr>
+        <a:xfrm>
+          <a:off x="0" y="0"/>
+          <a:ext cx="0" cy="0"/>
+          <a:chOff x="0" y="0"/>
+          <a:chExt cx="0" cy="0"/>
+        </a:xfrm>
+      </p:grpSpPr>
+      <p:sp>
+        <p:nvSpPr>
+          <p:cNvPr id="6" name="Rechteck: abgerundete Ecken 5">
+            <a:extLst>
+              <a:ext uri="{FF2B5EF4-FFF2-40B4-BE49-F238E27FC236}">
+                <a16:creationId xmlns:a16="http://schemas.microsoft.com/office/drawing/2014/main" id="{49B6EC7B-BD7F-4BEA-6898-1C4C07A642A0}"/>
+              </a:ext>
+            </a:extLst>
+          </p:cNvPr>
+          <p:cNvSpPr/>
+          <p:nvPr/>
+        </p:nvSpPr>
+        <p:spPr>
+          <a:xfrm>
+            <a:off x="2676000" y="9000"/>
+            <a:ext cx="6840000" cy="6840000"/>
+          </a:xfrm>
+          <a:prstGeom prst="roundRect">
+            <a:avLst>
+              <a:gd name="adj" fmla="val 0"/>
+            </a:avLst>
+          </a:prstGeom>
+          <a:solidFill>
+            <a:schemeClr val="tx1"/>
+          </a:solidFill>
+          <a:ln>
+            <a:noFill/>
+          </a:ln>
+        </p:spPr>
+        <p:style>
+          <a:lnRef idx="2">
+            <a:schemeClr val="accent1">
+              <a:shade val="15000"/>
+            </a:schemeClr>
+          </a:lnRef>
+          <a:fillRef idx="1">
+            <a:schemeClr val="accent1"/>
+          </a:fillRef>
+          <a:effectRef idx="0">
+            <a:schemeClr val="accent1"/>
+          </a:effectRef>
+          <a:fontRef idx="minor">
+            <a:schemeClr val="lt1"/>
+          </a:fontRef>
+        </p:style>
+        <p:txBody>
+          <a:bodyPr rtlCol="0" anchor="ctr"/>
+          <a:lstStyle/>
+          <a:p>
+            <a:pPr algn="ctr"/>
+            <a:endParaRPr lang="en-US"/>
+          </a:p>
+        </p:txBody>
+      </p:sp>
+      <p:grpSp>
+        <p:nvGrpSpPr>
+          <p:cNvPr id="40" name="Gruppieren 39">
+            <a:extLst>
+              <a:ext uri="{FF2B5EF4-FFF2-40B4-BE49-F238E27FC236}">
+                <a16:creationId xmlns:a16="http://schemas.microsoft.com/office/drawing/2014/main" id="{3ECE757F-32C9-2E84-A428-7EB4D969DA6B}"/>
+              </a:ext>
+            </a:extLst>
+          </p:cNvPr>
+          <p:cNvGrpSpPr>
+            <a:grpSpLocks noChangeAspect="1"/>
+          </p:cNvGrpSpPr>
+          <p:nvPr/>
+        </p:nvGrpSpPr>
+        <p:grpSpPr>
+          <a:xfrm>
+            <a:off x="4882478" y="2238426"/>
+            <a:ext cx="2427044" cy="2381148"/>
+            <a:chOff x="4348757" y="1658235"/>
+            <a:chExt cx="3494487" cy="3428406"/>
+          </a:xfrm>
+        </p:grpSpPr>
+        <p:sp>
+          <p:nvSpPr>
+            <p:cNvPr id="22" name="Freihandform: Form 21">
+              <a:extLst>
+                <a:ext uri="{FF2B5EF4-FFF2-40B4-BE49-F238E27FC236}">
+                  <a16:creationId xmlns:a16="http://schemas.microsoft.com/office/drawing/2014/main" id="{3EE47F0B-FA8D-DCE2-2AE9-868D2A1C5A07}"/>
+                </a:ext>
+              </a:extLst>
+            </p:cNvPr>
+            <p:cNvSpPr/>
+            <p:nvPr/>
+          </p:nvSpPr>
+          <p:spPr>
+            <a:xfrm rot="18880689">
+              <a:off x="4917910" y="2747465"/>
+              <a:ext cx="2233750" cy="2444602"/>
+            </a:xfrm>
+            <a:custGeom>
+              <a:avLst/>
+              <a:gdLst>
+                <a:gd name="csX0" fmla="*/ 2152604 w 2233750"/>
+                <a:gd name="csY0" fmla="*/ 81146 h 2444602"/>
+                <a:gd name="csX1" fmla="*/ 2233750 w 2233750"/>
+                <a:gd name="csY1" fmla="*/ 277049 h 2444602"/>
+                <a:gd name="csX2" fmla="*/ 2233750 w 2233750"/>
+                <a:gd name="csY2" fmla="*/ 1504152 h 2444602"/>
+                <a:gd name="csX3" fmla="*/ 1956701 w 2233750"/>
+                <a:gd name="csY3" fmla="*/ 1781201 h 2444602"/>
+                <a:gd name="csX4" fmla="*/ 1433949 w 2233750"/>
+                <a:gd name="csY4" fmla="*/ 1781201 h 2444602"/>
+                <a:gd name="csX5" fmla="*/ 731578 w 2233750"/>
+                <a:gd name="csY5" fmla="*/ 2402052 h 2444602"/>
+                <a:gd name="csX6" fmla="*/ 492060 w 2233750"/>
+                <a:gd name="csY6" fmla="*/ 2387296 h 2444602"/>
+                <a:gd name="csX7" fmla="*/ 42550 w 2233750"/>
+                <a:gd name="csY7" fmla="*/ 1878764 h 2444602"/>
+                <a:gd name="csX8" fmla="*/ 57306 w 2233750"/>
+                <a:gd name="csY8" fmla="*/ 1639246 h 2444602"/>
+                <a:gd name="csX9" fmla="*/ 571490 w 2233750"/>
+                <a:gd name="csY9" fmla="*/ 1184740 h 2444602"/>
+                <a:gd name="csX10" fmla="*/ 571490 w 2233750"/>
+                <a:gd name="csY10" fmla="*/ 277049 h 2444602"/>
+                <a:gd name="csX11" fmla="*/ 848539 w 2233750"/>
+                <a:gd name="csY11" fmla="*/ 0 h 2444602"/>
+                <a:gd name="csX12" fmla="*/ 1956701 w 2233750"/>
+                <a:gd name="csY12" fmla="*/ 0 h 2444602"/>
+                <a:gd name="csX13" fmla="*/ 2152604 w 2233750"/>
+                <a:gd name="csY13" fmla="*/ 81146 h 2444602"/>
+              </a:gdLst>
+              <a:ahLst/>
+              <a:cxnLst>
+                <a:cxn ang="0">
+                  <a:pos x="csX0" y="csY0"/>
+                </a:cxn>
+                <a:cxn ang="0">
+                  <a:pos x="csX1" y="csY1"/>
+                </a:cxn>
+                <a:cxn ang="0">
+                  <a:pos x="csX2" y="csY2"/>
+                </a:cxn>
+                <a:cxn ang="0">
+                  <a:pos x="csX3" y="csY3"/>
+                </a:cxn>
+                <a:cxn ang="0">
+                  <a:pos x="csX4" y="csY4"/>
+                </a:cxn>
+                <a:cxn ang="0">
+                  <a:pos x="csX5" y="csY5"/>
+                </a:cxn>
+                <a:cxn ang="0">
+                  <a:pos x="csX6" y="csY6"/>
+                </a:cxn>
+                <a:cxn ang="0">
+                  <a:pos x="csX7" y="csY7"/>
+                </a:cxn>
+                <a:cxn ang="0">
+                  <a:pos x="csX8" y="csY8"/>
+                </a:cxn>
+                <a:cxn ang="0">
+                  <a:pos x="csX9" y="csY9"/>
+                </a:cxn>
+                <a:cxn ang="0">
+                  <a:pos x="csX10" y="csY10"/>
+                </a:cxn>
+                <a:cxn ang="0">
+                  <a:pos x="csX11" y="csY11"/>
+                </a:cxn>
+                <a:cxn ang="0">
+                  <a:pos x="csX12" y="csY12"/>
+                </a:cxn>
+                <a:cxn ang="0">
+                  <a:pos x="csX13" y="csY13"/>
+                </a:cxn>
+              </a:cxnLst>
+              <a:rect l="l" t="t" r="r" b="b"/>
+              <a:pathLst>
+                <a:path w="2233750" h="2444602">
+                  <a:moveTo>
+                    <a:pt x="2152604" y="81146"/>
+                  </a:moveTo>
+                  <a:cubicBezTo>
+                    <a:pt x="2202740" y="131282"/>
+                    <a:pt x="2233750" y="200544"/>
+                    <a:pt x="2233750" y="277049"/>
+                  </a:cubicBezTo>
+                  <a:lnTo>
+                    <a:pt x="2233750" y="1504152"/>
+                  </a:lnTo>
+                  <a:cubicBezTo>
+                    <a:pt x="2233750" y="1657162"/>
+                    <a:pt x="2109711" y="1781201"/>
+                    <a:pt x="1956701" y="1781201"/>
+                  </a:cubicBezTo>
+                  <a:lnTo>
+                    <a:pt x="1433949" y="1781201"/>
+                  </a:lnTo>
+                  <a:lnTo>
+                    <a:pt x="731578" y="2402052"/>
+                  </a:lnTo>
+                  <a:cubicBezTo>
+                    <a:pt x="661362" y="2464118"/>
+                    <a:pt x="554126" y="2457512"/>
+                    <a:pt x="492060" y="2387296"/>
+                  </a:cubicBezTo>
+                  <a:lnTo>
+                    <a:pt x="42550" y="1878764"/>
+                  </a:lnTo>
+                  <a:cubicBezTo>
+                    <a:pt x="-19516" y="1808548"/>
+                    <a:pt x="-12910" y="1701312"/>
+                    <a:pt x="57306" y="1639246"/>
+                  </a:cubicBezTo>
+                  <a:lnTo>
+                    <a:pt x="571490" y="1184740"/>
+                  </a:lnTo>
+                  <a:lnTo>
+                    <a:pt x="571490" y="277049"/>
+                  </a:lnTo>
+                  <a:cubicBezTo>
+                    <a:pt x="571490" y="124039"/>
+                    <a:pt x="695529" y="0"/>
+                    <a:pt x="848539" y="0"/>
+                  </a:cubicBezTo>
+                  <a:lnTo>
+                    <a:pt x="1956701" y="0"/>
+                  </a:lnTo>
+                  <a:cubicBezTo>
+                    <a:pt x="2033206" y="0"/>
+                    <a:pt x="2102468" y="31010"/>
+                    <a:pt x="2152604" y="81146"/>
+                  </a:cubicBezTo>
+                  <a:close/>
+                </a:path>
+              </a:pathLst>
+            </a:custGeom>
+            <a:solidFill>
+              <a:schemeClr val="bg2">
+                <a:lumMod val="75000"/>
+              </a:schemeClr>
+            </a:solidFill>
+            <a:ln>
+              <a:noFill/>
+            </a:ln>
+          </p:spPr>
+          <p:style>
+            <a:lnRef idx="2">
+              <a:schemeClr val="accent1">
+                <a:shade val="15000"/>
+              </a:schemeClr>
+            </a:lnRef>
+            <a:fillRef idx="1">
+              <a:schemeClr val="accent1"/>
+            </a:fillRef>
+            <a:effectRef idx="0">
+              <a:schemeClr val="accent1"/>
+            </a:effectRef>
+            <a:fontRef idx="minor">
+              <a:schemeClr val="lt1"/>
+            </a:fontRef>
+          </p:style>
+          <p:txBody>
+            <a:bodyPr wrap="square" rtlCol="0" anchor="ctr">
+              <a:noAutofit/>
+            </a:bodyPr>
+            <a:lstStyle/>
+            <a:p>
+              <a:pPr algn="ctr"/>
+              <a:endParaRPr lang="en-US"/>
+            </a:p>
+          </p:txBody>
+        </p:sp>
+        <p:grpSp>
+          <p:nvGrpSpPr>
+            <p:cNvPr id="26" name="Gruppieren 25">
+              <a:extLst>
+                <a:ext uri="{FF2B5EF4-FFF2-40B4-BE49-F238E27FC236}">
+                  <a16:creationId xmlns:a16="http://schemas.microsoft.com/office/drawing/2014/main" id="{E902CB1B-43D0-234E-4880-DEC13819BAF0}"/>
+                </a:ext>
+              </a:extLst>
+            </p:cNvPr>
+            <p:cNvGrpSpPr/>
             <p:nvPr/>
           </p:nvGrpSpPr>
           <p:grpSpPr>
             <a:xfrm>
-              <a:off x="4882478" y="2238426"/>
-              <a:ext cx="2427044" cy="2381148"/>
+              <a:off x="4348757" y="1658235"/>
+              <a:ext cx="3494487" cy="2429130"/>
               <a:chOff x="4348757" y="1658235"/>
-              <a:chExt cx="3494487" cy="3428406"/>
+              <a:chExt cx="3494487" cy="2429130"/>
             </a:xfrm>
+            <a:solidFill>
+              <a:schemeClr val="bg1"/>
+            </a:solidFill>
           </p:grpSpPr>
           <p:sp>
             <p:nvSpPr>
-              <p:cNvPr id="22" name="Freihandform: Form 21">
+              <p:cNvPr id="27" name="Ellipse 26">
                 <a:extLst>
                   <a:ext uri="{FF2B5EF4-FFF2-40B4-BE49-F238E27FC236}">
-                    <a16:creationId xmlns:a16="http://schemas.microsoft.com/office/drawing/2014/main" id="{9EAA24F4-3BFA-931E-944F-73B14B5F5A86}"/>
+                    <a16:creationId xmlns:a16="http://schemas.microsoft.com/office/drawing/2014/main" id="{E53F4ACF-FBC8-1086-4E1E-AF19623D4405}"/>
                   </a:ext>
                 </a:extLst>
               </p:cNvPr>
@@ -6375,153 +8577,14 @@
               <p:nvPr/>
             </p:nvSpPr>
             <p:spPr>
-              <a:xfrm rot="18880689">
-                <a:off x="4917910" y="2747465"/>
-                <a:ext cx="2233750" cy="2444602"/>
+              <a:xfrm>
+                <a:off x="4833972" y="2874297"/>
+                <a:ext cx="1093509" cy="1213068"/>
               </a:xfrm>
-              <a:custGeom>
+              <a:prstGeom prst="ellipse">
                 <a:avLst/>
-                <a:gdLst>
-                  <a:gd name="csX0" fmla="*/ 2152604 w 2233750"/>
-                  <a:gd name="csY0" fmla="*/ 81146 h 2444602"/>
-                  <a:gd name="csX1" fmla="*/ 2233750 w 2233750"/>
-                  <a:gd name="csY1" fmla="*/ 277049 h 2444602"/>
-                  <a:gd name="csX2" fmla="*/ 2233750 w 2233750"/>
-                  <a:gd name="csY2" fmla="*/ 1504152 h 2444602"/>
-                  <a:gd name="csX3" fmla="*/ 1956701 w 2233750"/>
-                  <a:gd name="csY3" fmla="*/ 1781201 h 2444602"/>
-                  <a:gd name="csX4" fmla="*/ 1433949 w 2233750"/>
-                  <a:gd name="csY4" fmla="*/ 1781201 h 2444602"/>
-                  <a:gd name="csX5" fmla="*/ 731578 w 2233750"/>
-                  <a:gd name="csY5" fmla="*/ 2402052 h 2444602"/>
-                  <a:gd name="csX6" fmla="*/ 492060 w 2233750"/>
-                  <a:gd name="csY6" fmla="*/ 2387296 h 2444602"/>
-                  <a:gd name="csX7" fmla="*/ 42550 w 2233750"/>
-                  <a:gd name="csY7" fmla="*/ 1878764 h 2444602"/>
-                  <a:gd name="csX8" fmla="*/ 57306 w 2233750"/>
-                  <a:gd name="csY8" fmla="*/ 1639246 h 2444602"/>
-                  <a:gd name="csX9" fmla="*/ 571490 w 2233750"/>
-                  <a:gd name="csY9" fmla="*/ 1184740 h 2444602"/>
-                  <a:gd name="csX10" fmla="*/ 571490 w 2233750"/>
-                  <a:gd name="csY10" fmla="*/ 277049 h 2444602"/>
-                  <a:gd name="csX11" fmla="*/ 848539 w 2233750"/>
-                  <a:gd name="csY11" fmla="*/ 0 h 2444602"/>
-                  <a:gd name="csX12" fmla="*/ 1956701 w 2233750"/>
-                  <a:gd name="csY12" fmla="*/ 0 h 2444602"/>
-                  <a:gd name="csX13" fmla="*/ 2152604 w 2233750"/>
-                  <a:gd name="csY13" fmla="*/ 81146 h 2444602"/>
-                </a:gdLst>
-                <a:ahLst/>
-                <a:cxnLst>
-                  <a:cxn ang="0">
-                    <a:pos x="csX0" y="csY0"/>
-                  </a:cxn>
-                  <a:cxn ang="0">
-                    <a:pos x="csX1" y="csY1"/>
-                  </a:cxn>
-                  <a:cxn ang="0">
-                    <a:pos x="csX2" y="csY2"/>
-                  </a:cxn>
-                  <a:cxn ang="0">
-                    <a:pos x="csX3" y="csY3"/>
-                  </a:cxn>
-                  <a:cxn ang="0">
-                    <a:pos x="csX4" y="csY4"/>
-                  </a:cxn>
-                  <a:cxn ang="0">
-                    <a:pos x="csX5" y="csY5"/>
-                  </a:cxn>
-                  <a:cxn ang="0">
-                    <a:pos x="csX6" y="csY6"/>
-                  </a:cxn>
-                  <a:cxn ang="0">
-                    <a:pos x="csX7" y="csY7"/>
-                  </a:cxn>
-                  <a:cxn ang="0">
-                    <a:pos x="csX8" y="csY8"/>
-                  </a:cxn>
-                  <a:cxn ang="0">
-                    <a:pos x="csX9" y="csY9"/>
-                  </a:cxn>
-                  <a:cxn ang="0">
-                    <a:pos x="csX10" y="csY10"/>
-                  </a:cxn>
-                  <a:cxn ang="0">
-                    <a:pos x="csX11" y="csY11"/>
-                  </a:cxn>
-                  <a:cxn ang="0">
-                    <a:pos x="csX12" y="csY12"/>
-                  </a:cxn>
-                  <a:cxn ang="0">
-                    <a:pos x="csX13" y="csY13"/>
-                  </a:cxn>
-                </a:cxnLst>
-                <a:rect l="l" t="t" r="r" b="b"/>
-                <a:pathLst>
-                  <a:path w="2233750" h="2444602">
-                    <a:moveTo>
-                      <a:pt x="2152604" y="81146"/>
-                    </a:moveTo>
-                    <a:cubicBezTo>
-                      <a:pt x="2202740" y="131282"/>
-                      <a:pt x="2233750" y="200544"/>
-                      <a:pt x="2233750" y="277049"/>
-                    </a:cubicBezTo>
-                    <a:lnTo>
-                      <a:pt x="2233750" y="1504152"/>
-                    </a:lnTo>
-                    <a:cubicBezTo>
-                      <a:pt x="2233750" y="1657162"/>
-                      <a:pt x="2109711" y="1781201"/>
-                      <a:pt x="1956701" y="1781201"/>
-                    </a:cubicBezTo>
-                    <a:lnTo>
-                      <a:pt x="1433949" y="1781201"/>
-                    </a:lnTo>
-                    <a:lnTo>
-                      <a:pt x="731578" y="2402052"/>
-                    </a:lnTo>
-                    <a:cubicBezTo>
-                      <a:pt x="661362" y="2464118"/>
-                      <a:pt x="554126" y="2457512"/>
-                      <a:pt x="492060" y="2387296"/>
-                    </a:cubicBezTo>
-                    <a:lnTo>
-                      <a:pt x="42550" y="1878764"/>
-                    </a:lnTo>
-                    <a:cubicBezTo>
-                      <a:pt x="-19516" y="1808548"/>
-                      <a:pt x="-12910" y="1701312"/>
-                      <a:pt x="57306" y="1639246"/>
-                    </a:cubicBezTo>
-                    <a:lnTo>
-                      <a:pt x="571490" y="1184740"/>
-                    </a:lnTo>
-                    <a:lnTo>
-                      <a:pt x="571490" y="277049"/>
-                    </a:lnTo>
-                    <a:cubicBezTo>
-                      <a:pt x="571490" y="124039"/>
-                      <a:pt x="695529" y="0"/>
-                      <a:pt x="848539" y="0"/>
-                    </a:cubicBezTo>
-                    <a:lnTo>
-                      <a:pt x="1956701" y="0"/>
-                    </a:lnTo>
-                    <a:cubicBezTo>
-                      <a:pt x="2033206" y="0"/>
-                      <a:pt x="2102468" y="31010"/>
-                      <a:pt x="2152604" y="81146"/>
-                    </a:cubicBezTo>
-                    <a:close/>
-                  </a:path>
-                </a:pathLst>
-              </a:custGeom>
-              <a:solidFill>
-                <a:schemeClr val="bg2">
-                  <a:lumMod val="75000"/>
-                </a:schemeClr>
-              </a:solidFill>
+              </a:prstGeom>
+              <a:grpFill/>
               <a:ln>
                 <a:noFill/>
               </a:ln>
@@ -6543,9 +8606,7 @@
               </a:fontRef>
             </p:style>
             <p:txBody>
-              <a:bodyPr wrap="square" rtlCol="0" anchor="ctr">
-                <a:noAutofit/>
-              </a:bodyPr>
+              <a:bodyPr rtlCol="0" anchor="ctr"/>
               <a:lstStyle/>
               <a:p>
                 <a:pPr algn="ctr"/>
@@ -6553,536 +8614,12 @@
               </a:p>
             </p:txBody>
           </p:sp>
-          <p:grpSp>
-            <p:nvGrpSpPr>
-              <p:cNvPr id="26" name="Gruppieren 25">
+          <p:sp>
+            <p:nvSpPr>
+              <p:cNvPr id="28" name="Ellipse 27">
                 <a:extLst>
                   <a:ext uri="{FF2B5EF4-FFF2-40B4-BE49-F238E27FC236}">
-                    <a16:creationId xmlns:a16="http://schemas.microsoft.com/office/drawing/2014/main" id="{D5F8CB99-FA14-6E7F-9691-2148CAB2EAE1}"/>
-                  </a:ext>
-                </a:extLst>
-              </p:cNvPr>
-              <p:cNvGrpSpPr/>
-              <p:nvPr/>
-            </p:nvGrpSpPr>
-            <p:grpSpPr>
-              <a:xfrm>
-                <a:off x="4348757" y="1658235"/>
-                <a:ext cx="3494487" cy="2429130"/>
-                <a:chOff x="4348757" y="1658235"/>
-                <a:chExt cx="3494487" cy="2429130"/>
-              </a:xfrm>
-              <a:solidFill>
-                <a:schemeClr val="bg1"/>
-              </a:solidFill>
-            </p:grpSpPr>
-            <p:sp>
-              <p:nvSpPr>
-                <p:cNvPr id="27" name="Ellipse 26">
-                  <a:extLst>
-                    <a:ext uri="{FF2B5EF4-FFF2-40B4-BE49-F238E27FC236}">
-                      <a16:creationId xmlns:a16="http://schemas.microsoft.com/office/drawing/2014/main" id="{CCA4935F-5AD3-DA1D-F061-110E9482D382}"/>
-                    </a:ext>
-                  </a:extLst>
-                </p:cNvPr>
-                <p:cNvSpPr/>
-                <p:nvPr/>
-              </p:nvSpPr>
-              <p:spPr>
-                <a:xfrm>
-                  <a:off x="4833972" y="2874297"/>
-                  <a:ext cx="1093509" cy="1213068"/>
-                </a:xfrm>
-                <a:prstGeom prst="ellipse">
-                  <a:avLst/>
-                </a:prstGeom>
-                <a:grpFill/>
-                <a:ln>
-                  <a:noFill/>
-                </a:ln>
-              </p:spPr>
-              <p:style>
-                <a:lnRef idx="2">
-                  <a:schemeClr val="accent1">
-                    <a:shade val="15000"/>
-                  </a:schemeClr>
-                </a:lnRef>
-                <a:fillRef idx="1">
-                  <a:schemeClr val="accent1"/>
-                </a:fillRef>
-                <a:effectRef idx="0">
-                  <a:schemeClr val="accent1"/>
-                </a:effectRef>
-                <a:fontRef idx="minor">
-                  <a:schemeClr val="lt1"/>
-                </a:fontRef>
-              </p:style>
-              <p:txBody>
-                <a:bodyPr rtlCol="0" anchor="ctr"/>
-                <a:lstStyle/>
-                <a:p>
-                  <a:pPr algn="ctr"/>
-                  <a:endParaRPr lang="en-US"/>
-                </a:p>
-              </p:txBody>
-            </p:sp>
-            <p:sp>
-              <p:nvSpPr>
-                <p:cNvPr id="28" name="Ellipse 27">
-                  <a:extLst>
-                    <a:ext uri="{FF2B5EF4-FFF2-40B4-BE49-F238E27FC236}">
-                      <a16:creationId xmlns:a16="http://schemas.microsoft.com/office/drawing/2014/main" id="{AFBA8B64-1E96-F05D-9319-E12E398D499C}"/>
-                    </a:ext>
-                  </a:extLst>
-                </p:cNvPr>
-                <p:cNvSpPr/>
-                <p:nvPr/>
-              </p:nvSpPr>
-              <p:spPr>
-                <a:xfrm>
-                  <a:off x="4348757" y="2827162"/>
-                  <a:ext cx="895013" cy="978969"/>
-                </a:xfrm>
-                <a:prstGeom prst="ellipse">
-                  <a:avLst/>
-                </a:prstGeom>
-                <a:grpFill/>
-                <a:ln>
-                  <a:noFill/>
-                </a:ln>
-              </p:spPr>
-              <p:style>
-                <a:lnRef idx="2">
-                  <a:schemeClr val="accent1">
-                    <a:shade val="15000"/>
-                  </a:schemeClr>
-                </a:lnRef>
-                <a:fillRef idx="1">
-                  <a:schemeClr val="accent1"/>
-                </a:fillRef>
-                <a:effectRef idx="0">
-                  <a:schemeClr val="accent1"/>
-                </a:effectRef>
-                <a:fontRef idx="minor">
-                  <a:schemeClr val="lt1"/>
-                </a:fontRef>
-              </p:style>
-              <p:txBody>
-                <a:bodyPr rtlCol="0" anchor="ctr"/>
-                <a:lstStyle/>
-                <a:p>
-                  <a:pPr algn="ctr"/>
-                  <a:endParaRPr lang="en-US"/>
-                </a:p>
-              </p:txBody>
-            </p:sp>
-            <p:sp>
-              <p:nvSpPr>
-                <p:cNvPr id="29" name="Ellipse 28">
-                  <a:extLst>
-                    <a:ext uri="{FF2B5EF4-FFF2-40B4-BE49-F238E27FC236}">
-                      <a16:creationId xmlns:a16="http://schemas.microsoft.com/office/drawing/2014/main" id="{290E99AE-E33B-DDF5-0161-47E31271D164}"/>
-                    </a:ext>
-                  </a:extLst>
-                </p:cNvPr>
-                <p:cNvSpPr/>
-                <p:nvPr/>
-              </p:nvSpPr>
-              <p:spPr>
-                <a:xfrm>
-                  <a:off x="4523417" y="2216729"/>
-                  <a:ext cx="895013" cy="978969"/>
-                </a:xfrm>
-                <a:prstGeom prst="ellipse">
-                  <a:avLst/>
-                </a:prstGeom>
-                <a:grpFill/>
-                <a:ln>
-                  <a:noFill/>
-                </a:ln>
-              </p:spPr>
-              <p:style>
-                <a:lnRef idx="2">
-                  <a:schemeClr val="accent1">
-                    <a:shade val="15000"/>
-                  </a:schemeClr>
-                </a:lnRef>
-                <a:fillRef idx="1">
-                  <a:schemeClr val="accent1"/>
-                </a:fillRef>
-                <a:effectRef idx="0">
-                  <a:schemeClr val="accent1"/>
-                </a:effectRef>
-                <a:fontRef idx="minor">
-                  <a:schemeClr val="lt1"/>
-                </a:fontRef>
-              </p:style>
-              <p:txBody>
-                <a:bodyPr rtlCol="0" anchor="ctr"/>
-                <a:lstStyle/>
-                <a:p>
-                  <a:pPr algn="ctr"/>
-                  <a:endParaRPr lang="en-US"/>
-                </a:p>
-              </p:txBody>
-            </p:sp>
-            <p:sp>
-              <p:nvSpPr>
-                <p:cNvPr id="30" name="Ellipse 29">
-                  <a:extLst>
-                    <a:ext uri="{FF2B5EF4-FFF2-40B4-BE49-F238E27FC236}">
-                      <a16:creationId xmlns:a16="http://schemas.microsoft.com/office/drawing/2014/main" id="{F18D8D3E-C78C-94E1-521D-1DA420607E3A}"/>
-                    </a:ext>
-                  </a:extLst>
-                </p:cNvPr>
-                <p:cNvSpPr/>
-                <p:nvPr/>
-              </p:nvSpPr>
-              <p:spPr>
-                <a:xfrm>
-                  <a:off x="5139472" y="1658235"/>
-                  <a:ext cx="1447888" cy="1213068"/>
-                </a:xfrm>
-                <a:prstGeom prst="ellipse">
-                  <a:avLst/>
-                </a:prstGeom>
-                <a:grpFill/>
-                <a:ln>
-                  <a:noFill/>
-                </a:ln>
-              </p:spPr>
-              <p:style>
-                <a:lnRef idx="2">
-                  <a:schemeClr val="accent1">
-                    <a:shade val="15000"/>
-                  </a:schemeClr>
-                </a:lnRef>
-                <a:fillRef idx="1">
-                  <a:schemeClr val="accent1"/>
-                </a:fillRef>
-                <a:effectRef idx="0">
-                  <a:schemeClr val="accent1"/>
-                </a:effectRef>
-                <a:fontRef idx="minor">
-                  <a:schemeClr val="lt1"/>
-                </a:fontRef>
-              </p:style>
-              <p:txBody>
-                <a:bodyPr rtlCol="0" anchor="ctr"/>
-                <a:lstStyle/>
-                <a:p>
-                  <a:pPr algn="ctr"/>
-                  <a:endParaRPr lang="en-US"/>
-                </a:p>
-              </p:txBody>
-            </p:sp>
-            <p:sp>
-              <p:nvSpPr>
-                <p:cNvPr id="31" name="Ellipse 30">
-                  <a:extLst>
-                    <a:ext uri="{FF2B5EF4-FFF2-40B4-BE49-F238E27FC236}">
-                      <a16:creationId xmlns:a16="http://schemas.microsoft.com/office/drawing/2014/main" id="{2B6BC96E-0378-F7EE-FC79-5B85229664E6}"/>
-                    </a:ext>
-                  </a:extLst>
-                </p:cNvPr>
-                <p:cNvSpPr/>
-                <p:nvPr/>
-              </p:nvSpPr>
-              <p:spPr>
-                <a:xfrm>
-                  <a:off x="6166303" y="1874525"/>
-                  <a:ext cx="1093509" cy="978969"/>
-                </a:xfrm>
-                <a:prstGeom prst="ellipse">
-                  <a:avLst/>
-                </a:prstGeom>
-                <a:grpFill/>
-                <a:ln>
-                  <a:noFill/>
-                </a:ln>
-              </p:spPr>
-              <p:style>
-                <a:lnRef idx="2">
-                  <a:schemeClr val="accent1">
-                    <a:shade val="15000"/>
-                  </a:schemeClr>
-                </a:lnRef>
-                <a:fillRef idx="1">
-                  <a:schemeClr val="accent1"/>
-                </a:fillRef>
-                <a:effectRef idx="0">
-                  <a:schemeClr val="accent1"/>
-                </a:effectRef>
-                <a:fontRef idx="minor">
-                  <a:schemeClr val="lt1"/>
-                </a:fontRef>
-              </p:style>
-              <p:txBody>
-                <a:bodyPr rtlCol="0" anchor="ctr"/>
-                <a:lstStyle/>
-                <a:p>
-                  <a:pPr algn="ctr"/>
-                  <a:endParaRPr lang="en-US"/>
-                </a:p>
-              </p:txBody>
-            </p:sp>
-            <p:sp>
-              <p:nvSpPr>
-                <p:cNvPr id="32" name="Ellipse 31">
-                  <a:extLst>
-                    <a:ext uri="{FF2B5EF4-FFF2-40B4-BE49-F238E27FC236}">
-                      <a16:creationId xmlns:a16="http://schemas.microsoft.com/office/drawing/2014/main" id="{1907DB48-CA1F-9970-08AD-D9DBE35B4A4D}"/>
-                    </a:ext>
-                  </a:extLst>
-                </p:cNvPr>
-                <p:cNvSpPr/>
-                <p:nvPr/>
-              </p:nvSpPr>
-              <p:spPr>
-                <a:xfrm>
-                  <a:off x="6685338" y="2280470"/>
-                  <a:ext cx="947871" cy="978969"/>
-                </a:xfrm>
-                <a:prstGeom prst="ellipse">
-                  <a:avLst/>
-                </a:prstGeom>
-                <a:grpFill/>
-                <a:ln>
-                  <a:noFill/>
-                </a:ln>
-              </p:spPr>
-              <p:style>
-                <a:lnRef idx="2">
-                  <a:schemeClr val="accent1">
-                    <a:shade val="15000"/>
-                  </a:schemeClr>
-                </a:lnRef>
-                <a:fillRef idx="1">
-                  <a:schemeClr val="accent1"/>
-                </a:fillRef>
-                <a:effectRef idx="0">
-                  <a:schemeClr val="accent1"/>
-                </a:effectRef>
-                <a:fontRef idx="minor">
-                  <a:schemeClr val="lt1"/>
-                </a:fontRef>
-              </p:style>
-              <p:txBody>
-                <a:bodyPr rtlCol="0" anchor="ctr"/>
-                <a:lstStyle/>
-                <a:p>
-                  <a:pPr algn="ctr"/>
-                  <a:endParaRPr lang="en-US"/>
-                </a:p>
-              </p:txBody>
-            </p:sp>
-            <p:sp>
-              <p:nvSpPr>
-                <p:cNvPr id="33" name="Ellipse 32">
-                  <a:extLst>
-                    <a:ext uri="{FF2B5EF4-FFF2-40B4-BE49-F238E27FC236}">
-                      <a16:creationId xmlns:a16="http://schemas.microsoft.com/office/drawing/2014/main" id="{3A183CB8-056A-5468-F9F1-42804CF21F7F}"/>
-                    </a:ext>
-                  </a:extLst>
-                </p:cNvPr>
-                <p:cNvSpPr/>
-                <p:nvPr/>
-              </p:nvSpPr>
-              <p:spPr>
-                <a:xfrm>
-                  <a:off x="6895373" y="2815788"/>
-                  <a:ext cx="947871" cy="978969"/>
-                </a:xfrm>
-                <a:prstGeom prst="ellipse">
-                  <a:avLst/>
-                </a:prstGeom>
-                <a:grpFill/>
-                <a:ln>
-                  <a:noFill/>
-                </a:ln>
-              </p:spPr>
-              <p:style>
-                <a:lnRef idx="2">
-                  <a:schemeClr val="accent1">
-                    <a:shade val="15000"/>
-                  </a:schemeClr>
-                </a:lnRef>
-                <a:fillRef idx="1">
-                  <a:schemeClr val="accent1"/>
-                </a:fillRef>
-                <a:effectRef idx="0">
-                  <a:schemeClr val="accent1"/>
-                </a:effectRef>
-                <a:fontRef idx="minor">
-                  <a:schemeClr val="lt1"/>
-                </a:fontRef>
-              </p:style>
-              <p:txBody>
-                <a:bodyPr rtlCol="0" anchor="ctr"/>
-                <a:lstStyle/>
-                <a:p>
-                  <a:pPr algn="ctr"/>
-                  <a:endParaRPr lang="en-US"/>
-                </a:p>
-              </p:txBody>
-            </p:sp>
-            <p:sp>
-              <p:nvSpPr>
-                <p:cNvPr id="34" name="Ellipse 33">
-                  <a:extLst>
-                    <a:ext uri="{FF2B5EF4-FFF2-40B4-BE49-F238E27FC236}">
-                      <a16:creationId xmlns:a16="http://schemas.microsoft.com/office/drawing/2014/main" id="{E5DFDAD7-0092-D85B-B7EC-7B7532FFCF05}"/>
-                    </a:ext>
-                  </a:extLst>
-                </p:cNvPr>
-                <p:cNvSpPr/>
-                <p:nvPr/>
-              </p:nvSpPr>
-              <p:spPr>
-                <a:xfrm>
-                  <a:off x="6447064" y="3074692"/>
-                  <a:ext cx="947871" cy="978969"/>
-                </a:xfrm>
-                <a:prstGeom prst="ellipse">
-                  <a:avLst/>
-                </a:prstGeom>
-                <a:grpFill/>
-                <a:ln>
-                  <a:noFill/>
-                </a:ln>
-              </p:spPr>
-              <p:style>
-                <a:lnRef idx="2">
-                  <a:schemeClr val="accent1">
-                    <a:shade val="15000"/>
-                  </a:schemeClr>
-                </a:lnRef>
-                <a:fillRef idx="1">
-                  <a:schemeClr val="accent1"/>
-                </a:fillRef>
-                <a:effectRef idx="0">
-                  <a:schemeClr val="accent1"/>
-                </a:effectRef>
-                <a:fontRef idx="minor">
-                  <a:schemeClr val="lt1"/>
-                </a:fontRef>
-              </p:style>
-              <p:txBody>
-                <a:bodyPr rtlCol="0" anchor="ctr"/>
-                <a:lstStyle/>
-                <a:p>
-                  <a:pPr algn="ctr"/>
-                  <a:endParaRPr lang="en-US"/>
-                </a:p>
-              </p:txBody>
-            </p:sp>
-            <p:sp>
-              <p:nvSpPr>
-                <p:cNvPr id="35" name="Ellipse 34">
-                  <a:extLst>
-                    <a:ext uri="{FF2B5EF4-FFF2-40B4-BE49-F238E27FC236}">
-                      <a16:creationId xmlns:a16="http://schemas.microsoft.com/office/drawing/2014/main" id="{B07877F7-5231-4458-875E-586A55856418}"/>
-                    </a:ext>
-                  </a:extLst>
-                </p:cNvPr>
-                <p:cNvSpPr/>
-                <p:nvPr/>
-              </p:nvSpPr>
-              <p:spPr>
-                <a:xfrm>
-                  <a:off x="5967792" y="2548129"/>
-                  <a:ext cx="947871" cy="978969"/>
-                </a:xfrm>
-                <a:prstGeom prst="ellipse">
-                  <a:avLst/>
-                </a:prstGeom>
-                <a:grpFill/>
-                <a:ln>
-                  <a:noFill/>
-                </a:ln>
-              </p:spPr>
-              <p:style>
-                <a:lnRef idx="2">
-                  <a:schemeClr val="accent1">
-                    <a:shade val="15000"/>
-                  </a:schemeClr>
-                </a:lnRef>
-                <a:fillRef idx="1">
-                  <a:schemeClr val="accent1"/>
-                </a:fillRef>
-                <a:effectRef idx="0">
-                  <a:schemeClr val="accent1"/>
-                </a:effectRef>
-                <a:fontRef idx="minor">
-                  <a:schemeClr val="lt1"/>
-                </a:fontRef>
-              </p:style>
-              <p:txBody>
-                <a:bodyPr rtlCol="0" anchor="ctr"/>
-                <a:lstStyle/>
-                <a:p>
-                  <a:pPr algn="ctr"/>
-                  <a:endParaRPr lang="en-US"/>
-                </a:p>
-              </p:txBody>
-            </p:sp>
-            <p:sp>
-              <p:nvSpPr>
-                <p:cNvPr id="36" name="Ellipse 35">
-                  <a:extLst>
-                    <a:ext uri="{FF2B5EF4-FFF2-40B4-BE49-F238E27FC236}">
-                      <a16:creationId xmlns:a16="http://schemas.microsoft.com/office/drawing/2014/main" id="{31D155ED-3B0B-D27D-19FA-632DF6F9799D}"/>
-                    </a:ext>
-                  </a:extLst>
-                </p:cNvPr>
-                <p:cNvSpPr/>
-                <p:nvPr/>
-              </p:nvSpPr>
-              <p:spPr>
-                <a:xfrm>
-                  <a:off x="5259186" y="2426730"/>
-                  <a:ext cx="1201277" cy="1156099"/>
-                </a:xfrm>
-                <a:prstGeom prst="ellipse">
-                  <a:avLst/>
-                </a:prstGeom>
-                <a:grpFill/>
-                <a:ln>
-                  <a:noFill/>
-                </a:ln>
-              </p:spPr>
-              <p:style>
-                <a:lnRef idx="2">
-                  <a:schemeClr val="accent1">
-                    <a:shade val="15000"/>
-                  </a:schemeClr>
-                </a:lnRef>
-                <a:fillRef idx="1">
-                  <a:schemeClr val="accent1"/>
-                </a:fillRef>
-                <a:effectRef idx="0">
-                  <a:schemeClr val="accent1"/>
-                </a:effectRef>
-                <a:fontRef idx="minor">
-                  <a:schemeClr val="lt1"/>
-                </a:fontRef>
-              </p:style>
-              <p:txBody>
-                <a:bodyPr rtlCol="0" anchor="ctr"/>
-                <a:lstStyle/>
-                <a:p>
-                  <a:pPr algn="ctr"/>
-                  <a:endParaRPr lang="en-US"/>
-                </a:p>
-              </p:txBody>
-            </p:sp>
-          </p:grpSp>
-          <p:sp>
-            <p:nvSpPr>
-              <p:cNvPr id="37" name="Bogen 36">
-                <a:extLst>
-                  <a:ext uri="{FF2B5EF4-FFF2-40B4-BE49-F238E27FC236}">
-                    <a16:creationId xmlns:a16="http://schemas.microsoft.com/office/drawing/2014/main" id="{663D166C-93CB-BC78-E71C-718D68D2EF0E}"/>
+                    <a16:creationId xmlns:a16="http://schemas.microsoft.com/office/drawing/2014/main" id="{5116C4D0-B5B2-17AA-E33D-AD597D4CA10A}"/>
                   </a:ext>
                 </a:extLst>
               </p:cNvPr>
@@ -7091,33 +8628,31 @@
             </p:nvSpPr>
             <p:spPr>
               <a:xfrm>
-                <a:off x="6492051" y="3087567"/>
-                <a:ext cx="858514" cy="978969"/>
+                <a:off x="4348757" y="2827162"/>
+                <a:ext cx="895013" cy="978969"/>
               </a:xfrm>
-              <a:prstGeom prst="arc">
-                <a:avLst>
-                  <a:gd name="adj1" fmla="val 15703901"/>
-                  <a:gd name="adj2" fmla="val 317033"/>
-                </a:avLst>
+              <a:prstGeom prst="ellipse">
+                <a:avLst/>
               </a:prstGeom>
-              <a:ln w="76200">
-                <a:solidFill>
-                  <a:schemeClr val="tx1"/>
-                </a:solidFill>
+              <a:grpFill/>
+              <a:ln>
+                <a:noFill/>
               </a:ln>
             </p:spPr>
             <p:style>
               <a:lnRef idx="2">
-                <a:schemeClr val="accent1"/>
+                <a:schemeClr val="accent1">
+                  <a:shade val="15000"/>
+                </a:schemeClr>
               </a:lnRef>
-              <a:fillRef idx="0">
+              <a:fillRef idx="1">
                 <a:schemeClr val="accent1"/>
               </a:fillRef>
-              <a:effectRef idx="1">
+              <a:effectRef idx="0">
                 <a:schemeClr val="accent1"/>
               </a:effectRef>
               <a:fontRef idx="minor">
-                <a:schemeClr val="tx1"/>
+                <a:schemeClr val="lt1"/>
               </a:fontRef>
             </p:style>
             <p:txBody>
@@ -7131,10 +8666,10 @@
           </p:sp>
           <p:sp>
             <p:nvSpPr>
-              <p:cNvPr id="38" name="Bogen 37">
+              <p:cNvPr id="29" name="Ellipse 28">
                 <a:extLst>
                   <a:ext uri="{FF2B5EF4-FFF2-40B4-BE49-F238E27FC236}">
-                    <a16:creationId xmlns:a16="http://schemas.microsoft.com/office/drawing/2014/main" id="{828A6962-07B2-6FA4-99A0-A74AA24DB048}"/>
+                    <a16:creationId xmlns:a16="http://schemas.microsoft.com/office/drawing/2014/main" id="{C61E8356-5E71-5820-F39B-05E89BF921D1}"/>
                   </a:ext>
                 </a:extLst>
               </p:cNvPr>
@@ -7143,33 +8678,31 @@
             </p:nvSpPr>
             <p:spPr>
               <a:xfrm>
-                <a:off x="5735049" y="2434333"/>
-                <a:ext cx="1212348" cy="1213069"/>
+                <a:off x="4523417" y="2216729"/>
+                <a:ext cx="895013" cy="978969"/>
               </a:xfrm>
-              <a:prstGeom prst="arc">
-                <a:avLst>
-                  <a:gd name="adj1" fmla="val 16200000"/>
-                  <a:gd name="adj2" fmla="val 20761643"/>
-                </a:avLst>
+              <a:prstGeom prst="ellipse">
+                <a:avLst/>
               </a:prstGeom>
-              <a:ln w="76200">
-                <a:solidFill>
-                  <a:schemeClr val="tx1"/>
-                </a:solidFill>
+              <a:grpFill/>
+              <a:ln>
+                <a:noFill/>
               </a:ln>
             </p:spPr>
             <p:style>
               <a:lnRef idx="2">
-                <a:schemeClr val="accent1"/>
+                <a:schemeClr val="accent1">
+                  <a:shade val="15000"/>
+                </a:schemeClr>
               </a:lnRef>
-              <a:fillRef idx="0">
+              <a:fillRef idx="1">
                 <a:schemeClr val="accent1"/>
               </a:fillRef>
-              <a:effectRef idx="1">
+              <a:effectRef idx="0">
                 <a:schemeClr val="accent1"/>
               </a:effectRef>
               <a:fontRef idx="minor">
-                <a:schemeClr val="tx1"/>
+                <a:schemeClr val="lt1"/>
               </a:fontRef>
             </p:style>
             <p:txBody>
@@ -7183,10 +8716,10 @@
           </p:sp>
           <p:sp>
             <p:nvSpPr>
-              <p:cNvPr id="39" name="Bogen 38">
+              <p:cNvPr id="30" name="Ellipse 29">
                 <a:extLst>
                   <a:ext uri="{FF2B5EF4-FFF2-40B4-BE49-F238E27FC236}">
-                    <a16:creationId xmlns:a16="http://schemas.microsoft.com/office/drawing/2014/main" id="{33A82913-01EE-1A48-2F94-94671F35E51B}"/>
+                    <a16:creationId xmlns:a16="http://schemas.microsoft.com/office/drawing/2014/main" id="{C4C5232C-430E-7E08-9966-C92438A6836E}"/>
                   </a:ext>
                 </a:extLst>
               </p:cNvPr>
@@ -7195,30 +8728,331 @@
             </p:nvSpPr>
             <p:spPr>
               <a:xfrm>
-                <a:off x="4946771" y="2999004"/>
-                <a:ext cx="946872" cy="906562"/>
+                <a:off x="5139472" y="1658235"/>
+                <a:ext cx="1447888" cy="1213068"/>
               </a:xfrm>
-              <a:prstGeom prst="arc">
+              <a:prstGeom prst="ellipse">
                 <a:avLst/>
               </a:prstGeom>
-              <a:ln w="76200">
-                <a:solidFill>
-                  <a:schemeClr val="tx1"/>
-                </a:solidFill>
+              <a:grpFill/>
+              <a:ln>
+                <a:noFill/>
               </a:ln>
             </p:spPr>
             <p:style>
               <a:lnRef idx="2">
-                <a:schemeClr val="accent1"/>
+                <a:schemeClr val="accent1">
+                  <a:shade val="15000"/>
+                </a:schemeClr>
               </a:lnRef>
-              <a:fillRef idx="0">
+              <a:fillRef idx="1">
                 <a:schemeClr val="accent1"/>
               </a:fillRef>
-              <a:effectRef idx="1">
+              <a:effectRef idx="0">
                 <a:schemeClr val="accent1"/>
               </a:effectRef>
               <a:fontRef idx="minor">
-                <a:schemeClr val="tx1"/>
+                <a:schemeClr val="lt1"/>
+              </a:fontRef>
+            </p:style>
+            <p:txBody>
+              <a:bodyPr rtlCol="0" anchor="ctr"/>
+              <a:lstStyle/>
+              <a:p>
+                <a:pPr algn="ctr"/>
+                <a:endParaRPr lang="en-US"/>
+              </a:p>
+            </p:txBody>
+          </p:sp>
+          <p:sp>
+            <p:nvSpPr>
+              <p:cNvPr id="31" name="Ellipse 30">
+                <a:extLst>
+                  <a:ext uri="{FF2B5EF4-FFF2-40B4-BE49-F238E27FC236}">
+                    <a16:creationId xmlns:a16="http://schemas.microsoft.com/office/drawing/2014/main" id="{0164066C-F1A6-9572-8D92-17D4C0264B88}"/>
+                  </a:ext>
+                </a:extLst>
+              </p:cNvPr>
+              <p:cNvSpPr/>
+              <p:nvPr/>
+            </p:nvSpPr>
+            <p:spPr>
+              <a:xfrm>
+                <a:off x="6166303" y="1874525"/>
+                <a:ext cx="1093509" cy="978969"/>
+              </a:xfrm>
+              <a:prstGeom prst="ellipse">
+                <a:avLst/>
+              </a:prstGeom>
+              <a:grpFill/>
+              <a:ln>
+                <a:noFill/>
+              </a:ln>
+            </p:spPr>
+            <p:style>
+              <a:lnRef idx="2">
+                <a:schemeClr val="accent1">
+                  <a:shade val="15000"/>
+                </a:schemeClr>
+              </a:lnRef>
+              <a:fillRef idx="1">
+                <a:schemeClr val="accent1"/>
+              </a:fillRef>
+              <a:effectRef idx="0">
+                <a:schemeClr val="accent1"/>
+              </a:effectRef>
+              <a:fontRef idx="minor">
+                <a:schemeClr val="lt1"/>
+              </a:fontRef>
+            </p:style>
+            <p:txBody>
+              <a:bodyPr rtlCol="0" anchor="ctr"/>
+              <a:lstStyle/>
+              <a:p>
+                <a:pPr algn="ctr"/>
+                <a:endParaRPr lang="en-US"/>
+              </a:p>
+            </p:txBody>
+          </p:sp>
+          <p:sp>
+            <p:nvSpPr>
+              <p:cNvPr id="32" name="Ellipse 31">
+                <a:extLst>
+                  <a:ext uri="{FF2B5EF4-FFF2-40B4-BE49-F238E27FC236}">
+                    <a16:creationId xmlns:a16="http://schemas.microsoft.com/office/drawing/2014/main" id="{FE2B43E2-250C-02E5-E85C-B4389D7B0DD0}"/>
+                  </a:ext>
+                </a:extLst>
+              </p:cNvPr>
+              <p:cNvSpPr/>
+              <p:nvPr/>
+            </p:nvSpPr>
+            <p:spPr>
+              <a:xfrm>
+                <a:off x="6685338" y="2280470"/>
+                <a:ext cx="947871" cy="978969"/>
+              </a:xfrm>
+              <a:prstGeom prst="ellipse">
+                <a:avLst/>
+              </a:prstGeom>
+              <a:grpFill/>
+              <a:ln>
+                <a:noFill/>
+              </a:ln>
+            </p:spPr>
+            <p:style>
+              <a:lnRef idx="2">
+                <a:schemeClr val="accent1">
+                  <a:shade val="15000"/>
+                </a:schemeClr>
+              </a:lnRef>
+              <a:fillRef idx="1">
+                <a:schemeClr val="accent1"/>
+              </a:fillRef>
+              <a:effectRef idx="0">
+                <a:schemeClr val="accent1"/>
+              </a:effectRef>
+              <a:fontRef idx="minor">
+                <a:schemeClr val="lt1"/>
+              </a:fontRef>
+            </p:style>
+            <p:txBody>
+              <a:bodyPr rtlCol="0" anchor="ctr"/>
+              <a:lstStyle/>
+              <a:p>
+                <a:pPr algn="ctr"/>
+                <a:endParaRPr lang="en-US"/>
+              </a:p>
+            </p:txBody>
+          </p:sp>
+          <p:sp>
+            <p:nvSpPr>
+              <p:cNvPr id="33" name="Ellipse 32">
+                <a:extLst>
+                  <a:ext uri="{FF2B5EF4-FFF2-40B4-BE49-F238E27FC236}">
+                    <a16:creationId xmlns:a16="http://schemas.microsoft.com/office/drawing/2014/main" id="{A27140AA-8FA9-9B61-DC1B-5037CDC45A93}"/>
+                  </a:ext>
+                </a:extLst>
+              </p:cNvPr>
+              <p:cNvSpPr/>
+              <p:nvPr/>
+            </p:nvSpPr>
+            <p:spPr>
+              <a:xfrm>
+                <a:off x="6895373" y="2815788"/>
+                <a:ext cx="947871" cy="978969"/>
+              </a:xfrm>
+              <a:prstGeom prst="ellipse">
+                <a:avLst/>
+              </a:prstGeom>
+              <a:grpFill/>
+              <a:ln>
+                <a:noFill/>
+              </a:ln>
+            </p:spPr>
+            <p:style>
+              <a:lnRef idx="2">
+                <a:schemeClr val="accent1">
+                  <a:shade val="15000"/>
+                </a:schemeClr>
+              </a:lnRef>
+              <a:fillRef idx="1">
+                <a:schemeClr val="accent1"/>
+              </a:fillRef>
+              <a:effectRef idx="0">
+                <a:schemeClr val="accent1"/>
+              </a:effectRef>
+              <a:fontRef idx="minor">
+                <a:schemeClr val="lt1"/>
+              </a:fontRef>
+            </p:style>
+            <p:txBody>
+              <a:bodyPr rtlCol="0" anchor="ctr"/>
+              <a:lstStyle/>
+              <a:p>
+                <a:pPr algn="ctr"/>
+                <a:endParaRPr lang="en-US"/>
+              </a:p>
+            </p:txBody>
+          </p:sp>
+          <p:sp>
+            <p:nvSpPr>
+              <p:cNvPr id="34" name="Ellipse 33">
+                <a:extLst>
+                  <a:ext uri="{FF2B5EF4-FFF2-40B4-BE49-F238E27FC236}">
+                    <a16:creationId xmlns:a16="http://schemas.microsoft.com/office/drawing/2014/main" id="{6A02383C-63CD-0200-27AF-A59E4423AF69}"/>
+                  </a:ext>
+                </a:extLst>
+              </p:cNvPr>
+              <p:cNvSpPr/>
+              <p:nvPr/>
+            </p:nvSpPr>
+            <p:spPr>
+              <a:xfrm>
+                <a:off x="6447064" y="3074692"/>
+                <a:ext cx="947871" cy="978969"/>
+              </a:xfrm>
+              <a:prstGeom prst="ellipse">
+                <a:avLst/>
+              </a:prstGeom>
+              <a:grpFill/>
+              <a:ln>
+                <a:noFill/>
+              </a:ln>
+            </p:spPr>
+            <p:style>
+              <a:lnRef idx="2">
+                <a:schemeClr val="accent1">
+                  <a:shade val="15000"/>
+                </a:schemeClr>
+              </a:lnRef>
+              <a:fillRef idx="1">
+                <a:schemeClr val="accent1"/>
+              </a:fillRef>
+              <a:effectRef idx="0">
+                <a:schemeClr val="accent1"/>
+              </a:effectRef>
+              <a:fontRef idx="minor">
+                <a:schemeClr val="lt1"/>
+              </a:fontRef>
+            </p:style>
+            <p:txBody>
+              <a:bodyPr rtlCol="0" anchor="ctr"/>
+              <a:lstStyle/>
+              <a:p>
+                <a:pPr algn="ctr"/>
+                <a:endParaRPr lang="en-US"/>
+              </a:p>
+            </p:txBody>
+          </p:sp>
+          <p:sp>
+            <p:nvSpPr>
+              <p:cNvPr id="35" name="Ellipse 34">
+                <a:extLst>
+                  <a:ext uri="{FF2B5EF4-FFF2-40B4-BE49-F238E27FC236}">
+                    <a16:creationId xmlns:a16="http://schemas.microsoft.com/office/drawing/2014/main" id="{8FC52E24-6425-0D1F-7D48-6075317C15D0}"/>
+                  </a:ext>
+                </a:extLst>
+              </p:cNvPr>
+              <p:cNvSpPr/>
+              <p:nvPr/>
+            </p:nvSpPr>
+            <p:spPr>
+              <a:xfrm>
+                <a:off x="5967792" y="2548129"/>
+                <a:ext cx="947871" cy="978969"/>
+              </a:xfrm>
+              <a:prstGeom prst="ellipse">
+                <a:avLst/>
+              </a:prstGeom>
+              <a:grpFill/>
+              <a:ln>
+                <a:noFill/>
+              </a:ln>
+            </p:spPr>
+            <p:style>
+              <a:lnRef idx="2">
+                <a:schemeClr val="accent1">
+                  <a:shade val="15000"/>
+                </a:schemeClr>
+              </a:lnRef>
+              <a:fillRef idx="1">
+                <a:schemeClr val="accent1"/>
+              </a:fillRef>
+              <a:effectRef idx="0">
+                <a:schemeClr val="accent1"/>
+              </a:effectRef>
+              <a:fontRef idx="minor">
+                <a:schemeClr val="lt1"/>
+              </a:fontRef>
+            </p:style>
+            <p:txBody>
+              <a:bodyPr rtlCol="0" anchor="ctr"/>
+              <a:lstStyle/>
+              <a:p>
+                <a:pPr algn="ctr"/>
+                <a:endParaRPr lang="en-US"/>
+              </a:p>
+            </p:txBody>
+          </p:sp>
+          <p:sp>
+            <p:nvSpPr>
+              <p:cNvPr id="36" name="Ellipse 35">
+                <a:extLst>
+                  <a:ext uri="{FF2B5EF4-FFF2-40B4-BE49-F238E27FC236}">
+                    <a16:creationId xmlns:a16="http://schemas.microsoft.com/office/drawing/2014/main" id="{E7F9E393-2819-8396-5782-34228141F531}"/>
+                  </a:ext>
+                </a:extLst>
+              </p:cNvPr>
+              <p:cNvSpPr/>
+              <p:nvPr/>
+            </p:nvSpPr>
+            <p:spPr>
+              <a:xfrm>
+                <a:off x="5259186" y="2426730"/>
+                <a:ext cx="1201277" cy="1156099"/>
+              </a:xfrm>
+              <a:prstGeom prst="ellipse">
+                <a:avLst/>
+              </a:prstGeom>
+              <a:grpFill/>
+              <a:ln>
+                <a:noFill/>
+              </a:ln>
+            </p:spPr>
+            <p:style>
+              <a:lnRef idx="2">
+                <a:schemeClr val="accent1">
+                  <a:shade val="15000"/>
+                </a:schemeClr>
+              </a:lnRef>
+              <a:fillRef idx="1">
+                <a:schemeClr val="accent1"/>
+              </a:fillRef>
+              <a:effectRef idx="0">
+                <a:schemeClr val="accent1"/>
+              </a:effectRef>
+              <a:fontRef idx="minor">
+                <a:schemeClr val="lt1"/>
               </a:fontRef>
             </p:style>
             <p:txBody>
@@ -7231,13 +9065,166 @@
             </p:txBody>
           </p:sp>
         </p:grpSp>
+        <p:sp>
+          <p:nvSpPr>
+            <p:cNvPr id="37" name="Bogen 36">
+              <a:extLst>
+                <a:ext uri="{FF2B5EF4-FFF2-40B4-BE49-F238E27FC236}">
+                  <a16:creationId xmlns:a16="http://schemas.microsoft.com/office/drawing/2014/main" id="{5065FDA5-EC03-F4A0-D7C4-0FD2A84BF8F5}"/>
+                </a:ext>
+              </a:extLst>
+            </p:cNvPr>
+            <p:cNvSpPr/>
+            <p:nvPr/>
+          </p:nvSpPr>
+          <p:spPr>
+            <a:xfrm>
+              <a:off x="6492051" y="3087567"/>
+              <a:ext cx="858514" cy="978969"/>
+            </a:xfrm>
+            <a:prstGeom prst="arc">
+              <a:avLst>
+                <a:gd name="adj1" fmla="val 15703901"/>
+                <a:gd name="adj2" fmla="val 317033"/>
+              </a:avLst>
+            </a:prstGeom>
+            <a:ln w="76200">
+              <a:solidFill>
+                <a:schemeClr val="tx1"/>
+              </a:solidFill>
+            </a:ln>
+          </p:spPr>
+          <p:style>
+            <a:lnRef idx="2">
+              <a:schemeClr val="accent1"/>
+            </a:lnRef>
+            <a:fillRef idx="0">
+              <a:schemeClr val="accent1"/>
+            </a:fillRef>
+            <a:effectRef idx="1">
+              <a:schemeClr val="accent1"/>
+            </a:effectRef>
+            <a:fontRef idx="minor">
+              <a:schemeClr val="tx1"/>
+            </a:fontRef>
+          </p:style>
+          <p:txBody>
+            <a:bodyPr rtlCol="0" anchor="ctr"/>
+            <a:lstStyle/>
+            <a:p>
+              <a:pPr algn="ctr"/>
+              <a:endParaRPr lang="en-US"/>
+            </a:p>
+          </p:txBody>
+        </p:sp>
+        <p:sp>
+          <p:nvSpPr>
+            <p:cNvPr id="38" name="Bogen 37">
+              <a:extLst>
+                <a:ext uri="{FF2B5EF4-FFF2-40B4-BE49-F238E27FC236}">
+                  <a16:creationId xmlns:a16="http://schemas.microsoft.com/office/drawing/2014/main" id="{C5C0E7B2-7E34-DCC5-DDD9-3F797E4C0876}"/>
+                </a:ext>
+              </a:extLst>
+            </p:cNvPr>
+            <p:cNvSpPr/>
+            <p:nvPr/>
+          </p:nvSpPr>
+          <p:spPr>
+            <a:xfrm>
+              <a:off x="5735049" y="2434333"/>
+              <a:ext cx="1212348" cy="1213069"/>
+            </a:xfrm>
+            <a:prstGeom prst="arc">
+              <a:avLst>
+                <a:gd name="adj1" fmla="val 16200000"/>
+                <a:gd name="adj2" fmla="val 20761643"/>
+              </a:avLst>
+            </a:prstGeom>
+            <a:ln w="76200">
+              <a:solidFill>
+                <a:schemeClr val="tx1"/>
+              </a:solidFill>
+            </a:ln>
+          </p:spPr>
+          <p:style>
+            <a:lnRef idx="2">
+              <a:schemeClr val="accent1"/>
+            </a:lnRef>
+            <a:fillRef idx="0">
+              <a:schemeClr val="accent1"/>
+            </a:fillRef>
+            <a:effectRef idx="1">
+              <a:schemeClr val="accent1"/>
+            </a:effectRef>
+            <a:fontRef idx="minor">
+              <a:schemeClr val="tx1"/>
+            </a:fontRef>
+          </p:style>
+          <p:txBody>
+            <a:bodyPr rtlCol="0" anchor="ctr"/>
+            <a:lstStyle/>
+            <a:p>
+              <a:pPr algn="ctr"/>
+              <a:endParaRPr lang="en-US"/>
+            </a:p>
+          </p:txBody>
+        </p:sp>
+        <p:sp>
+          <p:nvSpPr>
+            <p:cNvPr id="39" name="Bogen 38">
+              <a:extLst>
+                <a:ext uri="{FF2B5EF4-FFF2-40B4-BE49-F238E27FC236}">
+                  <a16:creationId xmlns:a16="http://schemas.microsoft.com/office/drawing/2014/main" id="{D7851A43-A8EC-783F-4149-F776E03A9647}"/>
+                </a:ext>
+              </a:extLst>
+            </p:cNvPr>
+            <p:cNvSpPr/>
+            <p:nvPr/>
+          </p:nvSpPr>
+          <p:spPr>
+            <a:xfrm>
+              <a:off x="4946771" y="2999004"/>
+              <a:ext cx="946872" cy="906562"/>
+            </a:xfrm>
+            <a:prstGeom prst="arc">
+              <a:avLst/>
+            </a:prstGeom>
+            <a:ln w="76200">
+              <a:solidFill>
+                <a:schemeClr val="tx1"/>
+              </a:solidFill>
+            </a:ln>
+          </p:spPr>
+          <p:style>
+            <a:lnRef idx="2">
+              <a:schemeClr val="accent1"/>
+            </a:lnRef>
+            <a:fillRef idx="0">
+              <a:schemeClr val="accent1"/>
+            </a:fillRef>
+            <a:effectRef idx="1">
+              <a:schemeClr val="accent1"/>
+            </a:effectRef>
+            <a:fontRef idx="minor">
+              <a:schemeClr val="tx1"/>
+            </a:fontRef>
+          </p:style>
+          <p:txBody>
+            <a:bodyPr rtlCol="0" anchor="ctr"/>
+            <a:lstStyle/>
+            <a:p>
+              <a:pPr algn="ctr"/>
+              <a:endParaRPr lang="en-US"/>
+            </a:p>
+          </p:txBody>
+        </p:sp>
       </p:grpSp>
       <p:sp>
         <p:nvSpPr>
           <p:cNvPr id="41" name="Textfeld 40">
             <a:extLst>
               <a:ext uri="{FF2B5EF4-FFF2-40B4-BE49-F238E27FC236}">
-                <a16:creationId xmlns:a16="http://schemas.microsoft.com/office/drawing/2014/main" id="{01773E8C-5336-89F3-3957-B661E5376FF8}"/>
+                <a16:creationId xmlns:a16="http://schemas.microsoft.com/office/drawing/2014/main" id="{60F9790F-88FC-345C-B20D-F9323E3555BE}"/>
               </a:ext>
             </a:extLst>
           </p:cNvPr>
@@ -7270,7 +9257,7 @@
     </p:spTree>
     <p:extLst>
       <p:ext uri="{BB962C8B-B14F-4D97-AF65-F5344CB8AC3E}">
-        <p14:creationId xmlns:p14="http://schemas.microsoft.com/office/powerpoint/2010/main" val="3030907397"/>
+        <p14:creationId xmlns:p14="http://schemas.microsoft.com/office/powerpoint/2010/main" val="3714031414"/>
       </p:ext>
     </p:extLst>
   </p:cSld>
@@ -7280,7 +9267,7 @@
 </p:sld>
 </file>
 
-<file path=ppt/slides/slide5.xml><?xml version="1.0" encoding="utf-8"?>
+<file path=ppt/slides/slide7.xml><?xml version="1.0" encoding="utf-8"?>
 <p:sld xmlns:a="http://schemas.openxmlformats.org/drawingml/2006/main" xmlns:r="http://schemas.openxmlformats.org/officeDocument/2006/relationships" xmlns:p="http://schemas.openxmlformats.org/presentationml/2006/main">
   <p:cSld>
     <p:spTree>
@@ -8400,7 +10387,7 @@
 </p:sld>
 </file>
 
-<file path=ppt/slides/slide6.xml><?xml version="1.0" encoding="utf-8"?>
+<file path=ppt/slides/slide8.xml><?xml version="1.0" encoding="utf-8"?>
 <p:sld xmlns:a="http://schemas.openxmlformats.org/drawingml/2006/main" xmlns:r="http://schemas.openxmlformats.org/officeDocument/2006/relationships" xmlns:p="http://schemas.openxmlformats.org/presentationml/2006/main">
   <p:cSld>
     <p:spTree>
@@ -8689,6 +10676,129 @@
     <p:extLst>
       <p:ext uri="{BB962C8B-B14F-4D97-AF65-F5344CB8AC3E}">
         <p14:creationId xmlns:p14="http://schemas.microsoft.com/office/powerpoint/2010/main" val="2374902956"/>
+      </p:ext>
+    </p:extLst>
+  </p:cSld>
+  <p:clrMapOvr>
+    <a:masterClrMapping/>
+  </p:clrMapOvr>
+</p:sld>
+</file>
+
+<file path=ppt/slides/slide9.xml><?xml version="1.0" encoding="utf-8"?>
+<p:sld xmlns:a="http://schemas.openxmlformats.org/drawingml/2006/main" xmlns:r="http://schemas.openxmlformats.org/officeDocument/2006/relationships" xmlns:p="http://schemas.openxmlformats.org/presentationml/2006/main">
+  <p:cSld>
+    <p:spTree>
+      <p:nvGrpSpPr>
+        <p:cNvPr id="1" name=""/>
+        <p:cNvGrpSpPr/>
+        <p:nvPr/>
+      </p:nvGrpSpPr>
+      <p:grpSpPr>
+        <a:xfrm>
+          <a:off x="0" y="0"/>
+          <a:ext cx="0" cy="0"/>
+          <a:chOff x="0" y="0"/>
+          <a:chExt cx="0" cy="0"/>
+        </a:xfrm>
+      </p:grpSpPr>
+      <p:grpSp>
+        <p:nvGrpSpPr>
+          <p:cNvPr id="15" name="Gruppieren 14">
+            <a:extLst>
+              <a:ext uri="{FF2B5EF4-FFF2-40B4-BE49-F238E27FC236}">
+                <a16:creationId xmlns:a16="http://schemas.microsoft.com/office/drawing/2014/main" id="{B5C84902-7ECC-508E-0880-0BCFFE91C348}"/>
+              </a:ext>
+            </a:extLst>
+          </p:cNvPr>
+          <p:cNvGrpSpPr/>
+          <p:nvPr/>
+        </p:nvGrpSpPr>
+        <p:grpSpPr>
+          <a:xfrm>
+            <a:off x="3178120" y="0"/>
+            <a:ext cx="6231825" cy="6858000"/>
+            <a:chOff x="3178120" y="0"/>
+            <a:chExt cx="6231825" cy="6858000"/>
+          </a:xfrm>
+        </p:grpSpPr>
+        <p:pic>
+          <p:nvPicPr>
+            <p:cNvPr id="7" name="Grafik 6">
+              <a:extLst>
+                <a:ext uri="{FF2B5EF4-FFF2-40B4-BE49-F238E27FC236}">
+                  <a16:creationId xmlns:a16="http://schemas.microsoft.com/office/drawing/2014/main" id="{70EF13CE-765F-E3DB-F344-6594D5828876}"/>
+                </a:ext>
+              </a:extLst>
+            </p:cNvPr>
+            <p:cNvPicPr>
+              <a:picLocks noChangeAspect="1"/>
+            </p:cNvPicPr>
+            <p:nvPr/>
+          </p:nvPicPr>
+          <p:blipFill>
+            <a:blip r:embed="rId2">
+              <a:extLst>
+                <a:ext uri="{28A0092B-C50C-407E-A947-70E740481C1C}">
+                  <a14:useLocalDpi xmlns:a14="http://schemas.microsoft.com/office/drawing/2010/main" val="0"/>
+                </a:ext>
+              </a:extLst>
+            </a:blip>
+            <a:stretch>
+              <a:fillRect/>
+            </a:stretch>
+          </p:blipFill>
+          <p:spPr>
+            <a:xfrm>
+              <a:off x="3178120" y="0"/>
+              <a:ext cx="3116346" cy="6858000"/>
+            </a:xfrm>
+            <a:prstGeom prst="rect">
+              <a:avLst/>
+            </a:prstGeom>
+          </p:spPr>
+        </p:pic>
+        <p:pic>
+          <p:nvPicPr>
+            <p:cNvPr id="14" name="Grafik 13">
+              <a:extLst>
+                <a:ext uri="{FF2B5EF4-FFF2-40B4-BE49-F238E27FC236}">
+                  <a16:creationId xmlns:a16="http://schemas.microsoft.com/office/drawing/2014/main" id="{299F9A69-8AA8-ADC3-BA81-310A9B5DEB46}"/>
+                </a:ext>
+              </a:extLst>
+            </p:cNvPr>
+            <p:cNvPicPr>
+              <a:picLocks noChangeAspect="1"/>
+            </p:cNvPicPr>
+            <p:nvPr/>
+          </p:nvPicPr>
+          <p:blipFill>
+            <a:blip r:embed="rId3">
+              <a:extLst>
+                <a:ext uri="{28A0092B-C50C-407E-A947-70E740481C1C}">
+                  <a14:useLocalDpi xmlns:a14="http://schemas.microsoft.com/office/drawing/2010/main" val="0"/>
+                </a:ext>
+              </a:extLst>
+            </a:blip>
+            <a:stretch>
+              <a:fillRect/>
+            </a:stretch>
+          </p:blipFill>
+          <p:spPr>
+            <a:xfrm>
+              <a:off x="6294465" y="0"/>
+              <a:ext cx="3115480" cy="6858000"/>
+            </a:xfrm>
+            <a:prstGeom prst="rect">
+              <a:avLst/>
+            </a:prstGeom>
+          </p:spPr>
+        </p:pic>
+      </p:grpSp>
+    </p:spTree>
+    <p:extLst>
+      <p:ext uri="{BB962C8B-B14F-4D97-AF65-F5344CB8AC3E}">
+        <p14:creationId xmlns:p14="http://schemas.microsoft.com/office/powerpoint/2010/main" val="3979895115"/>
       </p:ext>
     </p:extLst>
   </p:cSld>

</xml_diff>

<commit_message>
feat(addDish) & feat(swipeDishes): cleaned up UI & fixed buggy swiping
</commit_message>
<xml_diff>
--- a/App_Logo.pptx
+++ b/App_Logo.pptx
@@ -10,10 +10,11 @@
     <p:sldId id="262" r:id="rId4"/>
     <p:sldId id="259" r:id="rId5"/>
     <p:sldId id="260" r:id="rId6"/>
-    <p:sldId id="263" r:id="rId7"/>
-    <p:sldId id="261" r:id="rId8"/>
-    <p:sldId id="257" r:id="rId9"/>
-    <p:sldId id="264" r:id="rId10"/>
+    <p:sldId id="265" r:id="rId7"/>
+    <p:sldId id="263" r:id="rId8"/>
+    <p:sldId id="261" r:id="rId9"/>
+    <p:sldId id="257" r:id="rId10"/>
+    <p:sldId id="264" r:id="rId11"/>
   </p:sldIdLst>
   <p:sldSz cx="12192000" cy="6858000"/>
   <p:notesSz cx="6858000" cy="9144000"/>
@@ -269,7 +270,7 @@
           <a:p>
             <a:fld id="{DAE86DB9-DEFD-4D48-8EC1-A7DB55CC092E}" type="datetimeFigureOut">
               <a:rPr lang="en-US" smtClean="0"/>
-              <a:t>4/3/2026</a:t>
+              <a:t>4/4/2026</a:t>
             </a:fld>
             <a:endParaRPr lang="en-US"/>
           </a:p>
@@ -469,7 +470,7 @@
           <a:p>
             <a:fld id="{DAE86DB9-DEFD-4D48-8EC1-A7DB55CC092E}" type="datetimeFigureOut">
               <a:rPr lang="en-US" smtClean="0"/>
-              <a:t>4/3/2026</a:t>
+              <a:t>4/4/2026</a:t>
             </a:fld>
             <a:endParaRPr lang="en-US"/>
           </a:p>
@@ -679,7 +680,7 @@
           <a:p>
             <a:fld id="{DAE86DB9-DEFD-4D48-8EC1-A7DB55CC092E}" type="datetimeFigureOut">
               <a:rPr lang="en-US" smtClean="0"/>
-              <a:t>4/3/2026</a:t>
+              <a:t>4/4/2026</a:t>
             </a:fld>
             <a:endParaRPr lang="en-US"/>
           </a:p>
@@ -879,7 +880,7 @@
           <a:p>
             <a:fld id="{DAE86DB9-DEFD-4D48-8EC1-A7DB55CC092E}" type="datetimeFigureOut">
               <a:rPr lang="en-US" smtClean="0"/>
-              <a:t>4/3/2026</a:t>
+              <a:t>4/4/2026</a:t>
             </a:fld>
             <a:endParaRPr lang="en-US"/>
           </a:p>
@@ -1155,7 +1156,7 @@
           <a:p>
             <a:fld id="{DAE86DB9-DEFD-4D48-8EC1-A7DB55CC092E}" type="datetimeFigureOut">
               <a:rPr lang="en-US" smtClean="0"/>
-              <a:t>4/3/2026</a:t>
+              <a:t>4/4/2026</a:t>
             </a:fld>
             <a:endParaRPr lang="en-US"/>
           </a:p>
@@ -1423,7 +1424,7 @@
           <a:p>
             <a:fld id="{DAE86DB9-DEFD-4D48-8EC1-A7DB55CC092E}" type="datetimeFigureOut">
               <a:rPr lang="en-US" smtClean="0"/>
-              <a:t>4/3/2026</a:t>
+              <a:t>4/4/2026</a:t>
             </a:fld>
             <a:endParaRPr lang="en-US"/>
           </a:p>
@@ -1838,7 +1839,7 @@
           <a:p>
             <a:fld id="{DAE86DB9-DEFD-4D48-8EC1-A7DB55CC092E}" type="datetimeFigureOut">
               <a:rPr lang="en-US" smtClean="0"/>
-              <a:t>4/3/2026</a:t>
+              <a:t>4/4/2026</a:t>
             </a:fld>
             <a:endParaRPr lang="en-US"/>
           </a:p>
@@ -1980,7 +1981,7 @@
           <a:p>
             <a:fld id="{DAE86DB9-DEFD-4D48-8EC1-A7DB55CC092E}" type="datetimeFigureOut">
               <a:rPr lang="en-US" smtClean="0"/>
-              <a:t>4/3/2026</a:t>
+              <a:t>4/4/2026</a:t>
             </a:fld>
             <a:endParaRPr lang="en-US"/>
           </a:p>
@@ -2093,7 +2094,7 @@
           <a:p>
             <a:fld id="{DAE86DB9-DEFD-4D48-8EC1-A7DB55CC092E}" type="datetimeFigureOut">
               <a:rPr lang="en-US" smtClean="0"/>
-              <a:t>4/3/2026</a:t>
+              <a:t>4/4/2026</a:t>
             </a:fld>
             <a:endParaRPr lang="en-US"/>
           </a:p>
@@ -2406,7 +2407,7 @@
           <a:p>
             <a:fld id="{DAE86DB9-DEFD-4D48-8EC1-A7DB55CC092E}" type="datetimeFigureOut">
               <a:rPr lang="en-US" smtClean="0"/>
-              <a:t>4/3/2026</a:t>
+              <a:t>4/4/2026</a:t>
             </a:fld>
             <a:endParaRPr lang="en-US"/>
           </a:p>
@@ -2695,7 +2696,7 @@
           <a:p>
             <a:fld id="{DAE86DB9-DEFD-4D48-8EC1-A7DB55CC092E}" type="datetimeFigureOut">
               <a:rPr lang="en-US" smtClean="0"/>
-              <a:t>4/3/2026</a:t>
+              <a:t>4/4/2026</a:t>
             </a:fld>
             <a:endParaRPr lang="en-US"/>
           </a:p>
@@ -2938,7 +2939,7 @@
           <a:p>
             <a:fld id="{DAE86DB9-DEFD-4D48-8EC1-A7DB55CC092E}" type="datetimeFigureOut">
               <a:rPr lang="en-US" smtClean="0"/>
-              <a:t>4/3/2026</a:t>
+              <a:t>4/4/2026</a:t>
             </a:fld>
             <a:endParaRPr lang="en-US"/>
           </a:p>
@@ -4300,6 +4301,129 @@
     <p:extLst>
       <p:ext uri="{BB962C8B-B14F-4D97-AF65-F5344CB8AC3E}">
         <p14:creationId xmlns:p14="http://schemas.microsoft.com/office/powerpoint/2010/main" val="1847332711"/>
+      </p:ext>
+    </p:extLst>
+  </p:cSld>
+  <p:clrMapOvr>
+    <a:masterClrMapping/>
+  </p:clrMapOvr>
+</p:sld>
+</file>
+
+<file path=ppt/slides/slide10.xml><?xml version="1.0" encoding="utf-8"?>
+<p:sld xmlns:a="http://schemas.openxmlformats.org/drawingml/2006/main" xmlns:r="http://schemas.openxmlformats.org/officeDocument/2006/relationships" xmlns:p="http://schemas.openxmlformats.org/presentationml/2006/main">
+  <p:cSld>
+    <p:spTree>
+      <p:nvGrpSpPr>
+        <p:cNvPr id="1" name=""/>
+        <p:cNvGrpSpPr/>
+        <p:nvPr/>
+      </p:nvGrpSpPr>
+      <p:grpSpPr>
+        <a:xfrm>
+          <a:off x="0" y="0"/>
+          <a:ext cx="0" cy="0"/>
+          <a:chOff x="0" y="0"/>
+          <a:chExt cx="0" cy="0"/>
+        </a:xfrm>
+      </p:grpSpPr>
+      <p:grpSp>
+        <p:nvGrpSpPr>
+          <p:cNvPr id="15" name="Gruppieren 14">
+            <a:extLst>
+              <a:ext uri="{FF2B5EF4-FFF2-40B4-BE49-F238E27FC236}">
+                <a16:creationId xmlns:a16="http://schemas.microsoft.com/office/drawing/2014/main" id="{B5C84902-7ECC-508E-0880-0BCFFE91C348}"/>
+              </a:ext>
+            </a:extLst>
+          </p:cNvPr>
+          <p:cNvGrpSpPr/>
+          <p:nvPr/>
+        </p:nvGrpSpPr>
+        <p:grpSpPr>
+          <a:xfrm>
+            <a:off x="3178120" y="0"/>
+            <a:ext cx="6231825" cy="6858000"/>
+            <a:chOff x="3178120" y="0"/>
+            <a:chExt cx="6231825" cy="6858000"/>
+          </a:xfrm>
+        </p:grpSpPr>
+        <p:pic>
+          <p:nvPicPr>
+            <p:cNvPr id="7" name="Grafik 6">
+              <a:extLst>
+                <a:ext uri="{FF2B5EF4-FFF2-40B4-BE49-F238E27FC236}">
+                  <a16:creationId xmlns:a16="http://schemas.microsoft.com/office/drawing/2014/main" id="{70EF13CE-765F-E3DB-F344-6594D5828876}"/>
+                </a:ext>
+              </a:extLst>
+            </p:cNvPr>
+            <p:cNvPicPr>
+              <a:picLocks noChangeAspect="1"/>
+            </p:cNvPicPr>
+            <p:nvPr/>
+          </p:nvPicPr>
+          <p:blipFill>
+            <a:blip r:embed="rId2">
+              <a:extLst>
+                <a:ext uri="{28A0092B-C50C-407E-A947-70E740481C1C}">
+                  <a14:useLocalDpi xmlns:a14="http://schemas.microsoft.com/office/drawing/2010/main" val="0"/>
+                </a:ext>
+              </a:extLst>
+            </a:blip>
+            <a:stretch>
+              <a:fillRect/>
+            </a:stretch>
+          </p:blipFill>
+          <p:spPr>
+            <a:xfrm>
+              <a:off x="3178120" y="0"/>
+              <a:ext cx="3116346" cy="6858000"/>
+            </a:xfrm>
+            <a:prstGeom prst="rect">
+              <a:avLst/>
+            </a:prstGeom>
+          </p:spPr>
+        </p:pic>
+        <p:pic>
+          <p:nvPicPr>
+            <p:cNvPr id="14" name="Grafik 13">
+              <a:extLst>
+                <a:ext uri="{FF2B5EF4-FFF2-40B4-BE49-F238E27FC236}">
+                  <a16:creationId xmlns:a16="http://schemas.microsoft.com/office/drawing/2014/main" id="{299F9A69-8AA8-ADC3-BA81-310A9B5DEB46}"/>
+                </a:ext>
+              </a:extLst>
+            </p:cNvPr>
+            <p:cNvPicPr>
+              <a:picLocks noChangeAspect="1"/>
+            </p:cNvPicPr>
+            <p:nvPr/>
+          </p:nvPicPr>
+          <p:blipFill>
+            <a:blip r:embed="rId3">
+              <a:extLst>
+                <a:ext uri="{28A0092B-C50C-407E-A947-70E740481C1C}">
+                  <a14:useLocalDpi xmlns:a14="http://schemas.microsoft.com/office/drawing/2010/main" val="0"/>
+                </a:ext>
+              </a:extLst>
+            </a:blip>
+            <a:stretch>
+              <a:fillRect/>
+            </a:stretch>
+          </p:blipFill>
+          <p:spPr>
+            <a:xfrm>
+              <a:off x="6294465" y="0"/>
+              <a:ext cx="3115480" cy="6858000"/>
+            </a:xfrm>
+            <a:prstGeom prst="rect">
+              <a:avLst/>
+            </a:prstGeom>
+          </p:spPr>
+        </p:pic>
+      </p:grpSp>
+    </p:spTree>
+    <p:extLst>
+      <p:ext uri="{BB962C8B-B14F-4D97-AF65-F5344CB8AC3E}">
+        <p14:creationId xmlns:p14="http://schemas.microsoft.com/office/powerpoint/2010/main" val="3979895115"/>
       </p:ext>
     </p:extLst>
   </p:cSld>
@@ -7289,10 +7413,10 @@
       </p:sp>
       <p:grpSp>
         <p:nvGrpSpPr>
-          <p:cNvPr id="67" name="Gruppieren 66">
+          <p:cNvPr id="2" name="Gruppieren 1">
             <a:extLst>
               <a:ext uri="{FF2B5EF4-FFF2-40B4-BE49-F238E27FC236}">
-                <a16:creationId xmlns:a16="http://schemas.microsoft.com/office/drawing/2014/main" id="{19C0E5F3-440A-B413-D873-AF7EAE55DF41}"/>
+                <a16:creationId xmlns:a16="http://schemas.microsoft.com/office/drawing/2014/main" id="{3BF86F58-96DB-7BF1-C956-C16FF0811681}"/>
               </a:ext>
             </a:extLst>
           </p:cNvPr>
@@ -7329,20 +7453,9 @@
                 <a:gd name="adj" fmla="val 0"/>
               </a:avLst>
             </a:prstGeom>
-            <a:gradFill>
-              <a:gsLst>
-                <a:gs pos="0">
-                  <a:srgbClr val="262626"/>
-                </a:gs>
-                <a:gs pos="100000">
-                  <a:schemeClr val="tx1">
-                    <a:lumMod val="85000"/>
-                    <a:lumOff val="15000"/>
-                  </a:schemeClr>
-                </a:gs>
-              </a:gsLst>
-              <a:lin ang="5400000" scaled="1"/>
-            </a:gradFill>
+            <a:solidFill>
+              <a:schemeClr val="bg1"/>
+            </a:solidFill>
             <a:ln>
               <a:noFill/>
             </a:ln>
@@ -7528,7 +7641,7 @@
               </a:pathLst>
             </a:custGeom>
             <a:solidFill>
-              <a:srgbClr val="9FF62A"/>
+              <a:srgbClr val="92D050"/>
             </a:solidFill>
             <a:ln>
               <a:noFill/>
@@ -8252,6 +8365,1028 @@
 </file>
 
 <file path=ppt/slides/slide6.xml><?xml version="1.0" encoding="utf-8"?>
+<p:sld xmlns:a="http://schemas.openxmlformats.org/drawingml/2006/main" xmlns:r="http://schemas.openxmlformats.org/officeDocument/2006/relationships" xmlns:p="http://schemas.openxmlformats.org/presentationml/2006/main">
+  <p:cSld>
+    <p:spTree>
+      <p:nvGrpSpPr>
+        <p:cNvPr id="1" name="">
+          <a:extLst>
+            <a:ext uri="{FF2B5EF4-FFF2-40B4-BE49-F238E27FC236}">
+              <a16:creationId xmlns:a16="http://schemas.microsoft.com/office/drawing/2014/main" id="{D47D553C-8DFC-3FF0-A041-03F8EAD2ABB9}"/>
+            </a:ext>
+          </a:extLst>
+        </p:cNvPr>
+        <p:cNvGrpSpPr/>
+        <p:nvPr/>
+      </p:nvGrpSpPr>
+      <p:grpSpPr>
+        <a:xfrm>
+          <a:off x="0" y="0"/>
+          <a:ext cx="0" cy="0"/>
+          <a:chOff x="0" y="0"/>
+          <a:chExt cx="0" cy="0"/>
+        </a:xfrm>
+      </p:grpSpPr>
+      <p:sp>
+        <p:nvSpPr>
+          <p:cNvPr id="41" name="Textfeld 40">
+            <a:extLst>
+              <a:ext uri="{FF2B5EF4-FFF2-40B4-BE49-F238E27FC236}">
+                <a16:creationId xmlns:a16="http://schemas.microsoft.com/office/drawing/2014/main" id="{35A65E33-79C8-980C-7DE3-52F93FAC718A}"/>
+              </a:ext>
+            </a:extLst>
+          </p:cNvPr>
+          <p:cNvSpPr txBox="1"/>
+          <p:nvPr/>
+        </p:nvSpPr>
+        <p:spPr>
+          <a:xfrm>
+            <a:off x="414779" y="890393"/>
+            <a:ext cx="2116349" cy="369332"/>
+          </a:xfrm>
+          <a:prstGeom prst="rect">
+            <a:avLst/>
+          </a:prstGeom>
+          <a:noFill/>
+        </p:spPr>
+        <p:txBody>
+          <a:bodyPr wrap="none" rtlCol="0">
+            <a:spAutoFit/>
+          </a:bodyPr>
+          <a:lstStyle/>
+          <a:p>
+            <a:r>
+              <a:rPr lang="en-US"/>
+              <a:t>Splash Screen:dark</a:t>
+            </a:r>
+          </a:p>
+        </p:txBody>
+      </p:sp>
+      <p:grpSp>
+        <p:nvGrpSpPr>
+          <p:cNvPr id="67" name="Gruppieren 66">
+            <a:extLst>
+              <a:ext uri="{FF2B5EF4-FFF2-40B4-BE49-F238E27FC236}">
+                <a16:creationId xmlns:a16="http://schemas.microsoft.com/office/drawing/2014/main" id="{C7C55DAD-B215-5E32-2584-39ABB54ED2C8}"/>
+              </a:ext>
+            </a:extLst>
+          </p:cNvPr>
+          <p:cNvGrpSpPr/>
+          <p:nvPr/>
+        </p:nvGrpSpPr>
+        <p:grpSpPr>
+          <a:xfrm>
+            <a:off x="2676000" y="9000"/>
+            <a:ext cx="6840000" cy="6840000"/>
+            <a:chOff x="2676000" y="9000"/>
+            <a:chExt cx="6840000" cy="6840000"/>
+          </a:xfrm>
+        </p:grpSpPr>
+        <p:sp>
+          <p:nvSpPr>
+            <p:cNvPr id="6" name="Rechteck: abgerundete Ecken 5">
+              <a:extLst>
+                <a:ext uri="{FF2B5EF4-FFF2-40B4-BE49-F238E27FC236}">
+                  <a16:creationId xmlns:a16="http://schemas.microsoft.com/office/drawing/2014/main" id="{A36CFD09-71A0-7B58-2E8E-F3E5FC0B0FAC}"/>
+                </a:ext>
+              </a:extLst>
+            </p:cNvPr>
+            <p:cNvSpPr/>
+            <p:nvPr/>
+          </p:nvSpPr>
+          <p:spPr>
+            <a:xfrm>
+              <a:off x="2676000" y="9000"/>
+              <a:ext cx="6840000" cy="6840000"/>
+            </a:xfrm>
+            <a:prstGeom prst="roundRect">
+              <a:avLst>
+                <a:gd name="adj" fmla="val 0"/>
+              </a:avLst>
+            </a:prstGeom>
+            <a:gradFill>
+              <a:gsLst>
+                <a:gs pos="0">
+                  <a:srgbClr val="262626"/>
+                </a:gs>
+                <a:gs pos="100000">
+                  <a:schemeClr val="tx1">
+                    <a:lumMod val="85000"/>
+                    <a:lumOff val="15000"/>
+                  </a:schemeClr>
+                </a:gs>
+              </a:gsLst>
+              <a:lin ang="5400000" scaled="1"/>
+            </a:gradFill>
+            <a:ln>
+              <a:noFill/>
+            </a:ln>
+          </p:spPr>
+          <p:style>
+            <a:lnRef idx="2">
+              <a:schemeClr val="accent1">
+                <a:shade val="15000"/>
+              </a:schemeClr>
+            </a:lnRef>
+            <a:fillRef idx="1">
+              <a:schemeClr val="accent1"/>
+            </a:fillRef>
+            <a:effectRef idx="0">
+              <a:schemeClr val="accent1"/>
+            </a:effectRef>
+            <a:fontRef idx="minor">
+              <a:schemeClr val="lt1"/>
+            </a:fontRef>
+          </p:style>
+          <p:txBody>
+            <a:bodyPr rtlCol="0" anchor="ctr"/>
+            <a:lstStyle/>
+            <a:p>
+              <a:pPr algn="ctr"/>
+              <a:endParaRPr lang="en-US"/>
+            </a:p>
+          </p:txBody>
+        </p:sp>
+        <p:sp>
+          <p:nvSpPr>
+            <p:cNvPr id="51" name="Freihandform: Form 50">
+              <a:extLst>
+                <a:ext uri="{FF2B5EF4-FFF2-40B4-BE49-F238E27FC236}">
+                  <a16:creationId xmlns:a16="http://schemas.microsoft.com/office/drawing/2014/main" id="{48831D14-FCE0-DC2D-D6BB-B0C0845C9EF8}"/>
+                </a:ext>
+              </a:extLst>
+            </p:cNvPr>
+            <p:cNvSpPr/>
+            <p:nvPr/>
+          </p:nvSpPr>
+          <p:spPr>
+            <a:xfrm rot="18880689">
+              <a:off x="5345801" y="3050316"/>
+              <a:ext cx="1422436" cy="1556706"/>
+            </a:xfrm>
+            <a:custGeom>
+              <a:avLst/>
+              <a:gdLst>
+                <a:gd name="csX0" fmla="*/ 2152604 w 2233750"/>
+                <a:gd name="csY0" fmla="*/ 81146 h 2444602"/>
+                <a:gd name="csX1" fmla="*/ 2233750 w 2233750"/>
+                <a:gd name="csY1" fmla="*/ 277049 h 2444602"/>
+                <a:gd name="csX2" fmla="*/ 2233750 w 2233750"/>
+                <a:gd name="csY2" fmla="*/ 1504152 h 2444602"/>
+                <a:gd name="csX3" fmla="*/ 1956701 w 2233750"/>
+                <a:gd name="csY3" fmla="*/ 1781201 h 2444602"/>
+                <a:gd name="csX4" fmla="*/ 1433949 w 2233750"/>
+                <a:gd name="csY4" fmla="*/ 1781201 h 2444602"/>
+                <a:gd name="csX5" fmla="*/ 731578 w 2233750"/>
+                <a:gd name="csY5" fmla="*/ 2402052 h 2444602"/>
+                <a:gd name="csX6" fmla="*/ 492060 w 2233750"/>
+                <a:gd name="csY6" fmla="*/ 2387296 h 2444602"/>
+                <a:gd name="csX7" fmla="*/ 42550 w 2233750"/>
+                <a:gd name="csY7" fmla="*/ 1878764 h 2444602"/>
+                <a:gd name="csX8" fmla="*/ 57306 w 2233750"/>
+                <a:gd name="csY8" fmla="*/ 1639246 h 2444602"/>
+                <a:gd name="csX9" fmla="*/ 571490 w 2233750"/>
+                <a:gd name="csY9" fmla="*/ 1184740 h 2444602"/>
+                <a:gd name="csX10" fmla="*/ 571490 w 2233750"/>
+                <a:gd name="csY10" fmla="*/ 277049 h 2444602"/>
+                <a:gd name="csX11" fmla="*/ 848539 w 2233750"/>
+                <a:gd name="csY11" fmla="*/ 0 h 2444602"/>
+                <a:gd name="csX12" fmla="*/ 1956701 w 2233750"/>
+                <a:gd name="csY12" fmla="*/ 0 h 2444602"/>
+                <a:gd name="csX13" fmla="*/ 2152604 w 2233750"/>
+                <a:gd name="csY13" fmla="*/ 81146 h 2444602"/>
+              </a:gdLst>
+              <a:ahLst/>
+              <a:cxnLst>
+                <a:cxn ang="0">
+                  <a:pos x="csX0" y="csY0"/>
+                </a:cxn>
+                <a:cxn ang="0">
+                  <a:pos x="csX1" y="csY1"/>
+                </a:cxn>
+                <a:cxn ang="0">
+                  <a:pos x="csX2" y="csY2"/>
+                </a:cxn>
+                <a:cxn ang="0">
+                  <a:pos x="csX3" y="csY3"/>
+                </a:cxn>
+                <a:cxn ang="0">
+                  <a:pos x="csX4" y="csY4"/>
+                </a:cxn>
+                <a:cxn ang="0">
+                  <a:pos x="csX5" y="csY5"/>
+                </a:cxn>
+                <a:cxn ang="0">
+                  <a:pos x="csX6" y="csY6"/>
+                </a:cxn>
+                <a:cxn ang="0">
+                  <a:pos x="csX7" y="csY7"/>
+                </a:cxn>
+                <a:cxn ang="0">
+                  <a:pos x="csX8" y="csY8"/>
+                </a:cxn>
+                <a:cxn ang="0">
+                  <a:pos x="csX9" y="csY9"/>
+                </a:cxn>
+                <a:cxn ang="0">
+                  <a:pos x="csX10" y="csY10"/>
+                </a:cxn>
+                <a:cxn ang="0">
+                  <a:pos x="csX11" y="csY11"/>
+                </a:cxn>
+                <a:cxn ang="0">
+                  <a:pos x="csX12" y="csY12"/>
+                </a:cxn>
+                <a:cxn ang="0">
+                  <a:pos x="csX13" y="csY13"/>
+                </a:cxn>
+              </a:cxnLst>
+              <a:rect l="l" t="t" r="r" b="b"/>
+              <a:pathLst>
+                <a:path w="2233750" h="2444602">
+                  <a:moveTo>
+                    <a:pt x="2152604" y="81146"/>
+                  </a:moveTo>
+                  <a:cubicBezTo>
+                    <a:pt x="2202740" y="131282"/>
+                    <a:pt x="2233750" y="200544"/>
+                    <a:pt x="2233750" y="277049"/>
+                  </a:cubicBezTo>
+                  <a:lnTo>
+                    <a:pt x="2233750" y="1504152"/>
+                  </a:lnTo>
+                  <a:cubicBezTo>
+                    <a:pt x="2233750" y="1657162"/>
+                    <a:pt x="2109711" y="1781201"/>
+                    <a:pt x="1956701" y="1781201"/>
+                  </a:cubicBezTo>
+                  <a:lnTo>
+                    <a:pt x="1433949" y="1781201"/>
+                  </a:lnTo>
+                  <a:lnTo>
+                    <a:pt x="731578" y="2402052"/>
+                  </a:lnTo>
+                  <a:cubicBezTo>
+                    <a:pt x="661362" y="2464118"/>
+                    <a:pt x="554126" y="2457512"/>
+                    <a:pt x="492060" y="2387296"/>
+                  </a:cubicBezTo>
+                  <a:lnTo>
+                    <a:pt x="42550" y="1878764"/>
+                  </a:lnTo>
+                  <a:cubicBezTo>
+                    <a:pt x="-19516" y="1808548"/>
+                    <a:pt x="-12910" y="1701312"/>
+                    <a:pt x="57306" y="1639246"/>
+                  </a:cubicBezTo>
+                  <a:lnTo>
+                    <a:pt x="571490" y="1184740"/>
+                  </a:lnTo>
+                  <a:lnTo>
+                    <a:pt x="571490" y="277049"/>
+                  </a:lnTo>
+                  <a:cubicBezTo>
+                    <a:pt x="571490" y="124039"/>
+                    <a:pt x="695529" y="0"/>
+                    <a:pt x="848539" y="0"/>
+                  </a:cubicBezTo>
+                  <a:lnTo>
+                    <a:pt x="1956701" y="0"/>
+                  </a:lnTo>
+                  <a:cubicBezTo>
+                    <a:pt x="2033206" y="0"/>
+                    <a:pt x="2102468" y="31010"/>
+                    <a:pt x="2152604" y="81146"/>
+                  </a:cubicBezTo>
+                  <a:close/>
+                </a:path>
+              </a:pathLst>
+            </a:custGeom>
+            <a:solidFill>
+              <a:srgbClr val="9FF62A"/>
+            </a:solidFill>
+            <a:ln>
+              <a:noFill/>
+            </a:ln>
+          </p:spPr>
+          <p:style>
+            <a:lnRef idx="2">
+              <a:schemeClr val="accent1">
+                <a:shade val="15000"/>
+              </a:schemeClr>
+            </a:lnRef>
+            <a:fillRef idx="1">
+              <a:schemeClr val="accent1"/>
+            </a:fillRef>
+            <a:effectRef idx="0">
+              <a:schemeClr val="accent1"/>
+            </a:effectRef>
+            <a:fontRef idx="minor">
+              <a:schemeClr val="lt1"/>
+            </a:fontRef>
+          </p:style>
+          <p:txBody>
+            <a:bodyPr wrap="square" rtlCol="0" anchor="ctr">
+              <a:noAutofit/>
+            </a:bodyPr>
+            <a:lstStyle/>
+            <a:p>
+              <a:pPr algn="ctr"/>
+              <a:endParaRPr lang="en-US"/>
+            </a:p>
+          </p:txBody>
+        </p:sp>
+        <p:sp>
+          <p:nvSpPr>
+            <p:cNvPr id="53" name="Ellipse 52">
+              <a:extLst>
+                <a:ext uri="{FF2B5EF4-FFF2-40B4-BE49-F238E27FC236}">
+                  <a16:creationId xmlns:a16="http://schemas.microsoft.com/office/drawing/2014/main" id="{75304A05-FC89-17F3-FC6B-894A2D373749}"/>
+                </a:ext>
+              </a:extLst>
+            </p:cNvPr>
+            <p:cNvSpPr/>
+            <p:nvPr/>
+          </p:nvSpPr>
+          <p:spPr>
+            <a:xfrm>
+              <a:off x="5292350" y="3131082"/>
+              <a:ext cx="696339" cy="772473"/>
+            </a:xfrm>
+            <a:prstGeom prst="ellipse">
+              <a:avLst/>
+            </a:prstGeom>
+            <a:solidFill>
+              <a:schemeClr val="accent3"/>
+            </a:solidFill>
+            <a:ln>
+              <a:noFill/>
+            </a:ln>
+          </p:spPr>
+          <p:style>
+            <a:lnRef idx="2">
+              <a:schemeClr val="accent1">
+                <a:shade val="15000"/>
+              </a:schemeClr>
+            </a:lnRef>
+            <a:fillRef idx="1">
+              <a:schemeClr val="accent1"/>
+            </a:fillRef>
+            <a:effectRef idx="0">
+              <a:schemeClr val="accent1"/>
+            </a:effectRef>
+            <a:fontRef idx="minor">
+              <a:schemeClr val="lt1"/>
+            </a:fontRef>
+          </p:style>
+          <p:txBody>
+            <a:bodyPr rtlCol="0" anchor="ctr"/>
+            <a:lstStyle/>
+            <a:p>
+              <a:pPr algn="ctr"/>
+              <a:endParaRPr lang="en-US"/>
+            </a:p>
+          </p:txBody>
+        </p:sp>
+        <p:sp>
+          <p:nvSpPr>
+            <p:cNvPr id="54" name="Ellipse 53">
+              <a:extLst>
+                <a:ext uri="{FF2B5EF4-FFF2-40B4-BE49-F238E27FC236}">
+                  <a16:creationId xmlns:a16="http://schemas.microsoft.com/office/drawing/2014/main" id="{778454D9-1C49-8515-ED39-793D58F87BFA}"/>
+                </a:ext>
+              </a:extLst>
+            </p:cNvPr>
+            <p:cNvSpPr/>
+            <p:nvPr/>
+          </p:nvSpPr>
+          <p:spPr>
+            <a:xfrm>
+              <a:off x="4983368" y="3101067"/>
+              <a:ext cx="569938" cy="623401"/>
+            </a:xfrm>
+            <a:prstGeom prst="ellipse">
+              <a:avLst/>
+            </a:prstGeom>
+            <a:solidFill>
+              <a:schemeClr val="accent3"/>
+            </a:solidFill>
+            <a:ln>
+              <a:noFill/>
+            </a:ln>
+          </p:spPr>
+          <p:style>
+            <a:lnRef idx="2">
+              <a:schemeClr val="accent1">
+                <a:shade val="15000"/>
+              </a:schemeClr>
+            </a:lnRef>
+            <a:fillRef idx="1">
+              <a:schemeClr val="accent1"/>
+            </a:fillRef>
+            <a:effectRef idx="0">
+              <a:schemeClr val="accent1"/>
+            </a:effectRef>
+            <a:fontRef idx="minor">
+              <a:schemeClr val="lt1"/>
+            </a:fontRef>
+          </p:style>
+          <p:txBody>
+            <a:bodyPr rtlCol="0" anchor="ctr"/>
+            <a:lstStyle/>
+            <a:p>
+              <a:pPr algn="ctr"/>
+              <a:endParaRPr lang="en-US"/>
+            </a:p>
+          </p:txBody>
+        </p:sp>
+        <p:sp>
+          <p:nvSpPr>
+            <p:cNvPr id="55" name="Ellipse 54">
+              <a:extLst>
+                <a:ext uri="{FF2B5EF4-FFF2-40B4-BE49-F238E27FC236}">
+                  <a16:creationId xmlns:a16="http://schemas.microsoft.com/office/drawing/2014/main" id="{D1760E16-C8D2-96A0-1205-A6C3EA1BE5F2}"/>
+                </a:ext>
+              </a:extLst>
+            </p:cNvPr>
+            <p:cNvSpPr/>
+            <p:nvPr/>
+          </p:nvSpPr>
+          <p:spPr>
+            <a:xfrm>
+              <a:off x="5094590" y="2712347"/>
+              <a:ext cx="569938" cy="623401"/>
+            </a:xfrm>
+            <a:prstGeom prst="ellipse">
+              <a:avLst/>
+            </a:prstGeom>
+            <a:solidFill>
+              <a:schemeClr val="accent3"/>
+            </a:solidFill>
+            <a:ln>
+              <a:noFill/>
+            </a:ln>
+          </p:spPr>
+          <p:style>
+            <a:lnRef idx="2">
+              <a:schemeClr val="accent1">
+                <a:shade val="15000"/>
+              </a:schemeClr>
+            </a:lnRef>
+            <a:fillRef idx="1">
+              <a:schemeClr val="accent1"/>
+            </a:fillRef>
+            <a:effectRef idx="0">
+              <a:schemeClr val="accent1"/>
+            </a:effectRef>
+            <a:fontRef idx="minor">
+              <a:schemeClr val="lt1"/>
+            </a:fontRef>
+          </p:style>
+          <p:txBody>
+            <a:bodyPr rtlCol="0" anchor="ctr"/>
+            <a:lstStyle/>
+            <a:p>
+              <a:pPr algn="ctr"/>
+              <a:endParaRPr lang="en-US"/>
+            </a:p>
+          </p:txBody>
+        </p:sp>
+        <p:sp>
+          <p:nvSpPr>
+            <p:cNvPr id="56" name="Ellipse 55">
+              <a:extLst>
+                <a:ext uri="{FF2B5EF4-FFF2-40B4-BE49-F238E27FC236}">
+                  <a16:creationId xmlns:a16="http://schemas.microsoft.com/office/drawing/2014/main" id="{09DA5195-28FE-7EF6-1C6F-BB911B8F5700}"/>
+                </a:ext>
+              </a:extLst>
+            </p:cNvPr>
+            <p:cNvSpPr/>
+            <p:nvPr/>
+          </p:nvSpPr>
+          <p:spPr>
+            <a:xfrm>
+              <a:off x="5486890" y="2356702"/>
+              <a:ext cx="922005" cy="772473"/>
+            </a:xfrm>
+            <a:prstGeom prst="ellipse">
+              <a:avLst/>
+            </a:prstGeom>
+            <a:solidFill>
+              <a:schemeClr val="accent3"/>
+            </a:solidFill>
+            <a:ln>
+              <a:noFill/>
+            </a:ln>
+          </p:spPr>
+          <p:style>
+            <a:lnRef idx="2">
+              <a:schemeClr val="accent1">
+                <a:shade val="15000"/>
+              </a:schemeClr>
+            </a:lnRef>
+            <a:fillRef idx="1">
+              <a:schemeClr val="accent1"/>
+            </a:fillRef>
+            <a:effectRef idx="0">
+              <a:schemeClr val="accent1"/>
+            </a:effectRef>
+            <a:fontRef idx="minor">
+              <a:schemeClr val="lt1"/>
+            </a:fontRef>
+          </p:style>
+          <p:txBody>
+            <a:bodyPr rtlCol="0" anchor="ctr"/>
+            <a:lstStyle/>
+            <a:p>
+              <a:pPr algn="ctr"/>
+              <a:endParaRPr lang="en-US"/>
+            </a:p>
+          </p:txBody>
+        </p:sp>
+        <p:sp>
+          <p:nvSpPr>
+            <p:cNvPr id="57" name="Ellipse 56">
+              <a:extLst>
+                <a:ext uri="{FF2B5EF4-FFF2-40B4-BE49-F238E27FC236}">
+                  <a16:creationId xmlns:a16="http://schemas.microsoft.com/office/drawing/2014/main" id="{6131481D-8D32-6D99-A452-55B1DFBB30BB}"/>
+                </a:ext>
+              </a:extLst>
+            </p:cNvPr>
+            <p:cNvSpPr/>
+            <p:nvPr/>
+          </p:nvSpPr>
+          <p:spPr>
+            <a:xfrm>
+              <a:off x="6140769" y="2494434"/>
+              <a:ext cx="696339" cy="623401"/>
+            </a:xfrm>
+            <a:prstGeom prst="ellipse">
+              <a:avLst/>
+            </a:prstGeom>
+            <a:solidFill>
+              <a:schemeClr val="accent3"/>
+            </a:solidFill>
+            <a:ln>
+              <a:noFill/>
+            </a:ln>
+          </p:spPr>
+          <p:style>
+            <a:lnRef idx="2">
+              <a:schemeClr val="accent1">
+                <a:shade val="15000"/>
+              </a:schemeClr>
+            </a:lnRef>
+            <a:fillRef idx="1">
+              <a:schemeClr val="accent1"/>
+            </a:fillRef>
+            <a:effectRef idx="0">
+              <a:schemeClr val="accent1"/>
+            </a:effectRef>
+            <a:fontRef idx="minor">
+              <a:schemeClr val="lt1"/>
+            </a:fontRef>
+          </p:style>
+          <p:txBody>
+            <a:bodyPr rtlCol="0" anchor="ctr"/>
+            <a:lstStyle/>
+            <a:p>
+              <a:pPr algn="ctr"/>
+              <a:endParaRPr lang="en-US"/>
+            </a:p>
+          </p:txBody>
+        </p:sp>
+        <p:sp>
+          <p:nvSpPr>
+            <p:cNvPr id="58" name="Ellipse 57">
+              <a:extLst>
+                <a:ext uri="{FF2B5EF4-FFF2-40B4-BE49-F238E27FC236}">
+                  <a16:creationId xmlns:a16="http://schemas.microsoft.com/office/drawing/2014/main" id="{6E306D1F-AEF2-DC9E-BEE9-40D0BC212328}"/>
+                </a:ext>
+              </a:extLst>
+            </p:cNvPr>
+            <p:cNvSpPr/>
+            <p:nvPr/>
+          </p:nvSpPr>
+          <p:spPr>
+            <a:xfrm>
+              <a:off x="6471287" y="2752937"/>
+              <a:ext cx="603598" cy="623401"/>
+            </a:xfrm>
+            <a:prstGeom prst="ellipse">
+              <a:avLst/>
+            </a:prstGeom>
+            <a:solidFill>
+              <a:schemeClr val="accent3"/>
+            </a:solidFill>
+            <a:ln>
+              <a:noFill/>
+            </a:ln>
+          </p:spPr>
+          <p:style>
+            <a:lnRef idx="2">
+              <a:schemeClr val="accent1">
+                <a:shade val="15000"/>
+              </a:schemeClr>
+            </a:lnRef>
+            <a:fillRef idx="1">
+              <a:schemeClr val="accent1"/>
+            </a:fillRef>
+            <a:effectRef idx="0">
+              <a:schemeClr val="accent1"/>
+            </a:effectRef>
+            <a:fontRef idx="minor">
+              <a:schemeClr val="lt1"/>
+            </a:fontRef>
+          </p:style>
+          <p:txBody>
+            <a:bodyPr rtlCol="0" anchor="ctr"/>
+            <a:lstStyle/>
+            <a:p>
+              <a:pPr algn="ctr"/>
+              <a:endParaRPr lang="en-US"/>
+            </a:p>
+          </p:txBody>
+        </p:sp>
+        <p:sp>
+          <p:nvSpPr>
+            <p:cNvPr id="59" name="Ellipse 58">
+              <a:extLst>
+                <a:ext uri="{FF2B5EF4-FFF2-40B4-BE49-F238E27FC236}">
+                  <a16:creationId xmlns:a16="http://schemas.microsoft.com/office/drawing/2014/main" id="{183CF391-526F-9E3C-314F-EA3238A3FEC0}"/>
+                </a:ext>
+              </a:extLst>
+            </p:cNvPr>
+            <p:cNvSpPr/>
+            <p:nvPr/>
+          </p:nvSpPr>
+          <p:spPr>
+            <a:xfrm>
+              <a:off x="6605035" y="3093824"/>
+              <a:ext cx="603598" cy="623401"/>
+            </a:xfrm>
+            <a:prstGeom prst="ellipse">
+              <a:avLst/>
+            </a:prstGeom>
+            <a:solidFill>
+              <a:schemeClr val="accent3"/>
+            </a:solidFill>
+            <a:ln>
+              <a:noFill/>
+            </a:ln>
+          </p:spPr>
+          <p:style>
+            <a:lnRef idx="2">
+              <a:schemeClr val="accent1">
+                <a:shade val="15000"/>
+              </a:schemeClr>
+            </a:lnRef>
+            <a:fillRef idx="1">
+              <a:schemeClr val="accent1"/>
+            </a:fillRef>
+            <a:effectRef idx="0">
+              <a:schemeClr val="accent1"/>
+            </a:effectRef>
+            <a:fontRef idx="minor">
+              <a:schemeClr val="lt1"/>
+            </a:fontRef>
+          </p:style>
+          <p:txBody>
+            <a:bodyPr rtlCol="0" anchor="ctr"/>
+            <a:lstStyle/>
+            <a:p>
+              <a:pPr algn="ctr"/>
+              <a:endParaRPr lang="en-US"/>
+            </a:p>
+          </p:txBody>
+        </p:sp>
+        <p:sp>
+          <p:nvSpPr>
+            <p:cNvPr id="60" name="Ellipse 59">
+              <a:extLst>
+                <a:ext uri="{FF2B5EF4-FFF2-40B4-BE49-F238E27FC236}">
+                  <a16:creationId xmlns:a16="http://schemas.microsoft.com/office/drawing/2014/main" id="{9DDD41F4-6B5F-D8DB-22D6-701049F1770C}"/>
+                </a:ext>
+              </a:extLst>
+            </p:cNvPr>
+            <p:cNvSpPr/>
+            <p:nvPr/>
+          </p:nvSpPr>
+          <p:spPr>
+            <a:xfrm>
+              <a:off x="6319555" y="3258692"/>
+              <a:ext cx="603598" cy="623401"/>
+            </a:xfrm>
+            <a:prstGeom prst="ellipse">
+              <a:avLst/>
+            </a:prstGeom>
+            <a:solidFill>
+              <a:schemeClr val="accent3"/>
+            </a:solidFill>
+            <a:ln>
+              <a:noFill/>
+            </a:ln>
+          </p:spPr>
+          <p:style>
+            <a:lnRef idx="2">
+              <a:schemeClr val="accent1">
+                <a:shade val="15000"/>
+              </a:schemeClr>
+            </a:lnRef>
+            <a:fillRef idx="1">
+              <a:schemeClr val="accent1"/>
+            </a:fillRef>
+            <a:effectRef idx="0">
+              <a:schemeClr val="accent1"/>
+            </a:effectRef>
+            <a:fontRef idx="minor">
+              <a:schemeClr val="lt1"/>
+            </a:fontRef>
+          </p:style>
+          <p:txBody>
+            <a:bodyPr rtlCol="0" anchor="ctr"/>
+            <a:lstStyle/>
+            <a:p>
+              <a:pPr algn="ctr"/>
+              <a:endParaRPr lang="en-US"/>
+            </a:p>
+          </p:txBody>
+        </p:sp>
+        <p:sp>
+          <p:nvSpPr>
+            <p:cNvPr id="61" name="Ellipse 60">
+              <a:extLst>
+                <a:ext uri="{FF2B5EF4-FFF2-40B4-BE49-F238E27FC236}">
+                  <a16:creationId xmlns:a16="http://schemas.microsoft.com/office/drawing/2014/main" id="{B362D81C-1551-BE66-0197-BAFE0C50A02D}"/>
+                </a:ext>
+              </a:extLst>
+            </p:cNvPr>
+            <p:cNvSpPr/>
+            <p:nvPr/>
+          </p:nvSpPr>
+          <p:spPr>
+            <a:xfrm>
+              <a:off x="6014358" y="2923380"/>
+              <a:ext cx="603598" cy="623401"/>
+            </a:xfrm>
+            <a:prstGeom prst="ellipse">
+              <a:avLst/>
+            </a:prstGeom>
+            <a:solidFill>
+              <a:schemeClr val="accent3"/>
+            </a:solidFill>
+            <a:ln>
+              <a:noFill/>
+            </a:ln>
+          </p:spPr>
+          <p:style>
+            <a:lnRef idx="2">
+              <a:schemeClr val="accent1">
+                <a:shade val="15000"/>
+              </a:schemeClr>
+            </a:lnRef>
+            <a:fillRef idx="1">
+              <a:schemeClr val="accent1"/>
+            </a:fillRef>
+            <a:effectRef idx="0">
+              <a:schemeClr val="accent1"/>
+            </a:effectRef>
+            <a:fontRef idx="minor">
+              <a:schemeClr val="lt1"/>
+            </a:fontRef>
+          </p:style>
+          <p:txBody>
+            <a:bodyPr rtlCol="0" anchor="ctr"/>
+            <a:lstStyle/>
+            <a:p>
+              <a:pPr algn="ctr"/>
+              <a:endParaRPr lang="en-US"/>
+            </a:p>
+          </p:txBody>
+        </p:sp>
+        <p:sp>
+          <p:nvSpPr>
+            <p:cNvPr id="62" name="Ellipse 61">
+              <a:extLst>
+                <a:ext uri="{FF2B5EF4-FFF2-40B4-BE49-F238E27FC236}">
+                  <a16:creationId xmlns:a16="http://schemas.microsoft.com/office/drawing/2014/main" id="{5FD5D99C-ECB0-08AB-823E-062C69E59B1B}"/>
+                </a:ext>
+              </a:extLst>
+            </p:cNvPr>
+            <p:cNvSpPr/>
+            <p:nvPr/>
+          </p:nvSpPr>
+          <p:spPr>
+            <a:xfrm>
+              <a:off x="5563123" y="2846074"/>
+              <a:ext cx="764965" cy="736196"/>
+            </a:xfrm>
+            <a:prstGeom prst="ellipse">
+              <a:avLst/>
+            </a:prstGeom>
+            <a:solidFill>
+              <a:schemeClr val="accent3"/>
+            </a:solidFill>
+            <a:ln>
+              <a:noFill/>
+            </a:ln>
+          </p:spPr>
+          <p:style>
+            <a:lnRef idx="2">
+              <a:schemeClr val="accent1">
+                <a:shade val="15000"/>
+              </a:schemeClr>
+            </a:lnRef>
+            <a:fillRef idx="1">
+              <a:schemeClr val="accent1"/>
+            </a:fillRef>
+            <a:effectRef idx="0">
+              <a:schemeClr val="accent1"/>
+            </a:effectRef>
+            <a:fontRef idx="minor">
+              <a:schemeClr val="lt1"/>
+            </a:fontRef>
+          </p:style>
+          <p:txBody>
+            <a:bodyPr rtlCol="0" anchor="ctr"/>
+            <a:lstStyle/>
+            <a:p>
+              <a:pPr algn="ctr"/>
+              <a:endParaRPr lang="en-US"/>
+            </a:p>
+          </p:txBody>
+        </p:sp>
+        <p:sp>
+          <p:nvSpPr>
+            <p:cNvPr id="63" name="Bogen 62">
+              <a:extLst>
+                <a:ext uri="{FF2B5EF4-FFF2-40B4-BE49-F238E27FC236}">
+                  <a16:creationId xmlns:a16="http://schemas.microsoft.com/office/drawing/2014/main" id="{5CB721BB-447F-B247-9BF8-9EA4362452AD}"/>
+                </a:ext>
+              </a:extLst>
+            </p:cNvPr>
+            <p:cNvSpPr/>
+            <p:nvPr/>
+          </p:nvSpPr>
+          <p:spPr>
+            <a:xfrm>
+              <a:off x="6261287" y="3258692"/>
+              <a:ext cx="617656" cy="623401"/>
+            </a:xfrm>
+            <a:prstGeom prst="arc">
+              <a:avLst>
+                <a:gd name="adj1" fmla="val 18172811"/>
+                <a:gd name="adj2" fmla="val 1288239"/>
+              </a:avLst>
+            </a:prstGeom>
+            <a:ln w="76200">
+              <a:solidFill>
+                <a:schemeClr val="bg1"/>
+              </a:solidFill>
+            </a:ln>
+          </p:spPr>
+          <p:style>
+            <a:lnRef idx="2">
+              <a:schemeClr val="accent1"/>
+            </a:lnRef>
+            <a:fillRef idx="0">
+              <a:schemeClr val="accent1"/>
+            </a:fillRef>
+            <a:effectRef idx="1">
+              <a:schemeClr val="accent1"/>
+            </a:effectRef>
+            <a:fontRef idx="minor">
+              <a:schemeClr val="tx1"/>
+            </a:fontRef>
+          </p:style>
+          <p:txBody>
+            <a:bodyPr rtlCol="0" anchor="ctr"/>
+            <a:lstStyle/>
+            <a:p>
+              <a:pPr algn="ctr"/>
+              <a:endParaRPr lang="en-US"/>
+            </a:p>
+          </p:txBody>
+        </p:sp>
+        <p:sp>
+          <p:nvSpPr>
+            <p:cNvPr id="64" name="Bogen 63">
+              <a:extLst>
+                <a:ext uri="{FF2B5EF4-FFF2-40B4-BE49-F238E27FC236}">
+                  <a16:creationId xmlns:a16="http://schemas.microsoft.com/office/drawing/2014/main" id="{4AC2F295-E011-070A-7FE2-5C45FDAF5967}"/>
+                </a:ext>
+              </a:extLst>
+            </p:cNvPr>
+            <p:cNvSpPr/>
+            <p:nvPr/>
+          </p:nvSpPr>
+          <p:spPr>
+            <a:xfrm>
+              <a:off x="5866149" y="2850916"/>
+              <a:ext cx="772015" cy="772474"/>
+            </a:xfrm>
+            <a:prstGeom prst="arc">
+              <a:avLst>
+                <a:gd name="adj1" fmla="val 16200000"/>
+                <a:gd name="adj2" fmla="val 20501590"/>
+              </a:avLst>
+            </a:prstGeom>
+            <a:ln w="76200">
+              <a:solidFill>
+                <a:schemeClr val="bg1"/>
+              </a:solidFill>
+            </a:ln>
+          </p:spPr>
+          <p:style>
+            <a:lnRef idx="2">
+              <a:schemeClr val="accent1"/>
+            </a:lnRef>
+            <a:fillRef idx="0">
+              <a:schemeClr val="accent1"/>
+            </a:fillRef>
+            <a:effectRef idx="1">
+              <a:schemeClr val="accent1"/>
+            </a:effectRef>
+            <a:fontRef idx="minor">
+              <a:schemeClr val="tx1"/>
+            </a:fontRef>
+          </p:style>
+          <p:txBody>
+            <a:bodyPr rtlCol="0" anchor="ctr"/>
+            <a:lstStyle/>
+            <a:p>
+              <a:pPr algn="ctr"/>
+              <a:endParaRPr lang="en-US"/>
+            </a:p>
+          </p:txBody>
+        </p:sp>
+        <p:sp>
+          <p:nvSpPr>
+            <p:cNvPr id="65" name="Bogen 64">
+              <a:extLst>
+                <a:ext uri="{FF2B5EF4-FFF2-40B4-BE49-F238E27FC236}">
+                  <a16:creationId xmlns:a16="http://schemas.microsoft.com/office/drawing/2014/main" id="{A7AB8DF7-09B4-D80B-B8F1-4328BB08067C}"/>
+                </a:ext>
+              </a:extLst>
+            </p:cNvPr>
+            <p:cNvSpPr/>
+            <p:nvPr/>
+          </p:nvSpPr>
+          <p:spPr>
+            <a:xfrm>
+              <a:off x="5252105" y="3210494"/>
+              <a:ext cx="696339" cy="736196"/>
+            </a:xfrm>
+            <a:prstGeom prst="arc">
+              <a:avLst>
+                <a:gd name="adj1" fmla="val 16200000"/>
+                <a:gd name="adj2" fmla="val 20595110"/>
+              </a:avLst>
+            </a:prstGeom>
+            <a:ln w="76200">
+              <a:solidFill>
+                <a:schemeClr val="bg1"/>
+              </a:solidFill>
+            </a:ln>
+          </p:spPr>
+          <p:style>
+            <a:lnRef idx="2">
+              <a:schemeClr val="accent1"/>
+            </a:lnRef>
+            <a:fillRef idx="0">
+              <a:schemeClr val="accent1"/>
+            </a:fillRef>
+            <a:effectRef idx="1">
+              <a:schemeClr val="accent1"/>
+            </a:effectRef>
+            <a:fontRef idx="minor">
+              <a:schemeClr val="tx1"/>
+            </a:fontRef>
+          </p:style>
+          <p:txBody>
+            <a:bodyPr rtlCol="0" anchor="ctr"/>
+            <a:lstStyle/>
+            <a:p>
+              <a:pPr algn="ctr"/>
+              <a:endParaRPr lang="en-US"/>
+            </a:p>
+          </p:txBody>
+        </p:sp>
+      </p:grpSp>
+    </p:spTree>
+    <p:extLst>
+      <p:ext uri="{BB962C8B-B14F-4D97-AF65-F5344CB8AC3E}">
+        <p14:creationId xmlns:p14="http://schemas.microsoft.com/office/powerpoint/2010/main" val="353547463"/>
+      </p:ext>
+    </p:extLst>
+  </p:cSld>
+  <p:clrMapOvr>
+    <a:masterClrMapping/>
+  </p:clrMapOvr>
+</p:sld>
+</file>
+
+<file path=ppt/slides/slide7.xml><?xml version="1.0" encoding="utf-8"?>
 <p:sld xmlns:a="http://schemas.openxmlformats.org/drawingml/2006/main" xmlns:r="http://schemas.openxmlformats.org/officeDocument/2006/relationships" xmlns:p="http://schemas.openxmlformats.org/presentationml/2006/main">
   <p:cSld>
     <p:spTree>
@@ -9267,7 +10402,7 @@
 </p:sld>
 </file>
 
-<file path=ppt/slides/slide7.xml><?xml version="1.0" encoding="utf-8"?>
+<file path=ppt/slides/slide8.xml><?xml version="1.0" encoding="utf-8"?>
 <p:sld xmlns:a="http://schemas.openxmlformats.org/drawingml/2006/main" xmlns:r="http://schemas.openxmlformats.org/officeDocument/2006/relationships" xmlns:p="http://schemas.openxmlformats.org/presentationml/2006/main">
   <p:cSld>
     <p:spTree>
@@ -10387,7 +11522,7 @@
 </p:sld>
 </file>
 
-<file path=ppt/slides/slide8.xml><?xml version="1.0" encoding="utf-8"?>
+<file path=ppt/slides/slide9.xml><?xml version="1.0" encoding="utf-8"?>
 <p:sld xmlns:a="http://schemas.openxmlformats.org/drawingml/2006/main" xmlns:r="http://schemas.openxmlformats.org/officeDocument/2006/relationships" xmlns:p="http://schemas.openxmlformats.org/presentationml/2006/main">
   <p:cSld>
     <p:spTree>
@@ -10676,129 +11811,6 @@
     <p:extLst>
       <p:ext uri="{BB962C8B-B14F-4D97-AF65-F5344CB8AC3E}">
         <p14:creationId xmlns:p14="http://schemas.microsoft.com/office/powerpoint/2010/main" val="2374902956"/>
-      </p:ext>
-    </p:extLst>
-  </p:cSld>
-  <p:clrMapOvr>
-    <a:masterClrMapping/>
-  </p:clrMapOvr>
-</p:sld>
-</file>
-
-<file path=ppt/slides/slide9.xml><?xml version="1.0" encoding="utf-8"?>
-<p:sld xmlns:a="http://schemas.openxmlformats.org/drawingml/2006/main" xmlns:r="http://schemas.openxmlformats.org/officeDocument/2006/relationships" xmlns:p="http://schemas.openxmlformats.org/presentationml/2006/main">
-  <p:cSld>
-    <p:spTree>
-      <p:nvGrpSpPr>
-        <p:cNvPr id="1" name=""/>
-        <p:cNvGrpSpPr/>
-        <p:nvPr/>
-      </p:nvGrpSpPr>
-      <p:grpSpPr>
-        <a:xfrm>
-          <a:off x="0" y="0"/>
-          <a:ext cx="0" cy="0"/>
-          <a:chOff x="0" y="0"/>
-          <a:chExt cx="0" cy="0"/>
-        </a:xfrm>
-      </p:grpSpPr>
-      <p:grpSp>
-        <p:nvGrpSpPr>
-          <p:cNvPr id="15" name="Gruppieren 14">
-            <a:extLst>
-              <a:ext uri="{FF2B5EF4-FFF2-40B4-BE49-F238E27FC236}">
-                <a16:creationId xmlns:a16="http://schemas.microsoft.com/office/drawing/2014/main" id="{B5C84902-7ECC-508E-0880-0BCFFE91C348}"/>
-              </a:ext>
-            </a:extLst>
-          </p:cNvPr>
-          <p:cNvGrpSpPr/>
-          <p:nvPr/>
-        </p:nvGrpSpPr>
-        <p:grpSpPr>
-          <a:xfrm>
-            <a:off x="3178120" y="0"/>
-            <a:ext cx="6231825" cy="6858000"/>
-            <a:chOff x="3178120" y="0"/>
-            <a:chExt cx="6231825" cy="6858000"/>
-          </a:xfrm>
-        </p:grpSpPr>
-        <p:pic>
-          <p:nvPicPr>
-            <p:cNvPr id="7" name="Grafik 6">
-              <a:extLst>
-                <a:ext uri="{FF2B5EF4-FFF2-40B4-BE49-F238E27FC236}">
-                  <a16:creationId xmlns:a16="http://schemas.microsoft.com/office/drawing/2014/main" id="{70EF13CE-765F-E3DB-F344-6594D5828876}"/>
-                </a:ext>
-              </a:extLst>
-            </p:cNvPr>
-            <p:cNvPicPr>
-              <a:picLocks noChangeAspect="1"/>
-            </p:cNvPicPr>
-            <p:nvPr/>
-          </p:nvPicPr>
-          <p:blipFill>
-            <a:blip r:embed="rId2">
-              <a:extLst>
-                <a:ext uri="{28A0092B-C50C-407E-A947-70E740481C1C}">
-                  <a14:useLocalDpi xmlns:a14="http://schemas.microsoft.com/office/drawing/2010/main" val="0"/>
-                </a:ext>
-              </a:extLst>
-            </a:blip>
-            <a:stretch>
-              <a:fillRect/>
-            </a:stretch>
-          </p:blipFill>
-          <p:spPr>
-            <a:xfrm>
-              <a:off x="3178120" y="0"/>
-              <a:ext cx="3116346" cy="6858000"/>
-            </a:xfrm>
-            <a:prstGeom prst="rect">
-              <a:avLst/>
-            </a:prstGeom>
-          </p:spPr>
-        </p:pic>
-        <p:pic>
-          <p:nvPicPr>
-            <p:cNvPr id="14" name="Grafik 13">
-              <a:extLst>
-                <a:ext uri="{FF2B5EF4-FFF2-40B4-BE49-F238E27FC236}">
-                  <a16:creationId xmlns:a16="http://schemas.microsoft.com/office/drawing/2014/main" id="{299F9A69-8AA8-ADC3-BA81-310A9B5DEB46}"/>
-                </a:ext>
-              </a:extLst>
-            </p:cNvPr>
-            <p:cNvPicPr>
-              <a:picLocks noChangeAspect="1"/>
-            </p:cNvPicPr>
-            <p:nvPr/>
-          </p:nvPicPr>
-          <p:blipFill>
-            <a:blip r:embed="rId3">
-              <a:extLst>
-                <a:ext uri="{28A0092B-C50C-407E-A947-70E740481C1C}">
-                  <a14:useLocalDpi xmlns:a14="http://schemas.microsoft.com/office/drawing/2010/main" val="0"/>
-                </a:ext>
-              </a:extLst>
-            </a:blip>
-            <a:stretch>
-              <a:fillRect/>
-            </a:stretch>
-          </p:blipFill>
-          <p:spPr>
-            <a:xfrm>
-              <a:off x="6294465" y="0"/>
-              <a:ext cx="3115480" cy="6858000"/>
-            </a:xfrm>
-            <a:prstGeom prst="rect">
-              <a:avLst/>
-            </a:prstGeom>
-          </p:spPr>
-        </p:pic>
-      </p:grpSp>
-    </p:spTree>
-    <p:extLst>
-      <p:ext uri="{BB962C8B-B14F-4D97-AF65-F5344CB8AC3E}">
-        <p14:creationId xmlns:p14="http://schemas.microsoft.com/office/powerpoint/2010/main" val="3979895115"/>
       </p:ext>
     </p:extLst>
   </p:cSld>

</xml_diff>